<commit_message>
Kursens veckor: start vecka 38, frånskiljning in i vecka 40 och vecka 40 dag för dag
Översikten visar verkliga datum (kursvecka 1 = vecka 38, 14/09). Frånskiljning och
mätteknik öppnar vecka 40 på måndag; den gamla vecka 38-sidan pekar dit. Vecka 40
har en dagplan: lektion måndag, tisdag och fredag, hemstudier med tider och mål
däremellan, inlämning söndag 4 oktober. Mappar och länkar oförändrade.

Co-Authored-By: Claude Opus 5.5 <noreply@anthropic.com>
Claude-Session: https://claude.ai/code/session_015VmRVkw19eqfRrMXc1iXco
</commit_message>
<xml_diff>
--- a/sjoskolan/vecka-38/aktuell/v38_01_Franskiljning_och_matteknik_elev.pptx
+++ b/sjoskolan/vecka-38/aktuell/v38_01_Franskiljning_och_matteknik_elev.pptx
@@ -3549,7 +3549,7 @@
                 <a:ea typeface="Calibri"/>
                 <a:cs typeface="Calibri"/>
               </a:rPr>
-              <a:t>Kursvecka 2 · vecka 38 · 14–18 september 2026</a:t>
+              <a:t>Kursvecka 3 · vecka 40 · måndag 28 september 2026</a:t>
             </a:r>
           </a:p>
           <a:p xmlns:a="http://schemas.openxmlformats.org/drawingml/2006/main">
@@ -4013,7 +4013,7 @@
                 <a:ea typeface="Calibri"/>
                 <a:cs typeface="Calibri"/>
               </a:rPr>
-              <a:t>Kursvecka 2 · v. 38  ·  10 / 19</a:t>
+              <a:t>Kursvecka 3 · v. 40  ·  10 / 19</a:t>
             </a:r>
           </a:p>
         </p:txBody>
@@ -5456,7 +5456,7 @@
                 <a:ea typeface="Calibri"/>
                 <a:cs typeface="Calibri"/>
               </a:rPr>
-              <a:t>Kursvecka 2 · v. 38  ·  11 / 19</a:t>
+              <a:t>Kursvecka 3 · v. 40  ·  11 / 19</a:t>
             </a:r>
           </a:p>
         </p:txBody>
@@ -6320,7 +6320,7 @@
                 <a:ea typeface="Calibri"/>
                 <a:cs typeface="Calibri"/>
               </a:rPr>
-              <a:t>Kursvecka 2 · v. 38  ·  12 / 19</a:t>
+              <a:t>Kursvecka 3 · v. 40  ·  12 / 19</a:t>
             </a:r>
           </a:p>
         </p:txBody>
@@ -6761,7 +6761,7 @@
                 <a:ea typeface="Calibri"/>
                 <a:cs typeface="Calibri"/>
               </a:rPr>
-              <a:t>Kursvecka 2 · v. 38  ·  13 / 19</a:t>
+              <a:t>Kursvecka 3 · v. 40  ·  13 / 19</a:t>
             </a:r>
           </a:p>
         </p:txBody>
@@ -7202,7 +7202,7 @@
                 <a:ea typeface="Calibri"/>
                 <a:cs typeface="Calibri"/>
               </a:rPr>
-              <a:t>Kursvecka 2 · v. 38  ·  14 / 19</a:t>
+              <a:t>Kursvecka 3 · v. 40  ·  14 / 19</a:t>
             </a:r>
           </a:p>
         </p:txBody>
@@ -7643,7 +7643,7 @@
                 <a:ea typeface="Calibri"/>
                 <a:cs typeface="Calibri"/>
               </a:rPr>
-              <a:t>Kursvecka 2 · v. 38  ·  15 / 19</a:t>
+              <a:t>Kursvecka 3 · v. 40  ·  15 / 19</a:t>
             </a:r>
           </a:p>
         </p:txBody>
@@ -8084,7 +8084,7 @@
                 <a:ea typeface="Calibri"/>
                 <a:cs typeface="Calibri"/>
               </a:rPr>
-              <a:t>Kursvecka 2 · v. 38  ·  16 / 19</a:t>
+              <a:t>Kursvecka 3 · v. 40  ·  16 / 19</a:t>
             </a:r>
           </a:p>
         </p:txBody>
@@ -8525,7 +8525,7 @@
                 <a:ea typeface="Calibri"/>
                 <a:cs typeface="Calibri"/>
               </a:rPr>
-              <a:t>Kursvecka 2 · v. 38  ·  17 / 19</a:t>
+              <a:t>Kursvecka 3 · v. 40  ·  17 / 19</a:t>
             </a:r>
           </a:p>
         </p:txBody>
@@ -8966,7 +8966,7 @@
                 <a:ea typeface="Calibri"/>
                 <a:cs typeface="Calibri"/>
               </a:rPr>
-              <a:t>Kursvecka 2 · v. 38  ·  18 / 19</a:t>
+              <a:t>Kursvecka 3 · v. 40  ·  18 / 19</a:t>
             </a:r>
           </a:p>
         </p:txBody>
@@ -9407,7 +9407,7 @@
                 <a:ea typeface="Calibri"/>
                 <a:cs typeface="Calibri"/>
               </a:rPr>
-              <a:t>Kursvecka 2 · v. 38  ·  19 / 19</a:t>
+              <a:t>Kursvecka 3 · v. 40  ·  19 / 19</a:t>
             </a:r>
           </a:p>
         </p:txBody>
@@ -9848,7 +9848,7 @@
                 <a:ea typeface="Calibri"/>
                 <a:cs typeface="Calibri"/>
               </a:rPr>
-              <a:t>Kursvecka 2 · v. 38  ·  2 / 19</a:t>
+              <a:t>Kursvecka 3 · v. 40  ·  2 / 19</a:t>
             </a:r>
           </a:p>
         </p:txBody>
@@ -10289,7 +10289,7 @@
                 <a:ea typeface="Calibri"/>
                 <a:cs typeface="Calibri"/>
               </a:rPr>
-              <a:t>Kursvecka 2 · v. 38  ·  3 / 19</a:t>
+              <a:t>Kursvecka 3 · v. 40  ·  3 / 19</a:t>
             </a:r>
           </a:p>
         </p:txBody>
@@ -11304,7 +11304,7 @@
                 <a:ea typeface="Calibri"/>
                 <a:cs typeface="Calibri"/>
               </a:rPr>
-              <a:t>Kursvecka 2 · v. 38  ·  4 / 19</a:t>
+              <a:t>Kursvecka 3 · v. 40  ·  4 / 19</a:t>
             </a:r>
           </a:p>
         </p:txBody>
@@ -11772,7 +11772,7 @@
                 <a:ea typeface="Calibri"/>
                 <a:cs typeface="Calibri"/>
               </a:rPr>
-              <a:t>Kursvecka 2 · v. 38  ·  5 / 19</a:t>
+              <a:t>Kursvecka 3 · v. 40  ·  5 / 19</a:t>
             </a:r>
           </a:p>
         </p:txBody>
@@ -13005,7 +13005,7 @@
                 <a:ea typeface="Calibri"/>
                 <a:cs typeface="Calibri"/>
               </a:rPr>
-              <a:t>Kursvecka 2 · v. 38  ·  6 / 19</a:t>
+              <a:t>Kursvecka 3 · v. 40  ·  6 / 19</a:t>
             </a:r>
           </a:p>
         </p:txBody>
@@ -13969,7 +13969,7 @@
                 <a:ea typeface="Calibri"/>
                 <a:cs typeface="Calibri"/>
               </a:rPr>
-              <a:t>Kursvecka 2 · v. 38  ·  7 / 19</a:t>
+              <a:t>Kursvecka 3 · v. 40  ·  7 / 19</a:t>
             </a:r>
           </a:p>
         </p:txBody>
@@ -14437,7 +14437,7 @@
                 <a:ea typeface="Calibri"/>
                 <a:cs typeface="Calibri"/>
               </a:rPr>
-              <a:t>Kursvecka 2 · v. 38  ·  8 / 19</a:t>
+              <a:t>Kursvecka 3 · v. 40  ·  8 / 19</a:t>
             </a:r>
           </a:p>
         </p:txBody>
@@ -14878,7 +14878,7 @@
                 <a:ea typeface="Calibri"/>
                 <a:cs typeface="Calibri"/>
               </a:rPr>
-              <a:t>Kursvecka 2 · v. 38  ·  9 / 19</a:t>
+              <a:t>Kursvecka 3 · v. 40  ·  9 / 19</a:t>
             </a:r>
           </a:p>
         </p:txBody>

</xml_diff>

<commit_message>
Sjöskolan v38_01: kopplingsscheman och symboler som bilder
Bild 4, 6, 11 och 12 i Frånskiljning och mätteknik var byggda av lösa linjer
och rutor som ritades fel i PowerPoint. De ritas nu som bilder
(verktyg/ac/scheman_v38.py) med samma innehåll. PDF och bildspel byggda om.

Co-Authored-By: Claude Opus 5.5 <noreply@anthropic.com>
Claude-Session: https://claude.ai/code/session_011V9KjBb53XrDm23Dw58SH3
</commit_message>
<xml_diff>
--- a/sjoskolan/vecka-38/aktuell/v38_01_Franskiljning_och_matteknik_elev.pptx
+++ b/sjoskolan/vecka-38/aktuell/v38_01_Franskiljning_och_matteknik_elev.pptx
@@ -4130,10 +4130,10 @@
       </p:sp>
       <p:sp>
         <p:nvSpPr>
-          <p:cNvPr id="6" name="">
-            <a:extLst xmlns:a="http://schemas.openxmlformats.org/drawingml/2006/main">
-              <a:ext uri="{FF2B5EF4-FFF2-40B4-BE49-F238E27FC236}">
-                <a16:creationId xmlns:a16="http://schemas.microsoft.com/office/drawing/2014/main" id="{6FDE1DA3-14A8-4DA7-93B2-ADCFAE986862}"/>
+          <p:cNvPr id="33" name="">
+            <a:extLst xmlns:a="http://schemas.openxmlformats.org/drawingml/2006/main">
+              <a:ext uri="{FF2B5EF4-FFF2-40B4-BE49-F238E27FC236}">
+                <a16:creationId xmlns:a16="http://schemas.microsoft.com/office/drawing/2014/main" id="{82CDB470-4E69-4460-9C39-5D761FD1704D}"/>
               </a:ext>
             </a:extLst>
           </p:cNvPr>
@@ -4144,42 +4144,8 @@
         </p:nvSpPr>
         <p:spPr>
           <a:xfrm xmlns:a="http://schemas.openxmlformats.org/drawingml/2006/main">
-            <a:off x="927735" y="3196590"/>
-            <a:ext cx="640080" cy="640080"/>
-          </a:xfrm>
-          <a:prstGeom xmlns:a="http://schemas.openxmlformats.org/drawingml/2006/main" prst="ellipse">
-            <a:avLst/>
-          </a:prstGeom>
-          <a:noFill xmlns:a="http://schemas.openxmlformats.org/drawingml/2006/main"/>
-          <a:ln xmlns:a="http://schemas.openxmlformats.org/drawingml/2006/main" w="23813">
-            <a:solidFill>
-              <a:srgbClr val="075398"/>
-            </a:solidFill>
-          </a:ln>
-        </p:spPr>
-        <p:txBody xmlns:a="http://schemas.openxmlformats.org/drawingml/2006/main">
-          <a:bodyPr/>
-          <a:p/>
-        </p:txBody>
-      </p:sp>
-      <p:sp>
-        <p:nvSpPr>
-          <p:cNvPr id="7" name="">
-            <a:extLst xmlns:a="http://schemas.openxmlformats.org/drawingml/2006/main">
-              <a:ext uri="{FF2B5EF4-FFF2-40B4-BE49-F238E27FC236}">
-                <a16:creationId xmlns:a16="http://schemas.microsoft.com/office/drawing/2014/main" id="{D9FF64A7-DD78-4F98-8576-2FD10D4BB785}"/>
-              </a:ext>
-            </a:extLst>
-          </p:cNvPr>
-          <p:cNvSpPr>
-            <a:spLocks xmlns:a="http://schemas.openxmlformats.org/drawingml/2006/main" noGrp="1"/>
-          </p:cNvSpPr>
-          <p:nvPr/>
-        </p:nvSpPr>
-        <p:spPr>
-          <a:xfrm xmlns:a="http://schemas.openxmlformats.org/drawingml/2006/main">
-            <a:off x="1156335" y="3224022"/>
-            <a:ext cx="274320" cy="256032"/>
+            <a:off x="619125" y="5924550"/>
+            <a:ext cx="7858125" cy="190500"/>
           </a:xfrm>
           <a:prstGeom xmlns:a="http://schemas.openxmlformats.org/drawingml/2006/main" prst="rect">
             <a:avLst/>
@@ -4196,35 +4162,35 @@
           <a:lstStyle xmlns:a="http://schemas.openxmlformats.org/drawingml/2006/main"/>
           <a:p xmlns:a="http://schemas.openxmlformats.org/drawingml/2006/main">
             <a:pPr>
-              <a:defRPr sz="1656" b="0">
-                <a:solidFill>
-                  <a:srgbClr val="075398"/>
-                </a:solidFill>
-                <a:latin typeface="Calibri"/>
-                <a:ea typeface="Calibri"/>
-                <a:cs typeface="Calibri"/>
-              </a:defRPr>
-            </a:pPr>
-            <a:r>
-              <a:rPr sz="1656" b="0">
-                <a:solidFill>
-                  <a:srgbClr val="075398"/>
+              <a:defRPr sz="1050" b="0">
+                <a:solidFill>
+                  <a:srgbClr val="555555"/>
+                </a:solidFill>
+                <a:latin typeface="Calibri"/>
+                <a:ea typeface="Calibri"/>
+                <a:cs typeface="Calibri"/>
+              </a:defRPr>
+            </a:pPr>
+            <a:r>
+              <a:rPr sz="1050" b="0">
+                <a:solidFill>
+                  <a:srgbClr val="555555"/>
                 </a:solidFill>
                 <a:latin typeface="Calibri"/>
                 <a:ea typeface="Calibri"/>
                 <a:cs typeface="Calibri"/>
               </a:rPr>
-              <a:t>+</a:t>
-            </a:r>
-          </a:p>
-        </p:txBody>
-      </p:sp>
-      <p:sp>
-        <p:nvSpPr>
-          <p:cNvPr id="8" name="">
-            <a:extLst xmlns:a="http://schemas.openxmlformats.org/drawingml/2006/main">
-              <a:ext uri="{FF2B5EF4-FFF2-40B4-BE49-F238E27FC236}">
-                <a16:creationId xmlns:a16="http://schemas.microsoft.com/office/drawing/2014/main" id="{F01379B3-709F-4667-B0E0-89E964718E71}"/>
+              <a:t>Principskiss för undervisning. Ingen installationsritning.</a:t>
+            </a:r>
+          </a:p>
+        </p:txBody>
+      </p:sp>
+      <p:sp>
+        <p:nvSpPr>
+          <p:cNvPr id="34" name="">
+            <a:extLst xmlns:a="http://schemas.openxmlformats.org/drawingml/2006/main">
+              <a:ext uri="{FF2B5EF4-FFF2-40B4-BE49-F238E27FC236}">
+                <a16:creationId xmlns:a16="http://schemas.microsoft.com/office/drawing/2014/main" id="{8F80381D-5D39-4725-B45F-06EFE504E0FA}"/>
               </a:ext>
             </a:extLst>
           </p:cNvPr>
@@ -4235,8 +4201,8 @@
         </p:nvSpPr>
         <p:spPr>
           <a:xfrm xmlns:a="http://schemas.openxmlformats.org/drawingml/2006/main">
-            <a:off x="1156335" y="3553206"/>
-            <a:ext cx="274320" cy="274320"/>
+            <a:off x="6715125" y="6429375"/>
+            <a:ext cx="2190750" cy="285750"/>
           </a:xfrm>
           <a:prstGeom xmlns:a="http://schemas.openxmlformats.org/drawingml/2006/main" prst="rect">
             <a:avLst/>
@@ -4253,1214 +4219,53 @@
           <a:lstStyle xmlns:a="http://schemas.openxmlformats.org/drawingml/2006/main"/>
           <a:p xmlns:a="http://schemas.openxmlformats.org/drawingml/2006/main">
             <a:pPr>
-              <a:defRPr sz="1656" b="0">
-                <a:solidFill>
-                  <a:srgbClr val="075398"/>
-                </a:solidFill>
-                <a:latin typeface="Calibri"/>
-                <a:ea typeface="Calibri"/>
-                <a:cs typeface="Calibri"/>
-              </a:defRPr>
-            </a:pPr>
-            <a:r>
-              <a:rPr sz="1656" b="0">
-                <a:solidFill>
-                  <a:srgbClr val="075398"/>
+              <a:defRPr sz="1350" b="0">
+                <a:solidFill>
+                  <a:srgbClr val="FFFFFF"/>
+                </a:solidFill>
+                <a:latin typeface="Calibri"/>
+                <a:ea typeface="Calibri"/>
+                <a:cs typeface="Calibri"/>
+              </a:defRPr>
+            </a:pPr>
+            <a:r>
+              <a:rPr sz="1350" b="0">
+                <a:solidFill>
+                  <a:srgbClr val="FFFFFF"/>
                 </a:solidFill>
                 <a:latin typeface="Calibri"/>
                 <a:ea typeface="Calibri"/>
                 <a:cs typeface="Calibri"/>
               </a:rPr>
-              <a:t>−</a:t>
-            </a:r>
-          </a:p>
-        </p:txBody>
-      </p:sp>
-      <p:sp>
-        <p:nvSpPr>
-          <p:cNvPr id="9" name="">
-            <a:extLst xmlns:a="http://schemas.openxmlformats.org/drawingml/2006/main">
-              <a:ext uri="{FF2B5EF4-FFF2-40B4-BE49-F238E27FC236}">
-                <a16:creationId xmlns:a16="http://schemas.microsoft.com/office/drawing/2014/main" id="{A3D4008A-7E2D-4667-BBFE-DEEF82F4CA53}"/>
-              </a:ext>
-            </a:extLst>
-          </p:cNvPr>
-          <p:cNvSpPr>
-            <a:spLocks xmlns:a="http://schemas.openxmlformats.org/drawingml/2006/main" noGrp="1"/>
-          </p:cNvSpPr>
+              <a:t>Kursvecka 3 · v. 40  ·  11 / 19</a:t>
+            </a:r>
+          </a:p>
+        </p:txBody>
+      </p:sp>
+      <p:pic xmlns:a="http://schemas.openxmlformats.org/drawingml/2006/main" xmlns:r="http://schemas.openxmlformats.org/officeDocument/2006/relationships">
+        <p:nvPicPr>
+          <p:cNvPr id="36" name="schema-bild11" descr="12 V DC, amperemeter i serie, R = 1 kΩ, voltmeter parallellt över R."/>
+          <p:cNvPicPr>
+            <a:picLocks noChangeAspect="1"/>
+          </p:cNvPicPr>
           <p:nvPr/>
-        </p:nvSpPr>
-        <p:spPr>
-          <a:xfrm xmlns:a="http://schemas.openxmlformats.org/drawingml/2006/main">
-            <a:off x="470535" y="3973830"/>
-            <a:ext cx="1645920" cy="320040"/>
-          </a:xfrm>
-          <a:prstGeom xmlns:a="http://schemas.openxmlformats.org/drawingml/2006/main" prst="rect">
+        </p:nvPicPr>
+        <p:blipFill>
+          <a:blip r:embed="rId4"/>
+          <a:stretch>
+            <a:fillRect/>
+          </a:stretch>
+        </p:blipFill>
+        <p:spPr>
+          <a:xfrm>
+            <a:off x="457200" y="1600200"/>
+            <a:ext cx="8229600" cy="3474720"/>
+          </a:xfrm>
+          <a:prstGeom prst="rect">
             <a:avLst/>
           </a:prstGeom>
-          <a:noFill xmlns:a="http://schemas.openxmlformats.org/drawingml/2006/main"/>
-          <a:ln xmlns:a="http://schemas.openxmlformats.org/drawingml/2006/main" w="0">
-            <a:noFill/>
-          </a:ln>
-        </p:spPr>
-        <p:txBody>
-          <a:bodyPr xmlns:a="http://schemas.openxmlformats.org/drawingml/2006/main" lIns="0" tIns="0" rIns="0" bIns="0">
-            <a:noAutofit/>
-          </a:bodyPr>
-          <a:lstStyle xmlns:a="http://schemas.openxmlformats.org/drawingml/2006/main"/>
-          <a:p xmlns:a="http://schemas.openxmlformats.org/drawingml/2006/main">
-            <a:pPr>
-              <a:defRPr sz="1584" b="0">
-                <a:solidFill>
-                  <a:srgbClr val="075398"/>
-                </a:solidFill>
-                <a:latin typeface="Calibri"/>
-                <a:ea typeface="Calibri"/>
-                <a:cs typeface="Calibri"/>
-              </a:defRPr>
-            </a:pPr>
-            <a:r>
-              <a:rPr sz="1584" b="0">
-                <a:solidFill>
-                  <a:srgbClr val="075398"/>
-                </a:solidFill>
-                <a:latin typeface="Calibri"/>
-                <a:ea typeface="Calibri"/>
-                <a:cs typeface="Calibri"/>
-              </a:rPr>
-              <a:t>12 V DC</a:t>
-            </a:r>
-          </a:p>
-        </p:txBody>
-      </p:sp>
-      <p:sp>
-        <p:nvSpPr>
-          <p:cNvPr id="10" name="">
-            <a:extLst xmlns:a="http://schemas.openxmlformats.org/drawingml/2006/main">
-              <a:ext uri="{FF2B5EF4-FFF2-40B4-BE49-F238E27FC236}">
-                <a16:creationId xmlns:a16="http://schemas.microsoft.com/office/drawing/2014/main" id="{EC7FCFE5-DA1F-4030-8BF4-C94D54921FE1}"/>
-              </a:ext>
-            </a:extLst>
-          </p:cNvPr>
-          <p:cNvSpPr>
-            <a:spLocks xmlns:a="http://schemas.openxmlformats.org/drawingml/2006/main" noGrp="1"/>
-          </p:cNvSpPr>
-          <p:nvPr/>
-        </p:nvSpPr>
-        <p:spPr>
-          <a:xfrm xmlns:a="http://schemas.openxmlformats.org/drawingml/2006/main">
-            <a:off x="1247775" y="2327910"/>
-            <a:ext cx="953" cy="868680"/>
-          </a:xfrm>
-          <a:custGeom xmlns:a="http://schemas.openxmlformats.org/drawingml/2006/main">
-            <a:pathLst>
-              <a:path w="953" h="868680">
-                <a:moveTo>
-                  <a:pt x="0" y="0"/>
-                </a:moveTo>
-                <a:lnTo>
-                  <a:pt x="0" y="868680"/>
-                </a:lnTo>
-              </a:path>
-            </a:pathLst>
-          </a:custGeom>
-          <a:noFill xmlns:a="http://schemas.openxmlformats.org/drawingml/2006/main"/>
-          <a:ln xmlns:a="http://schemas.openxmlformats.org/drawingml/2006/main" w="27432">
-            <a:solidFill>
-              <a:srgbClr val="111111"/>
-            </a:solidFill>
-          </a:ln>
-        </p:spPr>
-        <p:txBody xmlns:a="http://schemas.openxmlformats.org/drawingml/2006/main">
-          <a:bodyPr/>
-          <a:p/>
-        </p:txBody>
-      </p:sp>
-      <p:sp>
-        <p:nvSpPr>
-          <p:cNvPr id="11" name="">
-            <a:extLst xmlns:a="http://schemas.openxmlformats.org/drawingml/2006/main">
-              <a:ext uri="{FF2B5EF4-FFF2-40B4-BE49-F238E27FC236}">
-                <a16:creationId xmlns:a16="http://schemas.microsoft.com/office/drawing/2014/main" id="{93247D36-B0B1-4D29-BE75-70C4A35BEB84}"/>
-              </a:ext>
-            </a:extLst>
-          </p:cNvPr>
-          <p:cNvSpPr>
-            <a:spLocks xmlns:a="http://schemas.openxmlformats.org/drawingml/2006/main" noGrp="1"/>
-          </p:cNvSpPr>
-          <p:nvPr/>
-        </p:nvSpPr>
-        <p:spPr>
-          <a:xfrm xmlns:a="http://schemas.openxmlformats.org/drawingml/2006/main">
-            <a:off x="1247775" y="3836670"/>
-            <a:ext cx="953" cy="868680"/>
-          </a:xfrm>
-          <a:custGeom xmlns:a="http://schemas.openxmlformats.org/drawingml/2006/main">
-            <a:pathLst>
-              <a:path w="953" h="868680">
-                <a:moveTo>
-                  <a:pt x="0" y="0"/>
-                </a:moveTo>
-                <a:lnTo>
-                  <a:pt x="0" y="868680"/>
-                </a:lnTo>
-              </a:path>
-            </a:pathLst>
-          </a:custGeom>
-          <a:noFill xmlns:a="http://schemas.openxmlformats.org/drawingml/2006/main"/>
-          <a:ln xmlns:a="http://schemas.openxmlformats.org/drawingml/2006/main" w="27432">
-            <a:solidFill>
-              <a:srgbClr val="111111"/>
-            </a:solidFill>
-          </a:ln>
-        </p:spPr>
-        <p:txBody xmlns:a="http://schemas.openxmlformats.org/drawingml/2006/main">
-          <a:bodyPr/>
-          <a:p/>
-        </p:txBody>
-      </p:sp>
-      <p:sp>
-        <p:nvSpPr>
-          <p:cNvPr id="12" name="">
-            <a:extLst xmlns:a="http://schemas.openxmlformats.org/drawingml/2006/main">
-              <a:ext uri="{FF2B5EF4-FFF2-40B4-BE49-F238E27FC236}">
-                <a16:creationId xmlns:a16="http://schemas.microsoft.com/office/drawing/2014/main" id="{F9143E30-DA50-4AB3-9BB2-7679EABE824B}"/>
-              </a:ext>
-            </a:extLst>
-          </p:cNvPr>
-          <p:cNvSpPr>
-            <a:spLocks xmlns:a="http://schemas.openxmlformats.org/drawingml/2006/main" noGrp="1"/>
-          </p:cNvSpPr>
-          <p:nvPr/>
-        </p:nvSpPr>
-        <p:spPr>
-          <a:xfrm xmlns:a="http://schemas.openxmlformats.org/drawingml/2006/main">
-            <a:off x="1247775" y="4705350"/>
-            <a:ext cx="5943600" cy="953"/>
-          </a:xfrm>
-          <a:custGeom xmlns:a="http://schemas.openxmlformats.org/drawingml/2006/main">
-            <a:pathLst>
-              <a:path w="5943600" h="953">
-                <a:moveTo>
-                  <a:pt x="0" y="0"/>
-                </a:moveTo>
-                <a:lnTo>
-                  <a:pt x="5943600" y="0"/>
-                </a:lnTo>
-              </a:path>
-            </a:pathLst>
-          </a:custGeom>
-          <a:noFill xmlns:a="http://schemas.openxmlformats.org/drawingml/2006/main"/>
-          <a:ln xmlns:a="http://schemas.openxmlformats.org/drawingml/2006/main" w="27432">
-            <a:solidFill>
-              <a:srgbClr val="111111"/>
-            </a:solidFill>
-          </a:ln>
-        </p:spPr>
-        <p:txBody xmlns:a="http://schemas.openxmlformats.org/drawingml/2006/main">
-          <a:bodyPr/>
-          <a:p/>
-        </p:txBody>
-      </p:sp>
-      <p:sp>
-        <p:nvSpPr>
-          <p:cNvPr id="13" name="">
-            <a:extLst xmlns:a="http://schemas.openxmlformats.org/drawingml/2006/main">
-              <a:ext uri="{FF2B5EF4-FFF2-40B4-BE49-F238E27FC236}">
-                <a16:creationId xmlns:a16="http://schemas.microsoft.com/office/drawing/2014/main" id="{24FDE94E-889D-460B-8964-9C339CC7C5B6}"/>
-              </a:ext>
-            </a:extLst>
-          </p:cNvPr>
-          <p:cNvSpPr>
-            <a:spLocks xmlns:a="http://schemas.openxmlformats.org/drawingml/2006/main" noGrp="1"/>
-          </p:cNvSpPr>
-          <p:nvPr/>
-        </p:nvSpPr>
-        <p:spPr>
-          <a:xfrm xmlns:a="http://schemas.openxmlformats.org/drawingml/2006/main">
-            <a:off x="7191375" y="2327910"/>
-            <a:ext cx="953" cy="2377440"/>
-          </a:xfrm>
-          <a:custGeom xmlns:a="http://schemas.openxmlformats.org/drawingml/2006/main">
-            <a:pathLst>
-              <a:path w="953" h="2377440">
-                <a:moveTo>
-                  <a:pt x="0" y="0"/>
-                </a:moveTo>
-                <a:lnTo>
-                  <a:pt x="0" y="2377440"/>
-                </a:lnTo>
-              </a:path>
-            </a:pathLst>
-          </a:custGeom>
-          <a:noFill xmlns:a="http://schemas.openxmlformats.org/drawingml/2006/main"/>
-          <a:ln xmlns:a="http://schemas.openxmlformats.org/drawingml/2006/main" w="27432">
-            <a:solidFill>
-              <a:srgbClr val="111111"/>
-            </a:solidFill>
-          </a:ln>
-        </p:spPr>
-        <p:txBody xmlns:a="http://schemas.openxmlformats.org/drawingml/2006/main">
-          <a:bodyPr/>
-          <a:p/>
-        </p:txBody>
-      </p:sp>
-      <p:sp>
-        <p:nvSpPr>
-          <p:cNvPr id="14" name="">
-            <a:extLst xmlns:a="http://schemas.openxmlformats.org/drawingml/2006/main">
-              <a:ext uri="{FF2B5EF4-FFF2-40B4-BE49-F238E27FC236}">
-                <a16:creationId xmlns:a16="http://schemas.microsoft.com/office/drawing/2014/main" id="{B94E4272-4255-4C40-B024-144750E2FB36}"/>
-              </a:ext>
-            </a:extLst>
-          </p:cNvPr>
-          <p:cNvSpPr>
-            <a:spLocks xmlns:a="http://schemas.openxmlformats.org/drawingml/2006/main" noGrp="1"/>
-          </p:cNvSpPr>
-          <p:nvPr/>
-        </p:nvSpPr>
-        <p:spPr>
-          <a:xfrm xmlns:a="http://schemas.openxmlformats.org/drawingml/2006/main">
-            <a:off x="1247775" y="2327910"/>
-            <a:ext cx="1600200" cy="953"/>
-          </a:xfrm>
-          <a:custGeom xmlns:a="http://schemas.openxmlformats.org/drawingml/2006/main">
-            <a:pathLst>
-              <a:path w="1600200" h="953">
-                <a:moveTo>
-                  <a:pt x="0" y="0"/>
-                </a:moveTo>
-                <a:lnTo>
-                  <a:pt x="1600200" y="0"/>
-                </a:lnTo>
-              </a:path>
-            </a:pathLst>
-          </a:custGeom>
-          <a:noFill xmlns:a="http://schemas.openxmlformats.org/drawingml/2006/main"/>
-          <a:ln xmlns:a="http://schemas.openxmlformats.org/drawingml/2006/main" w="27432">
-            <a:solidFill>
-              <a:srgbClr val="111111"/>
-            </a:solidFill>
-          </a:ln>
-        </p:spPr>
-        <p:txBody xmlns:a="http://schemas.openxmlformats.org/drawingml/2006/main">
-          <a:bodyPr/>
-          <a:p/>
-        </p:txBody>
-      </p:sp>
-      <p:sp>
-        <p:nvSpPr>
-          <p:cNvPr id="15" name="">
-            <a:extLst xmlns:a="http://schemas.openxmlformats.org/drawingml/2006/main">
-              <a:ext uri="{FF2B5EF4-FFF2-40B4-BE49-F238E27FC236}">
-                <a16:creationId xmlns:a16="http://schemas.microsoft.com/office/drawing/2014/main" id="{2778E319-43F4-49E2-B3D5-F790B344FE3E}"/>
-              </a:ext>
-            </a:extLst>
-          </p:cNvPr>
-          <p:cNvSpPr>
-            <a:spLocks xmlns:a="http://schemas.openxmlformats.org/drawingml/2006/main" noGrp="1"/>
-          </p:cNvSpPr>
-          <p:nvPr/>
-        </p:nvSpPr>
-        <p:spPr>
-          <a:xfrm xmlns:a="http://schemas.openxmlformats.org/drawingml/2006/main">
-            <a:off x="2893695" y="2053590"/>
-            <a:ext cx="548640" cy="548640"/>
-          </a:xfrm>
-          <a:prstGeom xmlns:a="http://schemas.openxmlformats.org/drawingml/2006/main" prst="ellipse">
-            <a:avLst/>
-          </a:prstGeom>
-          <a:noFill xmlns:a="http://schemas.openxmlformats.org/drawingml/2006/main"/>
-          <a:ln xmlns:a="http://schemas.openxmlformats.org/drawingml/2006/main" w="23813">
-            <a:solidFill>
-              <a:srgbClr val="075398"/>
-            </a:solidFill>
-          </a:ln>
-        </p:spPr>
-        <p:txBody xmlns:a="http://schemas.openxmlformats.org/drawingml/2006/main">
-          <a:bodyPr/>
-          <a:p/>
-        </p:txBody>
-      </p:sp>
-      <p:sp>
-        <p:nvSpPr>
-          <p:cNvPr id="16" name="">
-            <a:extLst xmlns:a="http://schemas.openxmlformats.org/drawingml/2006/main">
-              <a:ext uri="{FF2B5EF4-FFF2-40B4-BE49-F238E27FC236}">
-                <a16:creationId xmlns:a16="http://schemas.microsoft.com/office/drawing/2014/main" id="{99C2A873-D44E-47EE-93FD-B631BABF065E}"/>
-              </a:ext>
-            </a:extLst>
-          </p:cNvPr>
-          <p:cNvSpPr>
-            <a:spLocks xmlns:a="http://schemas.openxmlformats.org/drawingml/2006/main" noGrp="1"/>
-          </p:cNvSpPr>
-          <p:nvPr/>
-        </p:nvSpPr>
-        <p:spPr>
-          <a:xfrm xmlns:a="http://schemas.openxmlformats.org/drawingml/2006/main">
-            <a:off x="3094863" y="2181606"/>
-            <a:ext cx="320040" cy="329184"/>
-          </a:xfrm>
-          <a:prstGeom xmlns:a="http://schemas.openxmlformats.org/drawingml/2006/main" prst="rect">
-            <a:avLst/>
-          </a:prstGeom>
-          <a:noFill xmlns:a="http://schemas.openxmlformats.org/drawingml/2006/main"/>
-          <a:ln xmlns:a="http://schemas.openxmlformats.org/drawingml/2006/main" w="0">
-            <a:noFill/>
-          </a:ln>
-        </p:spPr>
-        <p:txBody>
-          <a:bodyPr xmlns:a="http://schemas.openxmlformats.org/drawingml/2006/main" lIns="0" tIns="0" rIns="0" bIns="0">
-            <a:noAutofit/>
-          </a:bodyPr>
-          <a:lstStyle xmlns:a="http://schemas.openxmlformats.org/drawingml/2006/main"/>
-          <a:p xmlns:a="http://schemas.openxmlformats.org/drawingml/2006/main">
-            <a:pPr>
-              <a:defRPr sz="1656" b="0">
-                <a:solidFill>
-                  <a:srgbClr val="075398"/>
-                </a:solidFill>
-                <a:latin typeface="Calibri"/>
-                <a:ea typeface="Calibri"/>
-                <a:cs typeface="Calibri"/>
-              </a:defRPr>
-            </a:pPr>
-            <a:r>
-              <a:rPr sz="1656" b="0">
-                <a:solidFill>
-                  <a:srgbClr val="075398"/>
-                </a:solidFill>
-                <a:latin typeface="Calibri"/>
-                <a:ea typeface="Calibri"/>
-                <a:cs typeface="Calibri"/>
-              </a:rPr>
-              <a:t>A</a:t>
-            </a:r>
-          </a:p>
-        </p:txBody>
-      </p:sp>
-      <p:sp>
-        <p:nvSpPr>
-          <p:cNvPr id="17" name="">
-            <a:extLst xmlns:a="http://schemas.openxmlformats.org/drawingml/2006/main">
-              <a:ext uri="{FF2B5EF4-FFF2-40B4-BE49-F238E27FC236}">
-                <a16:creationId xmlns:a16="http://schemas.microsoft.com/office/drawing/2014/main" id="{2696A988-84C9-4FEC-99EA-D2954E95EABC}"/>
-              </a:ext>
-            </a:extLst>
-          </p:cNvPr>
-          <p:cNvSpPr>
-            <a:spLocks xmlns:a="http://schemas.openxmlformats.org/drawingml/2006/main" noGrp="1"/>
-          </p:cNvSpPr>
-          <p:nvPr/>
-        </p:nvSpPr>
-        <p:spPr>
-          <a:xfrm xmlns:a="http://schemas.openxmlformats.org/drawingml/2006/main">
-            <a:off x="3442335" y="2327910"/>
-            <a:ext cx="1645920" cy="953"/>
-          </a:xfrm>
-          <a:custGeom xmlns:a="http://schemas.openxmlformats.org/drawingml/2006/main">
-            <a:pathLst>
-              <a:path w="1645920" h="953">
-                <a:moveTo>
-                  <a:pt x="0" y="0"/>
-                </a:moveTo>
-                <a:lnTo>
-                  <a:pt x="1645920" y="0"/>
-                </a:lnTo>
-              </a:path>
-            </a:pathLst>
-          </a:custGeom>
-          <a:noFill xmlns:a="http://schemas.openxmlformats.org/drawingml/2006/main"/>
-          <a:ln xmlns:a="http://schemas.openxmlformats.org/drawingml/2006/main" w="27432">
-            <a:solidFill>
-              <a:srgbClr val="111111"/>
-            </a:solidFill>
-          </a:ln>
-        </p:spPr>
-        <p:txBody xmlns:a="http://schemas.openxmlformats.org/drawingml/2006/main">
-          <a:bodyPr/>
-          <a:p/>
-        </p:txBody>
-      </p:sp>
-      <p:sp>
-        <p:nvSpPr>
-          <p:cNvPr id="18" name="">
-            <a:extLst xmlns:a="http://schemas.openxmlformats.org/drawingml/2006/main">
-              <a:ext uri="{FF2B5EF4-FFF2-40B4-BE49-F238E27FC236}">
-                <a16:creationId xmlns:a16="http://schemas.microsoft.com/office/drawing/2014/main" id="{17038B34-696A-46A1-A75C-C9C116555F13}"/>
-              </a:ext>
-            </a:extLst>
-          </p:cNvPr>
-          <p:cNvSpPr>
-            <a:spLocks xmlns:a="http://schemas.openxmlformats.org/drawingml/2006/main" noGrp="1"/>
-          </p:cNvSpPr>
-          <p:nvPr/>
-        </p:nvSpPr>
-        <p:spPr>
-          <a:xfrm xmlns:a="http://schemas.openxmlformats.org/drawingml/2006/main">
-            <a:off x="5088255" y="2327910"/>
-            <a:ext cx="164592" cy="953"/>
-          </a:xfrm>
-          <a:custGeom xmlns:a="http://schemas.openxmlformats.org/drawingml/2006/main">
-            <a:pathLst>
-              <a:path w="164592" h="953">
-                <a:moveTo>
-                  <a:pt x="0" y="0"/>
-                </a:moveTo>
-                <a:lnTo>
-                  <a:pt x="164592" y="0"/>
-                </a:lnTo>
-              </a:path>
-            </a:pathLst>
-          </a:custGeom>
-          <a:noFill xmlns:a="http://schemas.openxmlformats.org/drawingml/2006/main"/>
-          <a:ln xmlns:a="http://schemas.openxmlformats.org/drawingml/2006/main" w="27432">
-            <a:solidFill>
-              <a:srgbClr val="111111"/>
-            </a:solidFill>
-          </a:ln>
-        </p:spPr>
-        <p:txBody xmlns:a="http://schemas.openxmlformats.org/drawingml/2006/main">
-          <a:bodyPr/>
-          <a:p/>
-        </p:txBody>
-      </p:sp>
-      <p:sp>
-        <p:nvSpPr>
-          <p:cNvPr id="19" name="">
-            <a:extLst xmlns:a="http://schemas.openxmlformats.org/drawingml/2006/main">
-              <a:ext uri="{FF2B5EF4-FFF2-40B4-BE49-F238E27FC236}">
-                <a16:creationId xmlns:a16="http://schemas.microsoft.com/office/drawing/2014/main" id="{80A8F39C-7818-4162-8BDB-990823187CC5}"/>
-              </a:ext>
-            </a:extLst>
-          </p:cNvPr>
-          <p:cNvSpPr>
-            <a:spLocks xmlns:a="http://schemas.openxmlformats.org/drawingml/2006/main" noGrp="1"/>
-          </p:cNvSpPr>
-          <p:nvPr/>
-        </p:nvSpPr>
-        <p:spPr>
-          <a:xfrm xmlns:a="http://schemas.openxmlformats.org/drawingml/2006/main">
-            <a:off x="5252847" y="2199894"/>
-            <a:ext cx="585216" cy="256032"/>
-          </a:xfrm>
-          <a:prstGeom xmlns:a="http://schemas.openxmlformats.org/drawingml/2006/main" prst="rect">
-            <a:avLst/>
-          </a:prstGeom>
-          <a:noFill xmlns:a="http://schemas.openxmlformats.org/drawingml/2006/main"/>
-          <a:ln xmlns:a="http://schemas.openxmlformats.org/drawingml/2006/main" w="23813">
-            <a:solidFill>
-              <a:srgbClr val="111111"/>
-            </a:solidFill>
-          </a:ln>
-        </p:spPr>
-        <p:txBody xmlns:a="http://schemas.openxmlformats.org/drawingml/2006/main">
-          <a:bodyPr/>
-          <a:p/>
-        </p:txBody>
-      </p:sp>
-      <p:sp>
-        <p:nvSpPr>
-          <p:cNvPr id="20" name="">
-            <a:extLst xmlns:a="http://schemas.openxmlformats.org/drawingml/2006/main">
-              <a:ext uri="{FF2B5EF4-FFF2-40B4-BE49-F238E27FC236}">
-                <a16:creationId xmlns:a16="http://schemas.microsoft.com/office/drawing/2014/main" id="{D739ED5D-D292-4872-9C79-63F14D523DC5}"/>
-              </a:ext>
-            </a:extLst>
-          </p:cNvPr>
-          <p:cNvSpPr>
-            <a:spLocks xmlns:a="http://schemas.openxmlformats.org/drawingml/2006/main" noGrp="1"/>
-          </p:cNvSpPr>
-          <p:nvPr/>
-        </p:nvSpPr>
-        <p:spPr>
-          <a:xfrm xmlns:a="http://schemas.openxmlformats.org/drawingml/2006/main">
-            <a:off x="5838063" y="2327910"/>
-            <a:ext cx="164592" cy="953"/>
-          </a:xfrm>
-          <a:custGeom xmlns:a="http://schemas.openxmlformats.org/drawingml/2006/main">
-            <a:pathLst>
-              <a:path w="164592" h="953">
-                <a:moveTo>
-                  <a:pt x="0" y="0"/>
-                </a:moveTo>
-                <a:lnTo>
-                  <a:pt x="164592" y="0"/>
-                </a:lnTo>
-              </a:path>
-            </a:pathLst>
-          </a:custGeom>
-          <a:noFill xmlns:a="http://schemas.openxmlformats.org/drawingml/2006/main"/>
-          <a:ln xmlns:a="http://schemas.openxmlformats.org/drawingml/2006/main" w="27432">
-            <a:solidFill>
-              <a:srgbClr val="111111"/>
-            </a:solidFill>
-          </a:ln>
-        </p:spPr>
-        <p:txBody xmlns:a="http://schemas.openxmlformats.org/drawingml/2006/main">
-          <a:bodyPr/>
-          <a:p/>
-        </p:txBody>
-      </p:sp>
-      <p:sp>
-        <p:nvSpPr>
-          <p:cNvPr id="21" name="">
-            <a:extLst xmlns:a="http://schemas.openxmlformats.org/drawingml/2006/main">
-              <a:ext uri="{FF2B5EF4-FFF2-40B4-BE49-F238E27FC236}">
-                <a16:creationId xmlns:a16="http://schemas.microsoft.com/office/drawing/2014/main" id="{C9B188D5-5FAF-4ED2-BB71-8DB64D79DC53}"/>
-              </a:ext>
-            </a:extLst>
-          </p:cNvPr>
-          <p:cNvSpPr>
-            <a:spLocks xmlns:a="http://schemas.openxmlformats.org/drawingml/2006/main" noGrp="1"/>
-          </p:cNvSpPr>
-          <p:nvPr/>
-        </p:nvSpPr>
-        <p:spPr>
-          <a:xfrm xmlns:a="http://schemas.openxmlformats.org/drawingml/2006/main">
-            <a:off x="4996815" y="1824990"/>
-            <a:ext cx="1554480" cy="347472"/>
-          </a:xfrm>
-          <a:prstGeom xmlns:a="http://schemas.openxmlformats.org/drawingml/2006/main" prst="rect">
-            <a:avLst/>
-          </a:prstGeom>
-          <a:noFill xmlns:a="http://schemas.openxmlformats.org/drawingml/2006/main"/>
-          <a:ln xmlns:a="http://schemas.openxmlformats.org/drawingml/2006/main" w="0">
-            <a:noFill/>
-          </a:ln>
-        </p:spPr>
-        <p:txBody>
-          <a:bodyPr xmlns:a="http://schemas.openxmlformats.org/drawingml/2006/main" lIns="0" tIns="0" rIns="0" bIns="0">
-            <a:noAutofit/>
-          </a:bodyPr>
-          <a:lstStyle xmlns:a="http://schemas.openxmlformats.org/drawingml/2006/main"/>
-          <a:p xmlns:a="http://schemas.openxmlformats.org/drawingml/2006/main">
-            <a:pPr>
-              <a:defRPr sz="1584" b="0">
-                <a:solidFill>
-                  <a:srgbClr val="111111"/>
-                </a:solidFill>
-                <a:latin typeface="Calibri"/>
-                <a:ea typeface="Calibri"/>
-                <a:cs typeface="Calibri"/>
-              </a:defRPr>
-            </a:pPr>
-            <a:r>
-              <a:rPr sz="1584" b="0">
-                <a:solidFill>
-                  <a:srgbClr val="111111"/>
-                </a:solidFill>
-                <a:latin typeface="Calibri"/>
-                <a:ea typeface="Calibri"/>
-                <a:cs typeface="Calibri"/>
-              </a:rPr>
-              <a:t>R = 1 kΩ</a:t>
-            </a:r>
-          </a:p>
-        </p:txBody>
-      </p:sp>
-      <p:sp>
-        <p:nvSpPr>
-          <p:cNvPr id="22" name="">
-            <a:extLst xmlns:a="http://schemas.openxmlformats.org/drawingml/2006/main">
-              <a:ext uri="{FF2B5EF4-FFF2-40B4-BE49-F238E27FC236}">
-                <a16:creationId xmlns:a16="http://schemas.microsoft.com/office/drawing/2014/main" id="{5F45DE00-9B9E-4640-B7D9-C1B718F0D531}"/>
-              </a:ext>
-            </a:extLst>
-          </p:cNvPr>
-          <p:cNvSpPr>
-            <a:spLocks xmlns:a="http://schemas.openxmlformats.org/drawingml/2006/main" noGrp="1"/>
-          </p:cNvSpPr>
-          <p:nvPr/>
-        </p:nvSpPr>
-        <p:spPr>
-          <a:xfrm xmlns:a="http://schemas.openxmlformats.org/drawingml/2006/main">
-            <a:off x="6002655" y="2327910"/>
-            <a:ext cx="1188720" cy="953"/>
-          </a:xfrm>
-          <a:custGeom xmlns:a="http://schemas.openxmlformats.org/drawingml/2006/main">
-            <a:pathLst>
-              <a:path w="1188720" h="953">
-                <a:moveTo>
-                  <a:pt x="0" y="0"/>
-                </a:moveTo>
-                <a:lnTo>
-                  <a:pt x="1188720" y="0"/>
-                </a:lnTo>
-              </a:path>
-            </a:pathLst>
-          </a:custGeom>
-          <a:noFill xmlns:a="http://schemas.openxmlformats.org/drawingml/2006/main"/>
-          <a:ln xmlns:a="http://schemas.openxmlformats.org/drawingml/2006/main" w="27432">
-            <a:solidFill>
-              <a:srgbClr val="111111"/>
-            </a:solidFill>
-          </a:ln>
-        </p:spPr>
-        <p:txBody xmlns:a="http://schemas.openxmlformats.org/drawingml/2006/main">
-          <a:bodyPr/>
-          <a:p/>
-        </p:txBody>
-      </p:sp>
-      <p:sp>
-        <p:nvSpPr>
-          <p:cNvPr id="23" name="">
-            <a:extLst xmlns:a="http://schemas.openxmlformats.org/drawingml/2006/main">
-              <a:ext uri="{FF2B5EF4-FFF2-40B4-BE49-F238E27FC236}">
-                <a16:creationId xmlns:a16="http://schemas.microsoft.com/office/drawing/2014/main" id="{9FDDD919-921D-48F2-BA3D-95E7A19B7572}"/>
-              </a:ext>
-            </a:extLst>
-          </p:cNvPr>
-          <p:cNvSpPr>
-            <a:spLocks xmlns:a="http://schemas.openxmlformats.org/drawingml/2006/main" noGrp="1"/>
-          </p:cNvSpPr>
-          <p:nvPr/>
-        </p:nvSpPr>
-        <p:spPr>
-          <a:xfrm xmlns:a="http://schemas.openxmlformats.org/drawingml/2006/main">
-            <a:off x="4905375" y="2327910"/>
-            <a:ext cx="953" cy="1097280"/>
-          </a:xfrm>
-          <a:custGeom xmlns:a="http://schemas.openxmlformats.org/drawingml/2006/main">
-            <a:pathLst>
-              <a:path w="953" h="1097280">
-                <a:moveTo>
-                  <a:pt x="0" y="0"/>
-                </a:moveTo>
-                <a:lnTo>
-                  <a:pt x="0" y="1097280"/>
-                </a:lnTo>
-              </a:path>
-            </a:pathLst>
-          </a:custGeom>
-          <a:noFill xmlns:a="http://schemas.openxmlformats.org/drawingml/2006/main"/>
-          <a:ln xmlns:a="http://schemas.openxmlformats.org/drawingml/2006/main" w="27432">
-            <a:solidFill>
-              <a:srgbClr val="111111"/>
-            </a:solidFill>
-          </a:ln>
-        </p:spPr>
-        <p:txBody xmlns:a="http://schemas.openxmlformats.org/drawingml/2006/main">
-          <a:bodyPr/>
-          <a:p/>
-        </p:txBody>
-      </p:sp>
-      <p:sp>
-        <p:nvSpPr>
-          <p:cNvPr id="24" name="">
-            <a:extLst xmlns:a="http://schemas.openxmlformats.org/drawingml/2006/main">
-              <a:ext uri="{FF2B5EF4-FFF2-40B4-BE49-F238E27FC236}">
-                <a16:creationId xmlns:a16="http://schemas.microsoft.com/office/drawing/2014/main" id="{E68790BF-C402-4C0A-97CE-A9C3094232C8}"/>
-              </a:ext>
-            </a:extLst>
-          </p:cNvPr>
-          <p:cNvSpPr>
-            <a:spLocks xmlns:a="http://schemas.openxmlformats.org/drawingml/2006/main" noGrp="1"/>
-          </p:cNvSpPr>
-          <p:nvPr/>
-        </p:nvSpPr>
-        <p:spPr>
-          <a:xfrm xmlns:a="http://schemas.openxmlformats.org/drawingml/2006/main">
-            <a:off x="6322695" y="2327910"/>
-            <a:ext cx="953" cy="1097280"/>
-          </a:xfrm>
-          <a:custGeom xmlns:a="http://schemas.openxmlformats.org/drawingml/2006/main">
-            <a:pathLst>
-              <a:path w="953" h="1097280">
-                <a:moveTo>
-                  <a:pt x="0" y="0"/>
-                </a:moveTo>
-                <a:lnTo>
-                  <a:pt x="0" y="1097280"/>
-                </a:lnTo>
-              </a:path>
-            </a:pathLst>
-          </a:custGeom>
-          <a:noFill xmlns:a="http://schemas.openxmlformats.org/drawingml/2006/main"/>
-          <a:ln xmlns:a="http://schemas.openxmlformats.org/drawingml/2006/main" w="27432">
-            <a:solidFill>
-              <a:srgbClr val="111111"/>
-            </a:solidFill>
-          </a:ln>
-        </p:spPr>
-        <p:txBody xmlns:a="http://schemas.openxmlformats.org/drawingml/2006/main">
-          <a:bodyPr/>
-          <a:p/>
-        </p:txBody>
-      </p:sp>
-      <p:sp>
-        <p:nvSpPr>
-          <p:cNvPr id="25" name="">
-            <a:extLst xmlns:a="http://schemas.openxmlformats.org/drawingml/2006/main">
-              <a:ext uri="{FF2B5EF4-FFF2-40B4-BE49-F238E27FC236}">
-                <a16:creationId xmlns:a16="http://schemas.microsoft.com/office/drawing/2014/main" id="{5264AB8A-40A3-41F0-8A71-C8425940D903}"/>
-              </a:ext>
-            </a:extLst>
-          </p:cNvPr>
-          <p:cNvSpPr>
-            <a:spLocks xmlns:a="http://schemas.openxmlformats.org/drawingml/2006/main" noGrp="1"/>
-          </p:cNvSpPr>
-          <p:nvPr/>
-        </p:nvSpPr>
-        <p:spPr>
-          <a:xfrm xmlns:a="http://schemas.openxmlformats.org/drawingml/2006/main">
-            <a:off x="4905375" y="3425190"/>
-            <a:ext cx="438912" cy="953"/>
-          </a:xfrm>
-          <a:custGeom xmlns:a="http://schemas.openxmlformats.org/drawingml/2006/main">
-            <a:pathLst>
-              <a:path w="438912" h="953">
-                <a:moveTo>
-                  <a:pt x="0" y="0"/>
-                </a:moveTo>
-                <a:lnTo>
-                  <a:pt x="438912" y="0"/>
-                </a:lnTo>
-              </a:path>
-            </a:pathLst>
-          </a:custGeom>
-          <a:noFill xmlns:a="http://schemas.openxmlformats.org/drawingml/2006/main"/>
-          <a:ln xmlns:a="http://schemas.openxmlformats.org/drawingml/2006/main" w="27432">
-            <a:solidFill>
-              <a:srgbClr val="111111"/>
-            </a:solidFill>
-          </a:ln>
-        </p:spPr>
-        <p:txBody xmlns:a="http://schemas.openxmlformats.org/drawingml/2006/main">
-          <a:bodyPr/>
-          <a:p/>
-        </p:txBody>
-      </p:sp>
-      <p:sp>
-        <p:nvSpPr>
-          <p:cNvPr id="26" name="">
-            <a:extLst xmlns:a="http://schemas.openxmlformats.org/drawingml/2006/main">
-              <a:ext uri="{FF2B5EF4-FFF2-40B4-BE49-F238E27FC236}">
-                <a16:creationId xmlns:a16="http://schemas.microsoft.com/office/drawing/2014/main" id="{01B266A5-9AC7-4627-B643-E61268235D98}"/>
-              </a:ext>
-            </a:extLst>
-          </p:cNvPr>
-          <p:cNvSpPr>
-            <a:spLocks xmlns:a="http://schemas.openxmlformats.org/drawingml/2006/main" noGrp="1"/>
-          </p:cNvSpPr>
-          <p:nvPr/>
-        </p:nvSpPr>
-        <p:spPr>
-          <a:xfrm xmlns:a="http://schemas.openxmlformats.org/drawingml/2006/main">
-            <a:off x="5344287" y="3132582"/>
-            <a:ext cx="585216" cy="585216"/>
-          </a:xfrm>
-          <a:prstGeom xmlns:a="http://schemas.openxmlformats.org/drawingml/2006/main" prst="ellipse">
-            <a:avLst/>
-          </a:prstGeom>
-          <a:noFill xmlns:a="http://schemas.openxmlformats.org/drawingml/2006/main"/>
-          <a:ln xmlns:a="http://schemas.openxmlformats.org/drawingml/2006/main" w="23813">
-            <a:solidFill>
-              <a:srgbClr val="16846C"/>
-            </a:solidFill>
-          </a:ln>
-        </p:spPr>
-        <p:txBody xmlns:a="http://schemas.openxmlformats.org/drawingml/2006/main">
-          <a:bodyPr/>
-          <a:p/>
-        </p:txBody>
-      </p:sp>
-      <p:sp>
-        <p:nvSpPr>
-          <p:cNvPr id="27" name="">
-            <a:extLst xmlns:a="http://schemas.openxmlformats.org/drawingml/2006/main">
-              <a:ext uri="{FF2B5EF4-FFF2-40B4-BE49-F238E27FC236}">
-                <a16:creationId xmlns:a16="http://schemas.microsoft.com/office/drawing/2014/main" id="{E88C170C-4ABE-4F9D-92CB-BA835D8834B8}"/>
-              </a:ext>
-            </a:extLst>
-          </p:cNvPr>
-          <p:cNvSpPr>
-            <a:spLocks xmlns:a="http://schemas.openxmlformats.org/drawingml/2006/main" noGrp="1"/>
-          </p:cNvSpPr>
-          <p:nvPr/>
-        </p:nvSpPr>
-        <p:spPr>
-          <a:xfrm xmlns:a="http://schemas.openxmlformats.org/drawingml/2006/main">
-            <a:off x="5563743" y="3278886"/>
-            <a:ext cx="320040" cy="329184"/>
-          </a:xfrm>
-          <a:prstGeom xmlns:a="http://schemas.openxmlformats.org/drawingml/2006/main" prst="rect">
-            <a:avLst/>
-          </a:prstGeom>
-          <a:noFill xmlns:a="http://schemas.openxmlformats.org/drawingml/2006/main"/>
-          <a:ln xmlns:a="http://schemas.openxmlformats.org/drawingml/2006/main" w="0">
-            <a:noFill/>
-          </a:ln>
-        </p:spPr>
-        <p:txBody>
-          <a:bodyPr xmlns:a="http://schemas.openxmlformats.org/drawingml/2006/main" lIns="0" tIns="0" rIns="0" bIns="0">
-            <a:noAutofit/>
-          </a:bodyPr>
-          <a:lstStyle xmlns:a="http://schemas.openxmlformats.org/drawingml/2006/main"/>
-          <a:p xmlns:a="http://schemas.openxmlformats.org/drawingml/2006/main">
-            <a:pPr>
-              <a:defRPr sz="1656" b="0">
-                <a:solidFill>
-                  <a:srgbClr val="16846C"/>
-                </a:solidFill>
-                <a:latin typeface="Calibri"/>
-                <a:ea typeface="Calibri"/>
-                <a:cs typeface="Calibri"/>
-              </a:defRPr>
-            </a:pPr>
-            <a:r>
-              <a:rPr sz="1656" b="0">
-                <a:solidFill>
-                  <a:srgbClr val="16846C"/>
-                </a:solidFill>
-                <a:latin typeface="Calibri"/>
-                <a:ea typeface="Calibri"/>
-                <a:cs typeface="Calibri"/>
-              </a:rPr>
-              <a:t>V</a:t>
-            </a:r>
-          </a:p>
-        </p:txBody>
-      </p:sp>
-      <p:sp>
-        <p:nvSpPr>
-          <p:cNvPr id="28" name="">
-            <a:extLst xmlns:a="http://schemas.openxmlformats.org/drawingml/2006/main">
-              <a:ext uri="{FF2B5EF4-FFF2-40B4-BE49-F238E27FC236}">
-                <a16:creationId xmlns:a16="http://schemas.microsoft.com/office/drawing/2014/main" id="{B18D93B8-E6F6-498B-94C4-42369FFB564B}"/>
-              </a:ext>
-            </a:extLst>
-          </p:cNvPr>
-          <p:cNvSpPr>
-            <a:spLocks xmlns:a="http://schemas.openxmlformats.org/drawingml/2006/main" noGrp="1"/>
-          </p:cNvSpPr>
-          <p:nvPr/>
-        </p:nvSpPr>
-        <p:spPr>
-          <a:xfrm xmlns:a="http://schemas.openxmlformats.org/drawingml/2006/main">
-            <a:off x="5929503" y="3425190"/>
-            <a:ext cx="393192" cy="953"/>
-          </a:xfrm>
-          <a:custGeom xmlns:a="http://schemas.openxmlformats.org/drawingml/2006/main">
-            <a:pathLst>
-              <a:path w="393192" h="953">
-                <a:moveTo>
-                  <a:pt x="0" y="0"/>
-                </a:moveTo>
-                <a:lnTo>
-                  <a:pt x="393192" y="0"/>
-                </a:lnTo>
-              </a:path>
-            </a:pathLst>
-          </a:custGeom>
-          <a:noFill xmlns:a="http://schemas.openxmlformats.org/drawingml/2006/main"/>
-          <a:ln xmlns:a="http://schemas.openxmlformats.org/drawingml/2006/main" w="27432">
-            <a:solidFill>
-              <a:srgbClr val="111111"/>
-            </a:solidFill>
-          </a:ln>
-        </p:spPr>
-        <p:txBody xmlns:a="http://schemas.openxmlformats.org/drawingml/2006/main">
-          <a:bodyPr/>
-          <a:p/>
-        </p:txBody>
-      </p:sp>
-      <p:sp>
-        <p:nvSpPr>
-          <p:cNvPr id="29" name="">
-            <a:extLst xmlns:a="http://schemas.openxmlformats.org/drawingml/2006/main">
-              <a:ext uri="{FF2B5EF4-FFF2-40B4-BE49-F238E27FC236}">
-                <a16:creationId xmlns:a16="http://schemas.microsoft.com/office/drawing/2014/main" id="{8C977254-ECD2-4A88-9DFF-5B6BC4B12381}"/>
-              </a:ext>
-            </a:extLst>
-          </p:cNvPr>
-          <p:cNvSpPr>
-            <a:spLocks xmlns:a="http://schemas.openxmlformats.org/drawingml/2006/main" noGrp="1"/>
-          </p:cNvSpPr>
-          <p:nvPr/>
-        </p:nvSpPr>
-        <p:spPr>
-          <a:xfrm xmlns:a="http://schemas.openxmlformats.org/drawingml/2006/main">
-            <a:off x="4868799" y="2291334"/>
-            <a:ext cx="73152" cy="73152"/>
-          </a:xfrm>
-          <a:prstGeom xmlns:a="http://schemas.openxmlformats.org/drawingml/2006/main" prst="ellipse">
-            <a:avLst/>
-          </a:prstGeom>
-          <a:noFill xmlns:a="http://schemas.openxmlformats.org/drawingml/2006/main"/>
-          <a:ln xmlns:a="http://schemas.openxmlformats.org/drawingml/2006/main" w="23813">
-            <a:solidFill>
-              <a:srgbClr val="111111"/>
-            </a:solidFill>
-          </a:ln>
-        </p:spPr>
-        <p:txBody xmlns:a="http://schemas.openxmlformats.org/drawingml/2006/main">
-          <a:bodyPr/>
-          <a:p/>
-        </p:txBody>
-      </p:sp>
-      <p:sp>
-        <p:nvSpPr>
-          <p:cNvPr id="30" name="">
-            <a:extLst xmlns:a="http://schemas.openxmlformats.org/drawingml/2006/main">
-              <a:ext uri="{FF2B5EF4-FFF2-40B4-BE49-F238E27FC236}">
-                <a16:creationId xmlns:a16="http://schemas.microsoft.com/office/drawing/2014/main" id="{A491330C-7410-46EA-9C20-620D6F3008F3}"/>
-              </a:ext>
-            </a:extLst>
-          </p:cNvPr>
-          <p:cNvSpPr>
-            <a:spLocks xmlns:a="http://schemas.openxmlformats.org/drawingml/2006/main" noGrp="1"/>
-          </p:cNvSpPr>
-          <p:nvPr/>
-        </p:nvSpPr>
-        <p:spPr>
-          <a:xfrm xmlns:a="http://schemas.openxmlformats.org/drawingml/2006/main">
-            <a:off x="6286119" y="2291334"/>
-            <a:ext cx="73152" cy="73152"/>
-          </a:xfrm>
-          <a:prstGeom xmlns:a="http://schemas.openxmlformats.org/drawingml/2006/main" prst="ellipse">
-            <a:avLst/>
-          </a:prstGeom>
-          <a:noFill xmlns:a="http://schemas.openxmlformats.org/drawingml/2006/main"/>
-          <a:ln xmlns:a="http://schemas.openxmlformats.org/drawingml/2006/main" w="23813">
-            <a:solidFill>
-              <a:srgbClr val="111111"/>
-            </a:solidFill>
-          </a:ln>
-        </p:spPr>
-        <p:txBody xmlns:a="http://schemas.openxmlformats.org/drawingml/2006/main">
-          <a:bodyPr/>
-          <a:p/>
-        </p:txBody>
-      </p:sp>
-      <p:sp>
-        <p:nvSpPr>
-          <p:cNvPr id="31" name="">
-            <a:extLst xmlns:a="http://schemas.openxmlformats.org/drawingml/2006/main">
-              <a:ext uri="{FF2B5EF4-FFF2-40B4-BE49-F238E27FC236}">
-                <a16:creationId xmlns:a16="http://schemas.microsoft.com/office/drawing/2014/main" id="{3E8146E2-7C04-44FA-ADED-FA54E8E6D782}"/>
-              </a:ext>
-            </a:extLst>
-          </p:cNvPr>
-          <p:cNvSpPr>
-            <a:spLocks xmlns:a="http://schemas.openxmlformats.org/drawingml/2006/main" noGrp="1"/>
-          </p:cNvSpPr>
-          <p:nvPr/>
-        </p:nvSpPr>
-        <p:spPr>
-          <a:xfrm xmlns:a="http://schemas.openxmlformats.org/drawingml/2006/main">
-            <a:off x="2756535" y="2830830"/>
-            <a:ext cx="1645920" cy="320040"/>
-          </a:xfrm>
-          <a:prstGeom xmlns:a="http://schemas.openxmlformats.org/drawingml/2006/main" prst="rect">
-            <a:avLst/>
-          </a:prstGeom>
-          <a:noFill xmlns:a="http://schemas.openxmlformats.org/drawingml/2006/main"/>
-          <a:ln xmlns:a="http://schemas.openxmlformats.org/drawingml/2006/main" w="0">
-            <a:noFill/>
-          </a:ln>
-        </p:spPr>
-        <p:txBody>
-          <a:bodyPr xmlns:a="http://schemas.openxmlformats.org/drawingml/2006/main" lIns="0" tIns="0" rIns="0" bIns="0">
-            <a:noAutofit/>
-          </a:bodyPr>
-          <a:lstStyle xmlns:a="http://schemas.openxmlformats.org/drawingml/2006/main"/>
-          <a:p xmlns:a="http://schemas.openxmlformats.org/drawingml/2006/main">
-            <a:pPr>
-              <a:defRPr sz="1584" b="0">
-                <a:solidFill>
-                  <a:srgbClr val="075398"/>
-                </a:solidFill>
-                <a:latin typeface="Calibri"/>
-                <a:ea typeface="Calibri"/>
-                <a:cs typeface="Calibri"/>
-              </a:defRPr>
-            </a:pPr>
-            <a:r>
-              <a:rPr sz="1584" b="0">
-                <a:solidFill>
-                  <a:srgbClr val="075398"/>
-                </a:solidFill>
-                <a:latin typeface="Calibri"/>
-                <a:ea typeface="Calibri"/>
-                <a:cs typeface="Calibri"/>
-              </a:rPr>
-              <a:t>A i serie</a:t>
-            </a:r>
-          </a:p>
-        </p:txBody>
-      </p:sp>
-      <p:sp>
-        <p:nvSpPr>
-          <p:cNvPr id="32" name="">
-            <a:extLst xmlns:a="http://schemas.openxmlformats.org/drawingml/2006/main">
-              <a:ext uri="{FF2B5EF4-FFF2-40B4-BE49-F238E27FC236}">
-                <a16:creationId xmlns:a16="http://schemas.microsoft.com/office/drawing/2014/main" id="{3426838D-8ACF-43BF-AB8F-EEAD227AAB5E}"/>
-              </a:ext>
-            </a:extLst>
-          </p:cNvPr>
-          <p:cNvSpPr>
-            <a:spLocks xmlns:a="http://schemas.openxmlformats.org/drawingml/2006/main" noGrp="1"/>
-          </p:cNvSpPr>
-          <p:nvPr/>
-        </p:nvSpPr>
-        <p:spPr>
-          <a:xfrm xmlns:a="http://schemas.openxmlformats.org/drawingml/2006/main">
-            <a:off x="4905375" y="3973830"/>
-            <a:ext cx="2834640" cy="320040"/>
-          </a:xfrm>
-          <a:prstGeom xmlns:a="http://schemas.openxmlformats.org/drawingml/2006/main" prst="rect">
-            <a:avLst/>
-          </a:prstGeom>
-          <a:noFill xmlns:a="http://schemas.openxmlformats.org/drawingml/2006/main"/>
-          <a:ln xmlns:a="http://schemas.openxmlformats.org/drawingml/2006/main" w="0">
-            <a:noFill/>
-          </a:ln>
-        </p:spPr>
-        <p:txBody>
-          <a:bodyPr xmlns:a="http://schemas.openxmlformats.org/drawingml/2006/main" lIns="0" tIns="0" rIns="0" bIns="0">
-            <a:noAutofit/>
-          </a:bodyPr>
-          <a:lstStyle xmlns:a="http://schemas.openxmlformats.org/drawingml/2006/main"/>
-          <a:p xmlns:a="http://schemas.openxmlformats.org/drawingml/2006/main">
-            <a:pPr>
-              <a:defRPr sz="1584" b="0">
-                <a:solidFill>
-                  <a:srgbClr val="16846C"/>
-                </a:solidFill>
-                <a:latin typeface="Calibri"/>
-                <a:ea typeface="Calibri"/>
-                <a:cs typeface="Calibri"/>
-              </a:defRPr>
-            </a:pPr>
-            <a:r>
-              <a:rPr sz="1584" b="0">
-                <a:solidFill>
-                  <a:srgbClr val="16846C"/>
-                </a:solidFill>
-                <a:latin typeface="Calibri"/>
-                <a:ea typeface="Calibri"/>
-                <a:cs typeface="Calibri"/>
-              </a:rPr>
-              <a:t>V parallellt över R</a:t>
-            </a:r>
-          </a:p>
-        </p:txBody>
-      </p:sp>
-      <p:sp>
-        <p:nvSpPr>
-          <p:cNvPr id="33" name="">
-            <a:extLst xmlns:a="http://schemas.openxmlformats.org/drawingml/2006/main">
-              <a:ext uri="{FF2B5EF4-FFF2-40B4-BE49-F238E27FC236}">
-                <a16:creationId xmlns:a16="http://schemas.microsoft.com/office/drawing/2014/main" id="{82CDB470-4E69-4460-9C39-5D761FD1704D}"/>
-              </a:ext>
-            </a:extLst>
-          </p:cNvPr>
-          <p:cNvSpPr>
-            <a:spLocks xmlns:a="http://schemas.openxmlformats.org/drawingml/2006/main" noGrp="1"/>
-          </p:cNvSpPr>
-          <p:nvPr/>
-        </p:nvSpPr>
-        <p:spPr>
-          <a:xfrm xmlns:a="http://schemas.openxmlformats.org/drawingml/2006/main">
-            <a:off x="619125" y="5924550"/>
-            <a:ext cx="7858125" cy="190500"/>
-          </a:xfrm>
-          <a:prstGeom xmlns:a="http://schemas.openxmlformats.org/drawingml/2006/main" prst="rect">
-            <a:avLst/>
-          </a:prstGeom>
-          <a:noFill xmlns:a="http://schemas.openxmlformats.org/drawingml/2006/main"/>
-          <a:ln xmlns:a="http://schemas.openxmlformats.org/drawingml/2006/main" w="0">
-            <a:noFill/>
-          </a:ln>
-        </p:spPr>
-        <p:txBody>
-          <a:bodyPr xmlns:a="http://schemas.openxmlformats.org/drawingml/2006/main" lIns="0" tIns="0" rIns="0" bIns="0">
-            <a:noAutofit/>
-          </a:bodyPr>
-          <a:lstStyle xmlns:a="http://schemas.openxmlformats.org/drawingml/2006/main"/>
-          <a:p xmlns:a="http://schemas.openxmlformats.org/drawingml/2006/main">
-            <a:pPr>
-              <a:defRPr sz="1050" b="0">
-                <a:solidFill>
-                  <a:srgbClr val="555555"/>
-                </a:solidFill>
-                <a:latin typeface="Calibri"/>
-                <a:ea typeface="Calibri"/>
-                <a:cs typeface="Calibri"/>
-              </a:defRPr>
-            </a:pPr>
-            <a:r>
-              <a:rPr sz="1050" b="0">
-                <a:solidFill>
-                  <a:srgbClr val="555555"/>
-                </a:solidFill>
-                <a:latin typeface="Calibri"/>
-                <a:ea typeface="Calibri"/>
-                <a:cs typeface="Calibri"/>
-              </a:rPr>
-              <a:t>Principskiss för undervisning. Ingen installationsritning.</a:t>
-            </a:r>
-          </a:p>
-        </p:txBody>
-      </p:sp>
-      <p:sp>
-        <p:nvSpPr>
-          <p:cNvPr id="34" name="">
-            <a:extLst xmlns:a="http://schemas.openxmlformats.org/drawingml/2006/main">
-              <a:ext uri="{FF2B5EF4-FFF2-40B4-BE49-F238E27FC236}">
-                <a16:creationId xmlns:a16="http://schemas.microsoft.com/office/drawing/2014/main" id="{8F80381D-5D39-4725-B45F-06EFE504E0FA}"/>
-              </a:ext>
-            </a:extLst>
-          </p:cNvPr>
-          <p:cNvSpPr>
-            <a:spLocks xmlns:a="http://schemas.openxmlformats.org/drawingml/2006/main" noGrp="1"/>
-          </p:cNvSpPr>
-          <p:nvPr/>
-        </p:nvSpPr>
-        <p:spPr>
-          <a:xfrm xmlns:a="http://schemas.openxmlformats.org/drawingml/2006/main">
-            <a:off x="6715125" y="6429375"/>
-            <a:ext cx="2190750" cy="285750"/>
-          </a:xfrm>
-          <a:prstGeom xmlns:a="http://schemas.openxmlformats.org/drawingml/2006/main" prst="rect">
-            <a:avLst/>
-          </a:prstGeom>
-          <a:noFill xmlns:a="http://schemas.openxmlformats.org/drawingml/2006/main"/>
-          <a:ln xmlns:a="http://schemas.openxmlformats.org/drawingml/2006/main" w="0">
-            <a:noFill/>
-          </a:ln>
-        </p:spPr>
-        <p:txBody>
-          <a:bodyPr xmlns:a="http://schemas.openxmlformats.org/drawingml/2006/main" lIns="0" tIns="0" rIns="0" bIns="0">
-            <a:noAutofit/>
-          </a:bodyPr>
-          <a:lstStyle xmlns:a="http://schemas.openxmlformats.org/drawingml/2006/main"/>
-          <a:p xmlns:a="http://schemas.openxmlformats.org/drawingml/2006/main">
-            <a:pPr>
-              <a:defRPr sz="1350" b="0">
-                <a:solidFill>
-                  <a:srgbClr val="FFFFFF"/>
-                </a:solidFill>
-                <a:latin typeface="Calibri"/>
-                <a:ea typeface="Calibri"/>
-                <a:cs typeface="Calibri"/>
-              </a:defRPr>
-            </a:pPr>
-            <a:r>
-              <a:rPr sz="1350" b="0">
-                <a:solidFill>
-                  <a:srgbClr val="FFFFFF"/>
-                </a:solidFill>
-                <a:latin typeface="Calibri"/>
-                <a:ea typeface="Calibri"/>
-                <a:cs typeface="Calibri"/>
-              </a:rPr>
-              <a:t>Kursvecka 3 · v. 40  ·  11 / 19</a:t>
-            </a:r>
-          </a:p>
-        </p:txBody>
-      </p:sp>
+        </p:spPr>
+      </p:pic>
     </p:spTree>
     <p:extLst>
       <p:ext uri="{BB962C8B-B14F-4D97-AF65-F5344CB8AC3E}">
@@ -5573,10 +4378,10 @@
       </p:sp>
       <p:sp>
         <p:nvSpPr>
-          <p:cNvPr id="6" name="">
-            <a:extLst xmlns:a="http://schemas.openxmlformats.org/drawingml/2006/main">
-              <a:ext uri="{FF2B5EF4-FFF2-40B4-BE49-F238E27FC236}">
-                <a16:creationId xmlns:a16="http://schemas.microsoft.com/office/drawing/2014/main" id="{7DEEDCCC-8896-4BC1-A1C1-866047CEE773}"/>
+          <p:cNvPr id="20" name="">
+            <a:extLst xmlns:a="http://schemas.openxmlformats.org/drawingml/2006/main">
+              <a:ext uri="{FF2B5EF4-FFF2-40B4-BE49-F238E27FC236}">
+                <a16:creationId xmlns:a16="http://schemas.microsoft.com/office/drawing/2014/main" id="{D3DBDCED-6095-46F7-8CF4-50A02ABADBC5}"/>
               </a:ext>
             </a:extLst>
           </p:cNvPr>
@@ -5587,128 +4392,8 @@
         </p:nvSpPr>
         <p:spPr>
           <a:xfrm xmlns:a="http://schemas.openxmlformats.org/drawingml/2006/main">
-            <a:off x="3533775" y="2922270"/>
-            <a:ext cx="164592" cy="953"/>
-          </a:xfrm>
-          <a:custGeom xmlns:a="http://schemas.openxmlformats.org/drawingml/2006/main">
-            <a:pathLst>
-              <a:path w="164592" h="953">
-                <a:moveTo>
-                  <a:pt x="0" y="0"/>
-                </a:moveTo>
-                <a:lnTo>
-                  <a:pt x="164592" y="0"/>
-                </a:lnTo>
-              </a:path>
-            </a:pathLst>
-          </a:custGeom>
-          <a:noFill xmlns:a="http://schemas.openxmlformats.org/drawingml/2006/main"/>
-          <a:ln xmlns:a="http://schemas.openxmlformats.org/drawingml/2006/main" w="27432">
-            <a:solidFill>
-              <a:srgbClr val="111111"/>
-            </a:solidFill>
-          </a:ln>
-        </p:spPr>
-        <p:txBody xmlns:a="http://schemas.openxmlformats.org/drawingml/2006/main">
-          <a:bodyPr/>
-          <a:p/>
-        </p:txBody>
-      </p:sp>
-      <p:sp>
-        <p:nvSpPr>
-          <p:cNvPr id="7" name="">
-            <a:extLst xmlns:a="http://schemas.openxmlformats.org/drawingml/2006/main">
-              <a:ext uri="{FF2B5EF4-FFF2-40B4-BE49-F238E27FC236}">
-                <a16:creationId xmlns:a16="http://schemas.microsoft.com/office/drawing/2014/main" id="{52D75FF5-56B6-44AE-A253-E10CF020242D}"/>
-              </a:ext>
-            </a:extLst>
-          </p:cNvPr>
-          <p:cNvSpPr>
-            <a:spLocks xmlns:a="http://schemas.openxmlformats.org/drawingml/2006/main" noGrp="1"/>
-          </p:cNvSpPr>
-          <p:nvPr/>
-        </p:nvSpPr>
-        <p:spPr>
-          <a:xfrm xmlns:a="http://schemas.openxmlformats.org/drawingml/2006/main">
-            <a:off x="3698367" y="2794254"/>
-            <a:ext cx="585216" cy="256032"/>
-          </a:xfrm>
-          <a:prstGeom xmlns:a="http://schemas.openxmlformats.org/drawingml/2006/main" prst="rect">
-            <a:avLst/>
-          </a:prstGeom>
-          <a:noFill xmlns:a="http://schemas.openxmlformats.org/drawingml/2006/main"/>
-          <a:ln xmlns:a="http://schemas.openxmlformats.org/drawingml/2006/main" w="23813">
-            <a:solidFill>
-              <a:srgbClr val="111111"/>
-            </a:solidFill>
-          </a:ln>
-        </p:spPr>
-        <p:txBody xmlns:a="http://schemas.openxmlformats.org/drawingml/2006/main">
-          <a:bodyPr/>
-          <a:p/>
-        </p:txBody>
-      </p:sp>
-      <p:sp>
-        <p:nvSpPr>
-          <p:cNvPr id="8" name="">
-            <a:extLst xmlns:a="http://schemas.openxmlformats.org/drawingml/2006/main">
-              <a:ext uri="{FF2B5EF4-FFF2-40B4-BE49-F238E27FC236}">
-                <a16:creationId xmlns:a16="http://schemas.microsoft.com/office/drawing/2014/main" id="{8A6B2066-374F-4D6E-B4DF-106AEE780541}"/>
-              </a:ext>
-            </a:extLst>
-          </p:cNvPr>
-          <p:cNvSpPr>
-            <a:spLocks xmlns:a="http://schemas.openxmlformats.org/drawingml/2006/main" noGrp="1"/>
-          </p:cNvSpPr>
-          <p:nvPr/>
-        </p:nvSpPr>
-        <p:spPr>
-          <a:xfrm xmlns:a="http://schemas.openxmlformats.org/drawingml/2006/main">
-            <a:off x="4283583" y="2922270"/>
-            <a:ext cx="164592" cy="953"/>
-          </a:xfrm>
-          <a:custGeom xmlns:a="http://schemas.openxmlformats.org/drawingml/2006/main">
-            <a:pathLst>
-              <a:path w="164592" h="953">
-                <a:moveTo>
-                  <a:pt x="0" y="0"/>
-                </a:moveTo>
-                <a:lnTo>
-                  <a:pt x="164592" y="0"/>
-                </a:lnTo>
-              </a:path>
-            </a:pathLst>
-          </a:custGeom>
-          <a:noFill xmlns:a="http://schemas.openxmlformats.org/drawingml/2006/main"/>
-          <a:ln xmlns:a="http://schemas.openxmlformats.org/drawingml/2006/main" w="27432">
-            <a:solidFill>
-              <a:srgbClr val="111111"/>
-            </a:solidFill>
-          </a:ln>
-        </p:spPr>
-        <p:txBody xmlns:a="http://schemas.openxmlformats.org/drawingml/2006/main">
-          <a:bodyPr/>
-          <a:p/>
-        </p:txBody>
-      </p:sp>
-      <p:sp>
-        <p:nvSpPr>
-          <p:cNvPr id="9" name="">
-            <a:extLst xmlns:a="http://schemas.openxmlformats.org/drawingml/2006/main">
-              <a:ext uri="{FF2B5EF4-FFF2-40B4-BE49-F238E27FC236}">
-                <a16:creationId xmlns:a16="http://schemas.microsoft.com/office/drawing/2014/main" id="{B08F478B-DD71-42A1-979E-0D7885022A1D}"/>
-              </a:ext>
-            </a:extLst>
-          </p:cNvPr>
-          <p:cNvSpPr>
-            <a:spLocks xmlns:a="http://schemas.openxmlformats.org/drawingml/2006/main" noGrp="1"/>
-          </p:cNvSpPr>
-          <p:nvPr/>
-        </p:nvSpPr>
-        <p:spPr>
-          <a:xfrm xmlns:a="http://schemas.openxmlformats.org/drawingml/2006/main">
-            <a:off x="3442335" y="2419350"/>
-            <a:ext cx="1554480" cy="347472"/>
+            <a:off x="619125" y="5924550"/>
+            <a:ext cx="7858125" cy="190500"/>
           </a:xfrm>
           <a:prstGeom xmlns:a="http://schemas.openxmlformats.org/drawingml/2006/main" prst="rect">
             <a:avLst/>
@@ -5725,35 +4410,35 @@
           <a:lstStyle xmlns:a="http://schemas.openxmlformats.org/drawingml/2006/main"/>
           <a:p xmlns:a="http://schemas.openxmlformats.org/drawingml/2006/main">
             <a:pPr>
-              <a:defRPr sz="1584" b="0">
-                <a:solidFill>
-                  <a:srgbClr val="111111"/>
-                </a:solidFill>
-                <a:latin typeface="Calibri"/>
-                <a:ea typeface="Calibri"/>
-                <a:cs typeface="Calibri"/>
-              </a:defRPr>
-            </a:pPr>
-            <a:r>
-              <a:rPr sz="1584" b="0">
-                <a:solidFill>
-                  <a:srgbClr val="111111"/>
+              <a:defRPr sz="1050" b="0">
+                <a:solidFill>
+                  <a:srgbClr val="555555"/>
+                </a:solidFill>
+                <a:latin typeface="Calibri"/>
+                <a:ea typeface="Calibri"/>
+                <a:cs typeface="Calibri"/>
+              </a:defRPr>
+            </a:pPr>
+            <a:r>
+              <a:rPr sz="1050" b="0">
+                <a:solidFill>
+                  <a:srgbClr val="555555"/>
                 </a:solidFill>
                 <a:latin typeface="Calibri"/>
                 <a:ea typeface="Calibri"/>
                 <a:cs typeface="Calibri"/>
               </a:rPr>
-              <a:t>R = 1 kΩ</a:t>
-            </a:r>
-          </a:p>
-        </p:txBody>
-      </p:sp>
-      <p:sp>
-        <p:nvSpPr>
-          <p:cNvPr id="10" name="">
-            <a:extLst xmlns:a="http://schemas.openxmlformats.org/drawingml/2006/main">
-              <a:ext uri="{FF2B5EF4-FFF2-40B4-BE49-F238E27FC236}">
-                <a16:creationId xmlns:a16="http://schemas.microsoft.com/office/drawing/2014/main" id="{27D9CDB4-0B35-422C-9571-76F599D7A60D}"/>
+              <a:t>Principskiss för undervisning. Ingen installationsritning.</a:t>
+            </a:r>
+          </a:p>
+        </p:txBody>
+      </p:sp>
+      <p:sp>
+        <p:nvSpPr>
+          <p:cNvPr id="21" name="">
+            <a:extLst xmlns:a="http://schemas.openxmlformats.org/drawingml/2006/main">
+              <a:ext uri="{FF2B5EF4-FFF2-40B4-BE49-F238E27FC236}">
+                <a16:creationId xmlns:a16="http://schemas.microsoft.com/office/drawing/2014/main" id="{61FECE5A-B0A9-4754-A458-7AF808C684FC}"/>
               </a:ext>
             </a:extLst>
           </p:cNvPr>
@@ -5764,257 +4449,8 @@
         </p:nvSpPr>
         <p:spPr>
           <a:xfrm xmlns:a="http://schemas.openxmlformats.org/drawingml/2006/main">
-            <a:off x="3259455" y="2922270"/>
-            <a:ext cx="274320" cy="953"/>
-          </a:xfrm>
-          <a:custGeom xmlns:a="http://schemas.openxmlformats.org/drawingml/2006/main">
-            <a:pathLst>
-              <a:path w="274320" h="953">
-                <a:moveTo>
-                  <a:pt x="0" y="0"/>
-                </a:moveTo>
-                <a:lnTo>
-                  <a:pt x="274320" y="0"/>
-                </a:lnTo>
-              </a:path>
-            </a:pathLst>
-          </a:custGeom>
-          <a:noFill xmlns:a="http://schemas.openxmlformats.org/drawingml/2006/main"/>
-          <a:ln xmlns:a="http://schemas.openxmlformats.org/drawingml/2006/main" w="27432">
-            <a:solidFill>
-              <a:srgbClr val="111111"/>
-            </a:solidFill>
-          </a:ln>
-        </p:spPr>
-        <p:txBody xmlns:a="http://schemas.openxmlformats.org/drawingml/2006/main">
-          <a:bodyPr/>
-          <a:p/>
-        </p:txBody>
-      </p:sp>
-      <p:sp>
-        <p:nvSpPr>
-          <p:cNvPr id="11" name="">
-            <a:extLst xmlns:a="http://schemas.openxmlformats.org/drawingml/2006/main">
-              <a:ext uri="{FF2B5EF4-FFF2-40B4-BE49-F238E27FC236}">
-                <a16:creationId xmlns:a16="http://schemas.microsoft.com/office/drawing/2014/main" id="{E4320985-F7B0-4F64-9C9D-4210A0AAF741}"/>
-              </a:ext>
-            </a:extLst>
-          </p:cNvPr>
-          <p:cNvSpPr>
-            <a:spLocks xmlns:a="http://schemas.openxmlformats.org/drawingml/2006/main" noGrp="1"/>
-          </p:cNvSpPr>
-          <p:nvPr/>
-        </p:nvSpPr>
-        <p:spPr>
-          <a:xfrm xmlns:a="http://schemas.openxmlformats.org/drawingml/2006/main">
-            <a:off x="4448175" y="2922270"/>
-            <a:ext cx="548640" cy="953"/>
-          </a:xfrm>
-          <a:custGeom xmlns:a="http://schemas.openxmlformats.org/drawingml/2006/main">
-            <a:pathLst>
-              <a:path w="548640" h="953">
-                <a:moveTo>
-                  <a:pt x="0" y="0"/>
-                </a:moveTo>
-                <a:lnTo>
-                  <a:pt x="548640" y="0"/>
-                </a:lnTo>
-              </a:path>
-            </a:pathLst>
-          </a:custGeom>
-          <a:noFill xmlns:a="http://schemas.openxmlformats.org/drawingml/2006/main"/>
-          <a:ln xmlns:a="http://schemas.openxmlformats.org/drawingml/2006/main" w="27432">
-            <a:solidFill>
-              <a:srgbClr val="111111"/>
-            </a:solidFill>
-          </a:ln>
-        </p:spPr>
-        <p:txBody xmlns:a="http://schemas.openxmlformats.org/drawingml/2006/main">
-          <a:bodyPr/>
-          <a:p/>
-        </p:txBody>
-      </p:sp>
-      <p:sp>
-        <p:nvSpPr>
-          <p:cNvPr id="12" name="">
-            <a:extLst xmlns:a="http://schemas.openxmlformats.org/drawingml/2006/main">
-              <a:ext uri="{FF2B5EF4-FFF2-40B4-BE49-F238E27FC236}">
-                <a16:creationId xmlns:a16="http://schemas.microsoft.com/office/drawing/2014/main" id="{AB04DB40-1FAA-41F7-9AB5-523ED5EF874C}"/>
-              </a:ext>
-            </a:extLst>
-          </p:cNvPr>
-          <p:cNvSpPr>
-            <a:spLocks xmlns:a="http://schemas.openxmlformats.org/drawingml/2006/main" noGrp="1"/>
-          </p:cNvSpPr>
-          <p:nvPr/>
-        </p:nvSpPr>
-        <p:spPr>
-          <a:xfrm xmlns:a="http://schemas.openxmlformats.org/drawingml/2006/main">
-            <a:off x="3259455" y="2922270"/>
-            <a:ext cx="953" cy="1600200"/>
-          </a:xfrm>
-          <a:custGeom xmlns:a="http://schemas.openxmlformats.org/drawingml/2006/main">
-            <a:pathLst>
-              <a:path w="953" h="1600200">
-                <a:moveTo>
-                  <a:pt x="0" y="0"/>
-                </a:moveTo>
-                <a:lnTo>
-                  <a:pt x="0" y="1600200"/>
-                </a:lnTo>
-              </a:path>
-            </a:pathLst>
-          </a:custGeom>
-          <a:noFill xmlns:a="http://schemas.openxmlformats.org/drawingml/2006/main"/>
-          <a:ln xmlns:a="http://schemas.openxmlformats.org/drawingml/2006/main" w="27432">
-            <a:solidFill>
-              <a:srgbClr val="111111"/>
-            </a:solidFill>
-          </a:ln>
-        </p:spPr>
-        <p:txBody xmlns:a="http://schemas.openxmlformats.org/drawingml/2006/main">
-          <a:bodyPr/>
-          <a:p/>
-        </p:txBody>
-      </p:sp>
-      <p:sp>
-        <p:nvSpPr>
-          <p:cNvPr id="13" name="">
-            <a:extLst xmlns:a="http://schemas.openxmlformats.org/drawingml/2006/main">
-              <a:ext uri="{FF2B5EF4-FFF2-40B4-BE49-F238E27FC236}">
-                <a16:creationId xmlns:a16="http://schemas.microsoft.com/office/drawing/2014/main" id="{CD9E0ECB-D104-4429-83AF-D5BF63A5A58B}"/>
-              </a:ext>
-            </a:extLst>
-          </p:cNvPr>
-          <p:cNvSpPr>
-            <a:spLocks xmlns:a="http://schemas.openxmlformats.org/drawingml/2006/main" noGrp="1"/>
-          </p:cNvSpPr>
-          <p:nvPr/>
-        </p:nvSpPr>
-        <p:spPr>
-          <a:xfrm xmlns:a="http://schemas.openxmlformats.org/drawingml/2006/main">
-            <a:off x="4996815" y="2922270"/>
-            <a:ext cx="953" cy="1600200"/>
-          </a:xfrm>
-          <a:custGeom xmlns:a="http://schemas.openxmlformats.org/drawingml/2006/main">
-            <a:pathLst>
-              <a:path w="953" h="1600200">
-                <a:moveTo>
-                  <a:pt x="0" y="0"/>
-                </a:moveTo>
-                <a:lnTo>
-                  <a:pt x="0" y="1600200"/>
-                </a:lnTo>
-              </a:path>
-            </a:pathLst>
-          </a:custGeom>
-          <a:noFill xmlns:a="http://schemas.openxmlformats.org/drawingml/2006/main"/>
-          <a:ln xmlns:a="http://schemas.openxmlformats.org/drawingml/2006/main" w="27432">
-            <a:solidFill>
-              <a:srgbClr val="111111"/>
-            </a:solidFill>
-          </a:ln>
-        </p:spPr>
-        <p:txBody xmlns:a="http://schemas.openxmlformats.org/drawingml/2006/main">
-          <a:bodyPr/>
-          <a:p/>
-        </p:txBody>
-      </p:sp>
-      <p:sp>
-        <p:nvSpPr>
-          <p:cNvPr id="14" name="">
-            <a:extLst xmlns:a="http://schemas.openxmlformats.org/drawingml/2006/main">
-              <a:ext uri="{FF2B5EF4-FFF2-40B4-BE49-F238E27FC236}">
-                <a16:creationId xmlns:a16="http://schemas.microsoft.com/office/drawing/2014/main" id="{1F9CD7E6-24A8-45C3-A069-4635BB00C382}"/>
-              </a:ext>
-            </a:extLst>
-          </p:cNvPr>
-          <p:cNvSpPr>
-            <a:spLocks xmlns:a="http://schemas.openxmlformats.org/drawingml/2006/main" noGrp="1"/>
-          </p:cNvSpPr>
-          <p:nvPr/>
-        </p:nvSpPr>
-        <p:spPr>
-          <a:xfrm xmlns:a="http://schemas.openxmlformats.org/drawingml/2006/main">
-            <a:off x="3259455" y="4522470"/>
-            <a:ext cx="457200" cy="953"/>
-          </a:xfrm>
-          <a:custGeom xmlns:a="http://schemas.openxmlformats.org/drawingml/2006/main">
-            <a:pathLst>
-              <a:path w="457200" h="953">
-                <a:moveTo>
-                  <a:pt x="0" y="0"/>
-                </a:moveTo>
-                <a:lnTo>
-                  <a:pt x="457200" y="0"/>
-                </a:lnTo>
-              </a:path>
-            </a:pathLst>
-          </a:custGeom>
-          <a:noFill xmlns:a="http://schemas.openxmlformats.org/drawingml/2006/main"/>
-          <a:ln xmlns:a="http://schemas.openxmlformats.org/drawingml/2006/main" w="27432">
-            <a:solidFill>
-              <a:srgbClr val="111111"/>
-            </a:solidFill>
-          </a:ln>
-        </p:spPr>
-        <p:txBody xmlns:a="http://schemas.openxmlformats.org/drawingml/2006/main">
-          <a:bodyPr/>
-          <a:p/>
-        </p:txBody>
-      </p:sp>
-      <p:sp>
-        <p:nvSpPr>
-          <p:cNvPr id="15" name="">
-            <a:extLst xmlns:a="http://schemas.openxmlformats.org/drawingml/2006/main">
-              <a:ext uri="{FF2B5EF4-FFF2-40B4-BE49-F238E27FC236}">
-                <a16:creationId xmlns:a16="http://schemas.microsoft.com/office/drawing/2014/main" id="{564FB415-A8F4-4940-B7AA-1835723B6966}"/>
-              </a:ext>
-            </a:extLst>
-          </p:cNvPr>
-          <p:cNvSpPr>
-            <a:spLocks xmlns:a="http://schemas.openxmlformats.org/drawingml/2006/main" noGrp="1"/>
-          </p:cNvSpPr>
-          <p:nvPr/>
-        </p:nvSpPr>
-        <p:spPr>
-          <a:xfrm xmlns:a="http://schemas.openxmlformats.org/drawingml/2006/main">
-            <a:off x="3734943" y="4129278"/>
-            <a:ext cx="786384" cy="786384"/>
-          </a:xfrm>
-          <a:prstGeom xmlns:a="http://schemas.openxmlformats.org/drawingml/2006/main" prst="ellipse">
-            <a:avLst/>
-          </a:prstGeom>
-          <a:noFill xmlns:a="http://schemas.openxmlformats.org/drawingml/2006/main"/>
-          <a:ln xmlns:a="http://schemas.openxmlformats.org/drawingml/2006/main" w="23813">
-            <a:solidFill>
-              <a:srgbClr val="075398"/>
-            </a:solidFill>
-          </a:ln>
-        </p:spPr>
-        <p:txBody xmlns:a="http://schemas.openxmlformats.org/drawingml/2006/main">
-          <a:bodyPr/>
-          <a:p/>
-        </p:txBody>
-      </p:sp>
-      <p:sp>
-        <p:nvSpPr>
-          <p:cNvPr id="16" name="">
-            <a:extLst xmlns:a="http://schemas.openxmlformats.org/drawingml/2006/main">
-              <a:ext uri="{FF2B5EF4-FFF2-40B4-BE49-F238E27FC236}">
-                <a16:creationId xmlns:a16="http://schemas.microsoft.com/office/drawing/2014/main" id="{6F633006-66A1-4E8F-A47C-EA6E043F2495}"/>
-              </a:ext>
-            </a:extLst>
-          </p:cNvPr>
-          <p:cNvSpPr>
-            <a:spLocks xmlns:a="http://schemas.openxmlformats.org/drawingml/2006/main" noGrp="1"/>
-          </p:cNvSpPr>
-          <p:nvPr/>
-        </p:nvSpPr>
-        <p:spPr>
-          <a:xfrm xmlns:a="http://schemas.openxmlformats.org/drawingml/2006/main">
-            <a:off x="4054983" y="4376166"/>
-            <a:ext cx="320040" cy="329184"/>
+            <a:off x="6715125" y="6429375"/>
+            <a:ext cx="2190750" cy="285750"/>
           </a:xfrm>
           <a:prstGeom xmlns:a="http://schemas.openxmlformats.org/drawingml/2006/main" prst="rect">
             <a:avLst/>
@@ -6031,300 +4467,53 @@
           <a:lstStyle xmlns:a="http://schemas.openxmlformats.org/drawingml/2006/main"/>
           <a:p xmlns:a="http://schemas.openxmlformats.org/drawingml/2006/main">
             <a:pPr>
-              <a:defRPr sz="1656" b="0">
-                <a:solidFill>
-                  <a:srgbClr val="075398"/>
-                </a:solidFill>
-                <a:latin typeface="Calibri"/>
-                <a:ea typeface="Calibri"/>
-                <a:cs typeface="Calibri"/>
-              </a:defRPr>
-            </a:pPr>
-            <a:r>
-              <a:rPr sz="1656" b="0">
-                <a:solidFill>
-                  <a:srgbClr val="075398"/>
+              <a:defRPr sz="1350" b="0">
+                <a:solidFill>
+                  <a:srgbClr val="FFFFFF"/>
+                </a:solidFill>
+                <a:latin typeface="Calibri"/>
+                <a:ea typeface="Calibri"/>
+                <a:cs typeface="Calibri"/>
+              </a:defRPr>
+            </a:pPr>
+            <a:r>
+              <a:rPr sz="1350" b="0">
+                <a:solidFill>
+                  <a:srgbClr val="FFFFFF"/>
                 </a:solidFill>
                 <a:latin typeface="Calibri"/>
                 <a:ea typeface="Calibri"/>
                 <a:cs typeface="Calibri"/>
               </a:rPr>
-              <a:t>Ω</a:t>
-            </a:r>
-          </a:p>
-        </p:txBody>
-      </p:sp>
-      <p:sp>
-        <p:nvSpPr>
-          <p:cNvPr id="17" name="">
-            <a:extLst xmlns:a="http://schemas.openxmlformats.org/drawingml/2006/main">
-              <a:ext uri="{FF2B5EF4-FFF2-40B4-BE49-F238E27FC236}">
-                <a16:creationId xmlns:a16="http://schemas.microsoft.com/office/drawing/2014/main" id="{A5B0F6A4-56C1-4161-807C-2109ABF68174}"/>
-              </a:ext>
-            </a:extLst>
-          </p:cNvPr>
-          <p:cNvSpPr>
-            <a:spLocks xmlns:a="http://schemas.openxmlformats.org/drawingml/2006/main" noGrp="1"/>
-          </p:cNvSpPr>
+              <a:t>Kursvecka 3 · v. 40  ·  12 / 19</a:t>
+            </a:r>
+          </a:p>
+        </p:txBody>
+      </p:sp>
+      <p:pic xmlns:a="http://schemas.openxmlformats.org/drawingml/2006/main" xmlns:r="http://schemas.openxmlformats.org/officeDocument/2006/relationships">
+        <p:nvPicPr>
+          <p:cNvPr id="23" name="schema-bild12" descr="Avgränsat motstånd och ohmmeter i en sluten slinga, ingen matning."/>
+          <p:cNvPicPr>
+            <a:picLocks noChangeAspect="1"/>
+          </p:cNvPicPr>
           <p:nvPr/>
-        </p:nvSpPr>
-        <p:spPr>
-          <a:xfrm xmlns:a="http://schemas.openxmlformats.org/drawingml/2006/main">
-            <a:off x="4521327" y="4522470"/>
-            <a:ext cx="475488" cy="953"/>
-          </a:xfrm>
-          <a:custGeom xmlns:a="http://schemas.openxmlformats.org/drawingml/2006/main">
-            <a:pathLst>
-              <a:path w="475488" h="953">
-                <a:moveTo>
-                  <a:pt x="0" y="0"/>
-                </a:moveTo>
-                <a:lnTo>
-                  <a:pt x="475488" y="0"/>
-                </a:lnTo>
-              </a:path>
-            </a:pathLst>
-          </a:custGeom>
-          <a:noFill xmlns:a="http://schemas.openxmlformats.org/drawingml/2006/main"/>
-          <a:ln xmlns:a="http://schemas.openxmlformats.org/drawingml/2006/main" w="27432">
-            <a:solidFill>
-              <a:srgbClr val="111111"/>
-            </a:solidFill>
-          </a:ln>
-        </p:spPr>
-        <p:txBody xmlns:a="http://schemas.openxmlformats.org/drawingml/2006/main">
-          <a:bodyPr/>
-          <a:p/>
-        </p:txBody>
-      </p:sp>
-      <p:sp>
-        <p:nvSpPr>
-          <p:cNvPr id="18" name="">
-            <a:extLst xmlns:a="http://schemas.openxmlformats.org/drawingml/2006/main">
-              <a:ext uri="{FF2B5EF4-FFF2-40B4-BE49-F238E27FC236}">
-                <a16:creationId xmlns:a16="http://schemas.microsoft.com/office/drawing/2014/main" id="{FB5AF4CF-01D0-4006-B9D4-E15EBD130296}"/>
-              </a:ext>
-            </a:extLst>
-          </p:cNvPr>
-          <p:cNvSpPr>
-            <a:spLocks xmlns:a="http://schemas.openxmlformats.org/drawingml/2006/main" noGrp="1"/>
-          </p:cNvSpPr>
-          <p:nvPr/>
-        </p:nvSpPr>
-        <p:spPr>
-          <a:xfrm xmlns:a="http://schemas.openxmlformats.org/drawingml/2006/main">
-            <a:off x="1979295" y="1916430"/>
-            <a:ext cx="4937760" cy="402336"/>
-          </a:xfrm>
-          <a:prstGeom xmlns:a="http://schemas.openxmlformats.org/drawingml/2006/main" prst="rect">
+        </p:nvPicPr>
+        <p:blipFill>
+          <a:blip r:embed="rId4"/>
+          <a:stretch>
+            <a:fillRect/>
+          </a:stretch>
+        </p:blipFill>
+        <p:spPr>
+          <a:xfrm>
+            <a:off x="457200" y="1600200"/>
+            <a:ext cx="8229600" cy="3474720"/>
+          </a:xfrm>
+          <a:prstGeom prst="rect">
             <a:avLst/>
           </a:prstGeom>
-          <a:noFill xmlns:a="http://schemas.openxmlformats.org/drawingml/2006/main"/>
-          <a:ln xmlns:a="http://schemas.openxmlformats.org/drawingml/2006/main" w="0">
-            <a:noFill/>
-          </a:ln>
-        </p:spPr>
-        <p:txBody>
-          <a:bodyPr xmlns:a="http://schemas.openxmlformats.org/drawingml/2006/main" lIns="0" tIns="0" rIns="0" bIns="0">
-            <a:noAutofit/>
-          </a:bodyPr>
-          <a:lstStyle xmlns:a="http://schemas.openxmlformats.org/drawingml/2006/main"/>
-          <a:p xmlns:a="http://schemas.openxmlformats.org/drawingml/2006/main">
-            <a:pPr>
-              <a:defRPr sz="2160" b="0">
-                <a:solidFill>
-                  <a:srgbClr val="075398"/>
-                </a:solidFill>
-                <a:latin typeface="Calibri"/>
-                <a:ea typeface="Calibri"/>
-                <a:cs typeface="Calibri"/>
-              </a:defRPr>
-            </a:pPr>
-            <a:r>
-              <a:rPr sz="2160" b="0">
-                <a:solidFill>
-                  <a:srgbClr val="075398"/>
-                </a:solidFill>
-                <a:latin typeface="Calibri"/>
-                <a:ea typeface="Calibri"/>
-                <a:cs typeface="Calibri"/>
-              </a:rPr>
-              <a:t>Ingen extern matning ansluten</a:t>
-            </a:r>
-          </a:p>
-        </p:txBody>
-      </p:sp>
-      <p:sp>
-        <p:nvSpPr>
-          <p:cNvPr id="19" name="">
-            <a:extLst xmlns:a="http://schemas.openxmlformats.org/drawingml/2006/main">
-              <a:ext uri="{FF2B5EF4-FFF2-40B4-BE49-F238E27FC236}">
-                <a16:creationId xmlns:a16="http://schemas.microsoft.com/office/drawing/2014/main" id="{4281EE1F-08DB-4F9A-917A-A034AF4183BA}"/>
-              </a:ext>
-            </a:extLst>
-          </p:cNvPr>
-          <p:cNvSpPr>
-            <a:spLocks xmlns:a="http://schemas.openxmlformats.org/drawingml/2006/main" noGrp="1"/>
-          </p:cNvSpPr>
-          <p:nvPr/>
-        </p:nvSpPr>
-        <p:spPr>
-          <a:xfrm xmlns:a="http://schemas.openxmlformats.org/drawingml/2006/main">
-            <a:off x="5088255" y="4019550"/>
-            <a:ext cx="3017520" cy="731520"/>
-          </a:xfrm>
-          <a:prstGeom xmlns:a="http://schemas.openxmlformats.org/drawingml/2006/main" prst="rect">
-            <a:avLst/>
-          </a:prstGeom>
-          <a:noFill xmlns:a="http://schemas.openxmlformats.org/drawingml/2006/main"/>
-          <a:ln xmlns:a="http://schemas.openxmlformats.org/drawingml/2006/main" w="0">
-            <a:noFill/>
-          </a:ln>
-        </p:spPr>
-        <p:txBody>
-          <a:bodyPr xmlns:a="http://schemas.openxmlformats.org/drawingml/2006/main" lIns="0" tIns="0" rIns="0" bIns="0">
-            <a:noAutofit/>
-          </a:bodyPr>
-          <a:lstStyle xmlns:a="http://schemas.openxmlformats.org/drawingml/2006/main"/>
-          <a:p xmlns:a="http://schemas.openxmlformats.org/drawingml/2006/main">
-            <a:pPr>
-              <a:defRPr sz="1800" b="0">
-                <a:solidFill>
-                  <a:srgbClr val="111111"/>
-                </a:solidFill>
-                <a:latin typeface="Calibri"/>
-                <a:ea typeface="Calibri"/>
-                <a:cs typeface="Calibri"/>
-              </a:defRPr>
-            </a:pPr>
-            <a:r>
-              <a:rPr sz="1800" b="0">
-                <a:solidFill>
-                  <a:srgbClr val="111111"/>
-                </a:solidFill>
-                <a:latin typeface="Calibri"/>
-                <a:ea typeface="Calibri"/>
-                <a:cs typeface="Calibri"/>
-              </a:rPr>
-              <a:t>Mätobjektet är avgränsat.</a:t>
-            </a:r>
-          </a:p>
-        </p:txBody>
-      </p:sp>
-      <p:sp>
-        <p:nvSpPr>
-          <p:cNvPr id="20" name="">
-            <a:extLst xmlns:a="http://schemas.openxmlformats.org/drawingml/2006/main">
-              <a:ext uri="{FF2B5EF4-FFF2-40B4-BE49-F238E27FC236}">
-                <a16:creationId xmlns:a16="http://schemas.microsoft.com/office/drawing/2014/main" id="{D3DBDCED-6095-46F7-8CF4-50A02ABADBC5}"/>
-              </a:ext>
-            </a:extLst>
-          </p:cNvPr>
-          <p:cNvSpPr>
-            <a:spLocks xmlns:a="http://schemas.openxmlformats.org/drawingml/2006/main" noGrp="1"/>
-          </p:cNvSpPr>
-          <p:nvPr/>
-        </p:nvSpPr>
-        <p:spPr>
-          <a:xfrm xmlns:a="http://schemas.openxmlformats.org/drawingml/2006/main">
-            <a:off x="619125" y="5924550"/>
-            <a:ext cx="7858125" cy="190500"/>
-          </a:xfrm>
-          <a:prstGeom xmlns:a="http://schemas.openxmlformats.org/drawingml/2006/main" prst="rect">
-            <a:avLst/>
-          </a:prstGeom>
-          <a:noFill xmlns:a="http://schemas.openxmlformats.org/drawingml/2006/main"/>
-          <a:ln xmlns:a="http://schemas.openxmlformats.org/drawingml/2006/main" w="0">
-            <a:noFill/>
-          </a:ln>
-        </p:spPr>
-        <p:txBody>
-          <a:bodyPr xmlns:a="http://schemas.openxmlformats.org/drawingml/2006/main" lIns="0" tIns="0" rIns="0" bIns="0">
-            <a:noAutofit/>
-          </a:bodyPr>
-          <a:lstStyle xmlns:a="http://schemas.openxmlformats.org/drawingml/2006/main"/>
-          <a:p xmlns:a="http://schemas.openxmlformats.org/drawingml/2006/main">
-            <a:pPr>
-              <a:defRPr sz="1050" b="0">
-                <a:solidFill>
-                  <a:srgbClr val="555555"/>
-                </a:solidFill>
-                <a:latin typeface="Calibri"/>
-                <a:ea typeface="Calibri"/>
-                <a:cs typeface="Calibri"/>
-              </a:defRPr>
-            </a:pPr>
-            <a:r>
-              <a:rPr sz="1050" b="0">
-                <a:solidFill>
-                  <a:srgbClr val="555555"/>
-                </a:solidFill>
-                <a:latin typeface="Calibri"/>
-                <a:ea typeface="Calibri"/>
-                <a:cs typeface="Calibri"/>
-              </a:rPr>
-              <a:t>Principskiss för undervisning. Ingen installationsritning.</a:t>
-            </a:r>
-          </a:p>
-        </p:txBody>
-      </p:sp>
-      <p:sp>
-        <p:nvSpPr>
-          <p:cNvPr id="21" name="">
-            <a:extLst xmlns:a="http://schemas.openxmlformats.org/drawingml/2006/main">
-              <a:ext uri="{FF2B5EF4-FFF2-40B4-BE49-F238E27FC236}">
-                <a16:creationId xmlns:a16="http://schemas.microsoft.com/office/drawing/2014/main" id="{61FECE5A-B0A9-4754-A458-7AF808C684FC}"/>
-              </a:ext>
-            </a:extLst>
-          </p:cNvPr>
-          <p:cNvSpPr>
-            <a:spLocks xmlns:a="http://schemas.openxmlformats.org/drawingml/2006/main" noGrp="1"/>
-          </p:cNvSpPr>
-          <p:nvPr/>
-        </p:nvSpPr>
-        <p:spPr>
-          <a:xfrm xmlns:a="http://schemas.openxmlformats.org/drawingml/2006/main">
-            <a:off x="6715125" y="6429375"/>
-            <a:ext cx="2190750" cy="285750"/>
-          </a:xfrm>
-          <a:prstGeom xmlns:a="http://schemas.openxmlformats.org/drawingml/2006/main" prst="rect">
-            <a:avLst/>
-          </a:prstGeom>
-          <a:noFill xmlns:a="http://schemas.openxmlformats.org/drawingml/2006/main"/>
-          <a:ln xmlns:a="http://schemas.openxmlformats.org/drawingml/2006/main" w="0">
-            <a:noFill/>
-          </a:ln>
-        </p:spPr>
-        <p:txBody>
-          <a:bodyPr xmlns:a="http://schemas.openxmlformats.org/drawingml/2006/main" lIns="0" tIns="0" rIns="0" bIns="0">
-            <a:noAutofit/>
-          </a:bodyPr>
-          <a:lstStyle xmlns:a="http://schemas.openxmlformats.org/drawingml/2006/main"/>
-          <a:p xmlns:a="http://schemas.openxmlformats.org/drawingml/2006/main">
-            <a:pPr>
-              <a:defRPr sz="1350" b="0">
-                <a:solidFill>
-                  <a:srgbClr val="FFFFFF"/>
-                </a:solidFill>
-                <a:latin typeface="Calibri"/>
-                <a:ea typeface="Calibri"/>
-                <a:cs typeface="Calibri"/>
-              </a:defRPr>
-            </a:pPr>
-            <a:r>
-              <a:rPr sz="1350" b="0">
-                <a:solidFill>
-                  <a:srgbClr val="FFFFFF"/>
-                </a:solidFill>
-                <a:latin typeface="Calibri"/>
-                <a:ea typeface="Calibri"/>
-                <a:cs typeface="Calibri"/>
-              </a:rPr>
-              <a:t>Kursvecka 3 · v. 40  ·  12 / 19</a:t>
-            </a:r>
-          </a:p>
-        </p:txBody>
-      </p:sp>
+        </p:spPr>
+      </p:pic>
     </p:spTree>
     <p:extLst>
       <p:ext uri="{BB962C8B-B14F-4D97-AF65-F5344CB8AC3E}">
@@ -10406,10 +8595,10 @@
       </p:sp>
       <p:sp>
         <p:nvSpPr>
-          <p:cNvPr id="6" name="">
-            <a:extLst xmlns:a="http://schemas.openxmlformats.org/drawingml/2006/main">
-              <a:ext uri="{FF2B5EF4-FFF2-40B4-BE49-F238E27FC236}">
-                <a16:creationId xmlns:a16="http://schemas.microsoft.com/office/drawing/2014/main" id="{9E78367B-7158-4AD2-99D8-2EE3137ACEDF}"/>
+          <p:cNvPr id="21" name="">
+            <a:extLst xmlns:a="http://schemas.openxmlformats.org/drawingml/2006/main">
+              <a:ext uri="{FF2B5EF4-FFF2-40B4-BE49-F238E27FC236}">
+                <a16:creationId xmlns:a16="http://schemas.microsoft.com/office/drawing/2014/main" id="{6A1EA6F2-745F-46F9-9873-09134FDA2E28}"/>
               </a:ext>
             </a:extLst>
           </p:cNvPr>
@@ -10420,42 +8609,8 @@
         </p:nvSpPr>
         <p:spPr>
           <a:xfrm xmlns:a="http://schemas.openxmlformats.org/drawingml/2006/main">
-            <a:off x="607695" y="2190750"/>
-            <a:ext cx="2103120" cy="822960"/>
-          </a:xfrm>
-          <a:prstGeom xmlns:a="http://schemas.openxmlformats.org/drawingml/2006/main" prst="rect">
-            <a:avLst/>
-          </a:prstGeom>
-          <a:noFill xmlns:a="http://schemas.openxmlformats.org/drawingml/2006/main"/>
-          <a:ln xmlns:a="http://schemas.openxmlformats.org/drawingml/2006/main" w="23813">
-            <a:solidFill>
-              <a:srgbClr val="075398"/>
-            </a:solidFill>
-          </a:ln>
-        </p:spPr>
-        <p:txBody xmlns:a="http://schemas.openxmlformats.org/drawingml/2006/main">
-          <a:bodyPr/>
-          <a:p/>
-        </p:txBody>
-      </p:sp>
-      <p:sp>
-        <p:nvSpPr>
-          <p:cNvPr id="7" name="">
-            <a:extLst xmlns:a="http://schemas.openxmlformats.org/drawingml/2006/main">
-              <a:ext uri="{FF2B5EF4-FFF2-40B4-BE49-F238E27FC236}">
-                <a16:creationId xmlns:a16="http://schemas.microsoft.com/office/drawing/2014/main" id="{91D3CFEC-9B9A-4F95-B877-0799A1AB0DB7}"/>
-              </a:ext>
-            </a:extLst>
-          </p:cNvPr>
-          <p:cNvSpPr>
-            <a:spLocks xmlns:a="http://schemas.openxmlformats.org/drawingml/2006/main" noGrp="1"/>
-          </p:cNvSpPr>
-          <p:nvPr/>
-        </p:nvSpPr>
-        <p:spPr>
-          <a:xfrm xmlns:a="http://schemas.openxmlformats.org/drawingml/2006/main">
-            <a:off x="699135" y="2282190"/>
-            <a:ext cx="1920240" cy="731520"/>
+            <a:off x="561975" y="5116830"/>
+            <a:ext cx="7680960" cy="594360"/>
           </a:xfrm>
           <a:prstGeom xmlns:a="http://schemas.openxmlformats.org/drawingml/2006/main" prst="rect">
             <a:avLst/>
@@ -10472,7 +8627,7 @@
           <a:lstStyle xmlns:a="http://schemas.openxmlformats.org/drawingml/2006/main"/>
           <a:p xmlns:a="http://schemas.openxmlformats.org/drawingml/2006/main">
             <a:pPr>
-              <a:defRPr sz="1584" b="0">
+              <a:defRPr sz="1656" b="0">
                 <a:solidFill>
                   <a:srgbClr val="075398"/>
                 </a:solidFill>
@@ -10482,7 +8637,7 @@
               </a:defRPr>
             </a:pPr>
             <a:r>
-              <a:rPr sz="1584" b="0">
+              <a:rPr sz="1656" b="0">
                 <a:solidFill>
                   <a:srgbClr val="075398"/>
                 </a:solidFill>
@@ -10490,40 +8645,17 @@
                 <a:ea typeface="Calibri"/>
                 <a:cs typeface="Calibri"/>
               </a:rPr>
-              <a:t>Källa A</a:t>
-            </a:r>
-          </a:p>
-          <a:p xmlns:a="http://schemas.openxmlformats.org/drawingml/2006/main">
-            <a:pPr>
-              <a:defRPr sz="1584" b="0">
-                <a:solidFill>
-                  <a:srgbClr val="075398"/>
-                </a:solidFill>
-                <a:latin typeface="Calibri"/>
-                <a:ea typeface="Calibri"/>
-                <a:cs typeface="Calibri"/>
-              </a:defRPr>
-            </a:pPr>
-            <a:r>
-              <a:rPr sz="1584" b="0">
-                <a:solidFill>
-                  <a:srgbClr val="075398"/>
-                </a:solidFill>
-                <a:latin typeface="Calibri"/>
-                <a:ea typeface="Calibri"/>
-                <a:cs typeface="Calibri"/>
-              </a:rPr>
-              <a:t>Generator</a:t>
-            </a:r>
-          </a:p>
-        </p:txBody>
-      </p:sp>
-      <p:sp>
-        <p:nvSpPr>
-          <p:cNvPr id="8" name="">
-            <a:extLst xmlns:a="http://schemas.openxmlformats.org/drawingml/2006/main">
-              <a:ext uri="{FF2B5EF4-FFF2-40B4-BE49-F238E27FC236}">
-                <a16:creationId xmlns:a16="http://schemas.microsoft.com/office/drawing/2014/main" id="{98107980-8A10-40EA-8DD1-7155D7C11002}"/>
+              <a:t>Princip: källorna får inte parallellkopplas av denna omkopplare.</a:t>
+            </a:r>
+          </a:p>
+        </p:txBody>
+      </p:sp>
+      <p:sp>
+        <p:nvSpPr>
+          <p:cNvPr id="22" name="">
+            <a:extLst xmlns:a="http://schemas.openxmlformats.org/drawingml/2006/main">
+              <a:ext uri="{FF2B5EF4-FFF2-40B4-BE49-F238E27FC236}">
+                <a16:creationId xmlns:a16="http://schemas.microsoft.com/office/drawing/2014/main" id="{390AA391-D4BE-49B5-8308-ABF34ED0AD2B}"/>
               </a:ext>
             </a:extLst>
           </p:cNvPr>
@@ -10534,42 +8666,8 @@
         </p:nvSpPr>
         <p:spPr>
           <a:xfrm xmlns:a="http://schemas.openxmlformats.org/drawingml/2006/main">
-            <a:off x="607695" y="3973830"/>
-            <a:ext cx="2103120" cy="822960"/>
-          </a:xfrm>
-          <a:prstGeom xmlns:a="http://schemas.openxmlformats.org/drawingml/2006/main" prst="rect">
-            <a:avLst/>
-          </a:prstGeom>
-          <a:noFill xmlns:a="http://schemas.openxmlformats.org/drawingml/2006/main"/>
-          <a:ln xmlns:a="http://schemas.openxmlformats.org/drawingml/2006/main" w="23813">
-            <a:solidFill>
-              <a:srgbClr val="075398"/>
-            </a:solidFill>
-          </a:ln>
-        </p:spPr>
-        <p:txBody xmlns:a="http://schemas.openxmlformats.org/drawingml/2006/main">
-          <a:bodyPr/>
-          <a:p/>
-        </p:txBody>
-      </p:sp>
-      <p:sp>
-        <p:nvSpPr>
-          <p:cNvPr id="9" name="">
-            <a:extLst xmlns:a="http://schemas.openxmlformats.org/drawingml/2006/main">
-              <a:ext uri="{FF2B5EF4-FFF2-40B4-BE49-F238E27FC236}">
-                <a16:creationId xmlns:a16="http://schemas.microsoft.com/office/drawing/2014/main" id="{1AAC1AF3-5199-429C-907D-2CEE89C1701B}"/>
-              </a:ext>
-            </a:extLst>
-          </p:cNvPr>
-          <p:cNvSpPr>
-            <a:spLocks xmlns:a="http://schemas.openxmlformats.org/drawingml/2006/main" noGrp="1"/>
-          </p:cNvSpPr>
-          <p:nvPr/>
-        </p:nvSpPr>
-        <p:spPr>
-          <a:xfrm xmlns:a="http://schemas.openxmlformats.org/drawingml/2006/main">
-            <a:off x="699135" y="4065270"/>
-            <a:ext cx="1920240" cy="731520"/>
+            <a:off x="619125" y="5924550"/>
+            <a:ext cx="7858125" cy="190500"/>
           </a:xfrm>
           <a:prstGeom xmlns:a="http://schemas.openxmlformats.org/drawingml/2006/main" prst="rect">
             <a:avLst/>
@@ -10586,58 +8684,35 @@
           <a:lstStyle xmlns:a="http://schemas.openxmlformats.org/drawingml/2006/main"/>
           <a:p xmlns:a="http://schemas.openxmlformats.org/drawingml/2006/main">
             <a:pPr>
-              <a:defRPr sz="1584" b="0">
-                <a:solidFill>
-                  <a:srgbClr val="075398"/>
-                </a:solidFill>
-                <a:latin typeface="Calibri"/>
-                <a:ea typeface="Calibri"/>
-                <a:cs typeface="Calibri"/>
-              </a:defRPr>
-            </a:pPr>
-            <a:r>
-              <a:rPr sz="1584" b="0">
-                <a:solidFill>
-                  <a:srgbClr val="075398"/>
+              <a:defRPr sz="1050" b="0">
+                <a:solidFill>
+                  <a:srgbClr val="555555"/>
+                </a:solidFill>
+                <a:latin typeface="Calibri"/>
+                <a:ea typeface="Calibri"/>
+                <a:cs typeface="Calibri"/>
+              </a:defRPr>
+            </a:pPr>
+            <a:r>
+              <a:rPr sz="1050" b="0">
+                <a:solidFill>
+                  <a:srgbClr val="555555"/>
                 </a:solidFill>
                 <a:latin typeface="Calibri"/>
                 <a:ea typeface="Calibri"/>
                 <a:cs typeface="Calibri"/>
               </a:rPr>
-              <a:t>Källa B</a:t>
-            </a:r>
-          </a:p>
-          <a:p xmlns:a="http://schemas.openxmlformats.org/drawingml/2006/main">
-            <a:pPr>
-              <a:defRPr sz="1584" b="0">
-                <a:solidFill>
-                  <a:srgbClr val="075398"/>
-                </a:solidFill>
-                <a:latin typeface="Calibri"/>
-                <a:ea typeface="Calibri"/>
-                <a:cs typeface="Calibri"/>
-              </a:defRPr>
-            </a:pPr>
-            <a:r>
-              <a:rPr sz="1584" b="0">
-                <a:solidFill>
-                  <a:srgbClr val="075398"/>
-                </a:solidFill>
-                <a:latin typeface="Calibri"/>
-                <a:ea typeface="Calibri"/>
-                <a:cs typeface="Calibri"/>
-              </a:rPr>
-              <a:t>Reservmatning</a:t>
-            </a:r>
-          </a:p>
-        </p:txBody>
-      </p:sp>
-      <p:sp>
-        <p:nvSpPr>
-          <p:cNvPr id="10" name="">
-            <a:extLst xmlns:a="http://schemas.openxmlformats.org/drawingml/2006/main">
-              <a:ext uri="{FF2B5EF4-FFF2-40B4-BE49-F238E27FC236}">
-                <a16:creationId xmlns:a16="http://schemas.microsoft.com/office/drawing/2014/main" id="{D0636BEC-6D0C-411B-BF85-E4687C1137E4}"/>
+              <a:t>Principskiss för undervisning. Ingen installationsritning.</a:t>
+            </a:r>
+          </a:p>
+        </p:txBody>
+      </p:sp>
+      <p:sp>
+        <p:nvSpPr>
+          <p:cNvPr id="23" name="">
+            <a:extLst xmlns:a="http://schemas.openxmlformats.org/drawingml/2006/main">
+              <a:ext uri="{FF2B5EF4-FFF2-40B4-BE49-F238E27FC236}">
+                <a16:creationId xmlns:a16="http://schemas.microsoft.com/office/drawing/2014/main" id="{F04E5150-FF4B-4DF8-A841-A2EF8CF1F879}"/>
               </a:ext>
             </a:extLst>
           </p:cNvPr>
@@ -10648,42 +8723,8 @@
         </p:nvSpPr>
         <p:spPr>
           <a:xfrm xmlns:a="http://schemas.openxmlformats.org/drawingml/2006/main">
-            <a:off x="3716655" y="2967990"/>
-            <a:ext cx="1965960" cy="914400"/>
-          </a:xfrm>
-          <a:prstGeom xmlns:a="http://schemas.openxmlformats.org/drawingml/2006/main" prst="rect">
-            <a:avLst/>
-          </a:prstGeom>
-          <a:noFill xmlns:a="http://schemas.openxmlformats.org/drawingml/2006/main"/>
-          <a:ln xmlns:a="http://schemas.openxmlformats.org/drawingml/2006/main" w="23813">
-            <a:solidFill>
-              <a:srgbClr val="075398"/>
-            </a:solidFill>
-          </a:ln>
-        </p:spPr>
-        <p:txBody xmlns:a="http://schemas.openxmlformats.org/drawingml/2006/main">
-          <a:bodyPr/>
-          <a:p/>
-        </p:txBody>
-      </p:sp>
-      <p:sp>
-        <p:nvSpPr>
-          <p:cNvPr id="11" name="">
-            <a:extLst xmlns:a="http://schemas.openxmlformats.org/drawingml/2006/main">
-              <a:ext uri="{FF2B5EF4-FFF2-40B4-BE49-F238E27FC236}">
-                <a16:creationId xmlns:a16="http://schemas.microsoft.com/office/drawing/2014/main" id="{F9CF39F7-B5DB-45A2-AD6B-45702D8F6CB3}"/>
-              </a:ext>
-            </a:extLst>
-          </p:cNvPr>
-          <p:cNvSpPr>
-            <a:spLocks xmlns:a="http://schemas.openxmlformats.org/drawingml/2006/main" noGrp="1"/>
-          </p:cNvSpPr>
-          <p:nvPr/>
-        </p:nvSpPr>
-        <p:spPr>
-          <a:xfrm xmlns:a="http://schemas.openxmlformats.org/drawingml/2006/main">
-            <a:off x="3808095" y="3059430"/>
-            <a:ext cx="1783080" cy="822960"/>
+            <a:off x="6715125" y="6429375"/>
+            <a:ext cx="2190750" cy="285750"/>
           </a:xfrm>
           <a:prstGeom xmlns:a="http://schemas.openxmlformats.org/drawingml/2006/main" prst="rect">
             <a:avLst/>
@@ -10700,615 +8741,53 @@
           <a:lstStyle xmlns:a="http://schemas.openxmlformats.org/drawingml/2006/main"/>
           <a:p xmlns:a="http://schemas.openxmlformats.org/drawingml/2006/main">
             <a:pPr>
-              <a:defRPr sz="1584" b="0">
-                <a:solidFill>
-                  <a:srgbClr val="075398"/>
-                </a:solidFill>
-                <a:latin typeface="Calibri"/>
-                <a:ea typeface="Calibri"/>
-                <a:cs typeface="Calibri"/>
-              </a:defRPr>
-            </a:pPr>
-            <a:r>
-              <a:rPr sz="1584" b="0">
-                <a:solidFill>
-                  <a:srgbClr val="075398"/>
+              <a:defRPr sz="1350" b="0">
+                <a:solidFill>
+                  <a:srgbClr val="FFFFFF"/>
+                </a:solidFill>
+                <a:latin typeface="Calibri"/>
+                <a:ea typeface="Calibri"/>
+                <a:cs typeface="Calibri"/>
+              </a:defRPr>
+            </a:pPr>
+            <a:r>
+              <a:rPr sz="1350" b="0">
+                <a:solidFill>
+                  <a:srgbClr val="FFFFFF"/>
                 </a:solidFill>
                 <a:latin typeface="Calibri"/>
                 <a:ea typeface="Calibri"/>
                 <a:cs typeface="Calibri"/>
               </a:rPr>
-              <a:t>Val A / 0 / B</a:t>
-            </a:r>
-          </a:p>
-          <a:p xmlns:a="http://schemas.openxmlformats.org/drawingml/2006/main">
-            <a:pPr>
-              <a:defRPr sz="1584" b="0">
-                <a:solidFill>
-                  <a:srgbClr val="075398"/>
-                </a:solidFill>
-                <a:latin typeface="Calibri"/>
-                <a:ea typeface="Calibri"/>
-                <a:cs typeface="Calibri"/>
-              </a:defRPr>
-            </a:pPr>
-            <a:r>
-              <a:rPr sz="1584" b="0">
-                <a:solidFill>
-                  <a:srgbClr val="075398"/>
-                </a:solidFill>
-                <a:latin typeface="Calibri"/>
-                <a:ea typeface="Calibri"/>
-                <a:cs typeface="Calibri"/>
-              </a:rPr>
-              <a:t>Förreglad</a:t>
-            </a:r>
-          </a:p>
-        </p:txBody>
-      </p:sp>
-      <p:sp>
-        <p:nvSpPr>
-          <p:cNvPr id="12" name="">
-            <a:extLst xmlns:a="http://schemas.openxmlformats.org/drawingml/2006/main">
-              <a:ext uri="{FF2B5EF4-FFF2-40B4-BE49-F238E27FC236}">
-                <a16:creationId xmlns:a16="http://schemas.microsoft.com/office/drawing/2014/main" id="{8FF250C1-12DE-42DB-9AD4-ACE2F8DEF24E}"/>
-              </a:ext>
-            </a:extLst>
-          </p:cNvPr>
-          <p:cNvSpPr>
-            <a:spLocks xmlns:a="http://schemas.openxmlformats.org/drawingml/2006/main" noGrp="1"/>
-          </p:cNvSpPr>
+              <a:t>Kursvecka 3 · v. 40  ·  4 / 19</a:t>
+            </a:r>
+          </a:p>
+        </p:txBody>
+      </p:sp>
+      <p:pic xmlns:a="http://schemas.openxmlformats.org/drawingml/2006/main" xmlns:r="http://schemas.openxmlformats.org/officeDocument/2006/relationships">
+        <p:nvPicPr>
+          <p:cNvPr id="25" name="schema-bild04" descr="Två källor via förreglad omkopplare A / 0 / B till lasten."/>
+          <p:cNvPicPr>
+            <a:picLocks noChangeAspect="1"/>
+          </p:cNvPicPr>
           <p:nvPr/>
-        </p:nvSpPr>
-        <p:spPr>
-          <a:xfrm xmlns:a="http://schemas.openxmlformats.org/drawingml/2006/main">
-            <a:off x="6597015" y="3013710"/>
-            <a:ext cx="1508760" cy="822960"/>
-          </a:xfrm>
-          <a:prstGeom xmlns:a="http://schemas.openxmlformats.org/drawingml/2006/main" prst="rect">
+        </p:nvPicPr>
+        <p:blipFill>
+          <a:blip r:embed="rId3"/>
+          <a:stretch>
+            <a:fillRect/>
+          </a:stretch>
+        </p:blipFill>
+        <p:spPr>
+          <a:xfrm>
+            <a:off x="511342" y="1600200"/>
+            <a:ext cx="8121315" cy="3429000"/>
+          </a:xfrm>
+          <a:prstGeom prst="rect">
             <a:avLst/>
           </a:prstGeom>
-          <a:noFill xmlns:a="http://schemas.openxmlformats.org/drawingml/2006/main"/>
-          <a:ln xmlns:a="http://schemas.openxmlformats.org/drawingml/2006/main" w="23813">
-            <a:solidFill>
-              <a:srgbClr val="075398"/>
-            </a:solidFill>
-          </a:ln>
-        </p:spPr>
-        <p:txBody xmlns:a="http://schemas.openxmlformats.org/drawingml/2006/main">
-          <a:bodyPr/>
-          <a:p/>
-        </p:txBody>
-      </p:sp>
-      <p:sp>
-        <p:nvSpPr>
-          <p:cNvPr id="13" name="">
-            <a:extLst xmlns:a="http://schemas.openxmlformats.org/drawingml/2006/main">
-              <a:ext uri="{FF2B5EF4-FFF2-40B4-BE49-F238E27FC236}">
-                <a16:creationId xmlns:a16="http://schemas.microsoft.com/office/drawing/2014/main" id="{2189192C-FF96-45AC-BEF8-485D1246393E}"/>
-              </a:ext>
-            </a:extLst>
-          </p:cNvPr>
-          <p:cNvSpPr>
-            <a:spLocks xmlns:a="http://schemas.openxmlformats.org/drawingml/2006/main" noGrp="1"/>
-          </p:cNvSpPr>
-          <p:nvPr/>
-        </p:nvSpPr>
-        <p:spPr>
-          <a:xfrm xmlns:a="http://schemas.openxmlformats.org/drawingml/2006/main">
-            <a:off x="6688455" y="3105150"/>
-            <a:ext cx="1325880" cy="731520"/>
-          </a:xfrm>
-          <a:prstGeom xmlns:a="http://schemas.openxmlformats.org/drawingml/2006/main" prst="rect">
-            <a:avLst/>
-          </a:prstGeom>
-          <a:noFill xmlns:a="http://schemas.openxmlformats.org/drawingml/2006/main"/>
-          <a:ln xmlns:a="http://schemas.openxmlformats.org/drawingml/2006/main" w="0">
-            <a:noFill/>
-          </a:ln>
-        </p:spPr>
-        <p:txBody>
-          <a:bodyPr xmlns:a="http://schemas.openxmlformats.org/drawingml/2006/main" lIns="0" tIns="0" rIns="0" bIns="0">
-            <a:noAutofit/>
-          </a:bodyPr>
-          <a:lstStyle xmlns:a="http://schemas.openxmlformats.org/drawingml/2006/main"/>
-          <a:p xmlns:a="http://schemas.openxmlformats.org/drawingml/2006/main">
-            <a:pPr>
-              <a:defRPr sz="1584" b="0">
-                <a:solidFill>
-                  <a:srgbClr val="075398"/>
-                </a:solidFill>
-                <a:latin typeface="Calibri"/>
-                <a:ea typeface="Calibri"/>
-                <a:cs typeface="Calibri"/>
-              </a:defRPr>
-            </a:pPr>
-            <a:r>
-              <a:rPr sz="1584" b="0">
-                <a:solidFill>
-                  <a:srgbClr val="075398"/>
-                </a:solidFill>
-                <a:latin typeface="Calibri"/>
-                <a:ea typeface="Calibri"/>
-                <a:cs typeface="Calibri"/>
-              </a:rPr>
-              <a:t>Last</a:t>
-            </a:r>
-          </a:p>
-        </p:txBody>
-      </p:sp>
-      <p:sp>
-        <p:nvSpPr>
-          <p:cNvPr id="14" name="">
-            <a:extLst xmlns:a="http://schemas.openxmlformats.org/drawingml/2006/main">
-              <a:ext uri="{FF2B5EF4-FFF2-40B4-BE49-F238E27FC236}">
-                <a16:creationId xmlns:a16="http://schemas.microsoft.com/office/drawing/2014/main" id="{63FE82B0-090A-4EAA-9CDC-778B344F14DA}"/>
-              </a:ext>
-            </a:extLst>
-          </p:cNvPr>
-          <p:cNvSpPr>
-            <a:spLocks xmlns:a="http://schemas.openxmlformats.org/drawingml/2006/main" noGrp="1"/>
-          </p:cNvSpPr>
-          <p:nvPr/>
-        </p:nvSpPr>
-        <p:spPr>
-          <a:xfrm xmlns:a="http://schemas.openxmlformats.org/drawingml/2006/main">
-            <a:off x="2710815" y="2602230"/>
-            <a:ext cx="502920" cy="953"/>
-          </a:xfrm>
-          <a:custGeom xmlns:a="http://schemas.openxmlformats.org/drawingml/2006/main">
-            <a:pathLst>
-              <a:path w="502920" h="953">
-                <a:moveTo>
-                  <a:pt x="0" y="0"/>
-                </a:moveTo>
-                <a:lnTo>
-                  <a:pt x="502920" y="0"/>
-                </a:lnTo>
-              </a:path>
-            </a:pathLst>
-          </a:custGeom>
-          <a:noFill xmlns:a="http://schemas.openxmlformats.org/drawingml/2006/main"/>
-          <a:ln xmlns:a="http://schemas.openxmlformats.org/drawingml/2006/main" w="27432">
-            <a:solidFill>
-              <a:srgbClr val="111111"/>
-            </a:solidFill>
-          </a:ln>
-        </p:spPr>
-        <p:txBody xmlns:a="http://schemas.openxmlformats.org/drawingml/2006/main">
-          <a:bodyPr/>
-          <a:p/>
-        </p:txBody>
-      </p:sp>
-      <p:sp>
-        <p:nvSpPr>
-          <p:cNvPr id="15" name="">
-            <a:extLst xmlns:a="http://schemas.openxmlformats.org/drawingml/2006/main">
-              <a:ext uri="{FF2B5EF4-FFF2-40B4-BE49-F238E27FC236}">
-                <a16:creationId xmlns:a16="http://schemas.microsoft.com/office/drawing/2014/main" id="{C048D802-A7D6-47C8-9D93-319430B929BF}"/>
-              </a:ext>
-            </a:extLst>
-          </p:cNvPr>
-          <p:cNvSpPr>
-            <a:spLocks xmlns:a="http://schemas.openxmlformats.org/drawingml/2006/main" noGrp="1"/>
-          </p:cNvSpPr>
-          <p:nvPr/>
-        </p:nvSpPr>
-        <p:spPr>
-          <a:xfrm xmlns:a="http://schemas.openxmlformats.org/drawingml/2006/main">
-            <a:off x="3213735" y="2602230"/>
-            <a:ext cx="953" cy="640080"/>
-          </a:xfrm>
-          <a:custGeom xmlns:a="http://schemas.openxmlformats.org/drawingml/2006/main">
-            <a:pathLst>
-              <a:path w="953" h="640080">
-                <a:moveTo>
-                  <a:pt x="0" y="0"/>
-                </a:moveTo>
-                <a:lnTo>
-                  <a:pt x="0" y="640080"/>
-                </a:lnTo>
-              </a:path>
-            </a:pathLst>
-          </a:custGeom>
-          <a:noFill xmlns:a="http://schemas.openxmlformats.org/drawingml/2006/main"/>
-          <a:ln xmlns:a="http://schemas.openxmlformats.org/drawingml/2006/main" w="27432">
-            <a:solidFill>
-              <a:srgbClr val="111111"/>
-            </a:solidFill>
-          </a:ln>
-        </p:spPr>
-        <p:txBody xmlns:a="http://schemas.openxmlformats.org/drawingml/2006/main">
-          <a:bodyPr/>
-          <a:p/>
-        </p:txBody>
-      </p:sp>
-      <p:sp>
-        <p:nvSpPr>
-          <p:cNvPr id="16" name="">
-            <a:extLst xmlns:a="http://schemas.openxmlformats.org/drawingml/2006/main">
-              <a:ext uri="{FF2B5EF4-FFF2-40B4-BE49-F238E27FC236}">
-                <a16:creationId xmlns:a16="http://schemas.microsoft.com/office/drawing/2014/main" id="{35566CCE-EB48-49FE-B729-CA8095220924}"/>
-              </a:ext>
-            </a:extLst>
-          </p:cNvPr>
-          <p:cNvSpPr>
-            <a:spLocks xmlns:a="http://schemas.openxmlformats.org/drawingml/2006/main" noGrp="1"/>
-          </p:cNvSpPr>
-          <p:nvPr/>
-        </p:nvSpPr>
-        <p:spPr>
-          <a:xfrm xmlns:a="http://schemas.openxmlformats.org/drawingml/2006/main">
-            <a:off x="3213735" y="3242310"/>
-            <a:ext cx="502920" cy="953"/>
-          </a:xfrm>
-          <a:custGeom xmlns:a="http://schemas.openxmlformats.org/drawingml/2006/main">
-            <a:pathLst>
-              <a:path w="502920" h="953">
-                <a:moveTo>
-                  <a:pt x="0" y="0"/>
-                </a:moveTo>
-                <a:lnTo>
-                  <a:pt x="502920" y="0"/>
-                </a:lnTo>
-              </a:path>
-            </a:pathLst>
-          </a:custGeom>
-          <a:noFill xmlns:a="http://schemas.openxmlformats.org/drawingml/2006/main"/>
-          <a:ln xmlns:a="http://schemas.openxmlformats.org/drawingml/2006/main" w="27432">
-            <a:solidFill>
-              <a:srgbClr val="111111"/>
-            </a:solidFill>
-          </a:ln>
-        </p:spPr>
-        <p:txBody xmlns:a="http://schemas.openxmlformats.org/drawingml/2006/main">
-          <a:bodyPr/>
-          <a:p/>
-        </p:txBody>
-      </p:sp>
-      <p:sp>
-        <p:nvSpPr>
-          <p:cNvPr id="17" name="">
-            <a:extLst xmlns:a="http://schemas.openxmlformats.org/drawingml/2006/main">
-              <a:ext uri="{FF2B5EF4-FFF2-40B4-BE49-F238E27FC236}">
-                <a16:creationId xmlns:a16="http://schemas.microsoft.com/office/drawing/2014/main" id="{6B8E3ABF-91A4-4477-B010-1827283450E7}"/>
-              </a:ext>
-            </a:extLst>
-          </p:cNvPr>
-          <p:cNvSpPr>
-            <a:spLocks xmlns:a="http://schemas.openxmlformats.org/drawingml/2006/main" noGrp="1"/>
-          </p:cNvSpPr>
-          <p:nvPr/>
-        </p:nvSpPr>
-        <p:spPr>
-          <a:xfrm xmlns:a="http://schemas.openxmlformats.org/drawingml/2006/main">
-            <a:off x="2710815" y="4385310"/>
-            <a:ext cx="502920" cy="953"/>
-          </a:xfrm>
-          <a:custGeom xmlns:a="http://schemas.openxmlformats.org/drawingml/2006/main">
-            <a:pathLst>
-              <a:path w="502920" h="953">
-                <a:moveTo>
-                  <a:pt x="0" y="0"/>
-                </a:moveTo>
-                <a:lnTo>
-                  <a:pt x="502920" y="0"/>
-                </a:lnTo>
-              </a:path>
-            </a:pathLst>
-          </a:custGeom>
-          <a:noFill xmlns:a="http://schemas.openxmlformats.org/drawingml/2006/main"/>
-          <a:ln xmlns:a="http://schemas.openxmlformats.org/drawingml/2006/main" w="27432">
-            <a:solidFill>
-              <a:srgbClr val="111111"/>
-            </a:solidFill>
-          </a:ln>
-        </p:spPr>
-        <p:txBody xmlns:a="http://schemas.openxmlformats.org/drawingml/2006/main">
-          <a:bodyPr/>
-          <a:p/>
-        </p:txBody>
-      </p:sp>
-      <p:sp>
-        <p:nvSpPr>
-          <p:cNvPr id="18" name="">
-            <a:extLst xmlns:a="http://schemas.openxmlformats.org/drawingml/2006/main">
-              <a:ext uri="{FF2B5EF4-FFF2-40B4-BE49-F238E27FC236}">
-                <a16:creationId xmlns:a16="http://schemas.microsoft.com/office/drawing/2014/main" id="{03F73F23-5986-4BB4-B1F5-F418F4D4FEFC}"/>
-              </a:ext>
-            </a:extLst>
-          </p:cNvPr>
-          <p:cNvSpPr>
-            <a:spLocks xmlns:a="http://schemas.openxmlformats.org/drawingml/2006/main" noGrp="1"/>
-          </p:cNvSpPr>
-          <p:nvPr/>
-        </p:nvSpPr>
-        <p:spPr>
-          <a:xfrm xmlns:a="http://schemas.openxmlformats.org/drawingml/2006/main">
-            <a:off x="3213735" y="3608070"/>
-            <a:ext cx="953" cy="777240"/>
-          </a:xfrm>
-          <a:custGeom xmlns:a="http://schemas.openxmlformats.org/drawingml/2006/main">
-            <a:pathLst>
-              <a:path w="953" h="777240">
-                <a:moveTo>
-                  <a:pt x="0" y="777240"/>
-                </a:moveTo>
-                <a:lnTo>
-                  <a:pt x="0" y="0"/>
-                </a:lnTo>
-              </a:path>
-            </a:pathLst>
-          </a:custGeom>
-          <a:noFill xmlns:a="http://schemas.openxmlformats.org/drawingml/2006/main"/>
-          <a:ln xmlns:a="http://schemas.openxmlformats.org/drawingml/2006/main" w="27432">
-            <a:solidFill>
-              <a:srgbClr val="111111"/>
-            </a:solidFill>
-          </a:ln>
-        </p:spPr>
-        <p:txBody xmlns:a="http://schemas.openxmlformats.org/drawingml/2006/main">
-          <a:bodyPr/>
-          <a:p/>
-        </p:txBody>
-      </p:sp>
-      <p:sp>
-        <p:nvSpPr>
-          <p:cNvPr id="19" name="">
-            <a:extLst xmlns:a="http://schemas.openxmlformats.org/drawingml/2006/main">
-              <a:ext uri="{FF2B5EF4-FFF2-40B4-BE49-F238E27FC236}">
-                <a16:creationId xmlns:a16="http://schemas.microsoft.com/office/drawing/2014/main" id="{0E676375-7DF6-45E8-BE79-2B4E7D5C13F8}"/>
-              </a:ext>
-            </a:extLst>
-          </p:cNvPr>
-          <p:cNvSpPr>
-            <a:spLocks xmlns:a="http://schemas.openxmlformats.org/drawingml/2006/main" noGrp="1"/>
-          </p:cNvSpPr>
-          <p:nvPr/>
-        </p:nvSpPr>
-        <p:spPr>
-          <a:xfrm xmlns:a="http://schemas.openxmlformats.org/drawingml/2006/main">
-            <a:off x="3213735" y="3608070"/>
-            <a:ext cx="502920" cy="953"/>
-          </a:xfrm>
-          <a:custGeom xmlns:a="http://schemas.openxmlformats.org/drawingml/2006/main">
-            <a:pathLst>
-              <a:path w="502920" h="953">
-                <a:moveTo>
-                  <a:pt x="0" y="0"/>
-                </a:moveTo>
-                <a:lnTo>
-                  <a:pt x="502920" y="0"/>
-                </a:lnTo>
-              </a:path>
-            </a:pathLst>
-          </a:custGeom>
-          <a:noFill xmlns:a="http://schemas.openxmlformats.org/drawingml/2006/main"/>
-          <a:ln xmlns:a="http://schemas.openxmlformats.org/drawingml/2006/main" w="27432">
-            <a:solidFill>
-              <a:srgbClr val="111111"/>
-            </a:solidFill>
-          </a:ln>
-        </p:spPr>
-        <p:txBody xmlns:a="http://schemas.openxmlformats.org/drawingml/2006/main">
-          <a:bodyPr/>
-          <a:p/>
-        </p:txBody>
-      </p:sp>
-      <p:sp>
-        <p:nvSpPr>
-          <p:cNvPr id="20" name="">
-            <a:extLst xmlns:a="http://schemas.openxmlformats.org/drawingml/2006/main">
-              <a:ext uri="{FF2B5EF4-FFF2-40B4-BE49-F238E27FC236}">
-                <a16:creationId xmlns:a16="http://schemas.microsoft.com/office/drawing/2014/main" id="{E4A1142E-6E71-4029-A0D8-C6824503B2E8}"/>
-              </a:ext>
-            </a:extLst>
-          </p:cNvPr>
-          <p:cNvSpPr>
-            <a:spLocks xmlns:a="http://schemas.openxmlformats.org/drawingml/2006/main" noGrp="1"/>
-          </p:cNvSpPr>
-          <p:nvPr/>
-        </p:nvSpPr>
-        <p:spPr>
-          <a:xfrm xmlns:a="http://schemas.openxmlformats.org/drawingml/2006/main">
-            <a:off x="5682615" y="3425190"/>
-            <a:ext cx="914400" cy="953"/>
-          </a:xfrm>
-          <a:custGeom xmlns:a="http://schemas.openxmlformats.org/drawingml/2006/main">
-            <a:pathLst>
-              <a:path w="914400" h="953">
-                <a:moveTo>
-                  <a:pt x="0" y="0"/>
-                </a:moveTo>
-                <a:lnTo>
-                  <a:pt x="914400" y="0"/>
-                </a:lnTo>
-              </a:path>
-            </a:pathLst>
-          </a:custGeom>
-          <a:noFill xmlns:a="http://schemas.openxmlformats.org/drawingml/2006/main"/>
-          <a:ln xmlns:a="http://schemas.openxmlformats.org/drawingml/2006/main" w="27432">
-            <a:solidFill>
-              <a:srgbClr val="111111"/>
-            </a:solidFill>
-          </a:ln>
-        </p:spPr>
-        <p:txBody xmlns:a="http://schemas.openxmlformats.org/drawingml/2006/main">
-          <a:bodyPr/>
-          <a:p/>
-        </p:txBody>
-      </p:sp>
-      <p:sp>
-        <p:nvSpPr>
-          <p:cNvPr id="21" name="">
-            <a:extLst xmlns:a="http://schemas.openxmlformats.org/drawingml/2006/main">
-              <a:ext uri="{FF2B5EF4-FFF2-40B4-BE49-F238E27FC236}">
-                <a16:creationId xmlns:a16="http://schemas.microsoft.com/office/drawing/2014/main" id="{6A1EA6F2-745F-46F9-9873-09134FDA2E28}"/>
-              </a:ext>
-            </a:extLst>
-          </p:cNvPr>
-          <p:cNvSpPr>
-            <a:spLocks xmlns:a="http://schemas.openxmlformats.org/drawingml/2006/main" noGrp="1"/>
-          </p:cNvSpPr>
-          <p:nvPr/>
-        </p:nvSpPr>
-        <p:spPr>
-          <a:xfrm xmlns:a="http://schemas.openxmlformats.org/drawingml/2006/main">
-            <a:off x="561975" y="5116830"/>
-            <a:ext cx="7680960" cy="594360"/>
-          </a:xfrm>
-          <a:prstGeom xmlns:a="http://schemas.openxmlformats.org/drawingml/2006/main" prst="rect">
-            <a:avLst/>
-          </a:prstGeom>
-          <a:noFill xmlns:a="http://schemas.openxmlformats.org/drawingml/2006/main"/>
-          <a:ln xmlns:a="http://schemas.openxmlformats.org/drawingml/2006/main" w="0">
-            <a:noFill/>
-          </a:ln>
-        </p:spPr>
-        <p:txBody>
-          <a:bodyPr xmlns:a="http://schemas.openxmlformats.org/drawingml/2006/main" lIns="0" tIns="0" rIns="0" bIns="0">
-            <a:noAutofit/>
-          </a:bodyPr>
-          <a:lstStyle xmlns:a="http://schemas.openxmlformats.org/drawingml/2006/main"/>
-          <a:p xmlns:a="http://schemas.openxmlformats.org/drawingml/2006/main">
-            <a:pPr>
-              <a:defRPr sz="1656" b="0">
-                <a:solidFill>
-                  <a:srgbClr val="075398"/>
-                </a:solidFill>
-                <a:latin typeface="Calibri"/>
-                <a:ea typeface="Calibri"/>
-                <a:cs typeface="Calibri"/>
-              </a:defRPr>
-            </a:pPr>
-            <a:r>
-              <a:rPr sz="1656" b="0">
-                <a:solidFill>
-                  <a:srgbClr val="075398"/>
-                </a:solidFill>
-                <a:latin typeface="Calibri"/>
-                <a:ea typeface="Calibri"/>
-                <a:cs typeface="Calibri"/>
-              </a:rPr>
-              <a:t>Princip: källorna får inte parallellkopplas av denna omkopplare.</a:t>
-            </a:r>
-          </a:p>
-        </p:txBody>
-      </p:sp>
-      <p:sp>
-        <p:nvSpPr>
-          <p:cNvPr id="22" name="">
-            <a:extLst xmlns:a="http://schemas.openxmlformats.org/drawingml/2006/main">
-              <a:ext uri="{FF2B5EF4-FFF2-40B4-BE49-F238E27FC236}">
-                <a16:creationId xmlns:a16="http://schemas.microsoft.com/office/drawing/2014/main" id="{390AA391-D4BE-49B5-8308-ABF34ED0AD2B}"/>
-              </a:ext>
-            </a:extLst>
-          </p:cNvPr>
-          <p:cNvSpPr>
-            <a:spLocks xmlns:a="http://schemas.openxmlformats.org/drawingml/2006/main" noGrp="1"/>
-          </p:cNvSpPr>
-          <p:nvPr/>
-        </p:nvSpPr>
-        <p:spPr>
-          <a:xfrm xmlns:a="http://schemas.openxmlformats.org/drawingml/2006/main">
-            <a:off x="619125" y="5924550"/>
-            <a:ext cx="7858125" cy="190500"/>
-          </a:xfrm>
-          <a:prstGeom xmlns:a="http://schemas.openxmlformats.org/drawingml/2006/main" prst="rect">
-            <a:avLst/>
-          </a:prstGeom>
-          <a:noFill xmlns:a="http://schemas.openxmlformats.org/drawingml/2006/main"/>
-          <a:ln xmlns:a="http://schemas.openxmlformats.org/drawingml/2006/main" w="0">
-            <a:noFill/>
-          </a:ln>
-        </p:spPr>
-        <p:txBody>
-          <a:bodyPr xmlns:a="http://schemas.openxmlformats.org/drawingml/2006/main" lIns="0" tIns="0" rIns="0" bIns="0">
-            <a:noAutofit/>
-          </a:bodyPr>
-          <a:lstStyle xmlns:a="http://schemas.openxmlformats.org/drawingml/2006/main"/>
-          <a:p xmlns:a="http://schemas.openxmlformats.org/drawingml/2006/main">
-            <a:pPr>
-              <a:defRPr sz="1050" b="0">
-                <a:solidFill>
-                  <a:srgbClr val="555555"/>
-                </a:solidFill>
-                <a:latin typeface="Calibri"/>
-                <a:ea typeface="Calibri"/>
-                <a:cs typeface="Calibri"/>
-              </a:defRPr>
-            </a:pPr>
-            <a:r>
-              <a:rPr sz="1050" b="0">
-                <a:solidFill>
-                  <a:srgbClr val="555555"/>
-                </a:solidFill>
-                <a:latin typeface="Calibri"/>
-                <a:ea typeface="Calibri"/>
-                <a:cs typeface="Calibri"/>
-              </a:rPr>
-              <a:t>Principskiss för undervisning. Ingen installationsritning.</a:t>
-            </a:r>
-          </a:p>
-        </p:txBody>
-      </p:sp>
-      <p:sp>
-        <p:nvSpPr>
-          <p:cNvPr id="23" name="">
-            <a:extLst xmlns:a="http://schemas.openxmlformats.org/drawingml/2006/main">
-              <a:ext uri="{FF2B5EF4-FFF2-40B4-BE49-F238E27FC236}">
-                <a16:creationId xmlns:a16="http://schemas.microsoft.com/office/drawing/2014/main" id="{F04E5150-FF4B-4DF8-A841-A2EF8CF1F879}"/>
-              </a:ext>
-            </a:extLst>
-          </p:cNvPr>
-          <p:cNvSpPr>
-            <a:spLocks xmlns:a="http://schemas.openxmlformats.org/drawingml/2006/main" noGrp="1"/>
-          </p:cNvSpPr>
-          <p:nvPr/>
-        </p:nvSpPr>
-        <p:spPr>
-          <a:xfrm xmlns:a="http://schemas.openxmlformats.org/drawingml/2006/main">
-            <a:off x="6715125" y="6429375"/>
-            <a:ext cx="2190750" cy="285750"/>
-          </a:xfrm>
-          <a:prstGeom xmlns:a="http://schemas.openxmlformats.org/drawingml/2006/main" prst="rect">
-            <a:avLst/>
-          </a:prstGeom>
-          <a:noFill xmlns:a="http://schemas.openxmlformats.org/drawingml/2006/main"/>
-          <a:ln xmlns:a="http://schemas.openxmlformats.org/drawingml/2006/main" w="0">
-            <a:noFill/>
-          </a:ln>
-        </p:spPr>
-        <p:txBody>
-          <a:bodyPr xmlns:a="http://schemas.openxmlformats.org/drawingml/2006/main" lIns="0" tIns="0" rIns="0" bIns="0">
-            <a:noAutofit/>
-          </a:bodyPr>
-          <a:lstStyle xmlns:a="http://schemas.openxmlformats.org/drawingml/2006/main"/>
-          <a:p xmlns:a="http://schemas.openxmlformats.org/drawingml/2006/main">
-            <a:pPr>
-              <a:defRPr sz="1350" b="0">
-                <a:solidFill>
-                  <a:srgbClr val="FFFFFF"/>
-                </a:solidFill>
-                <a:latin typeface="Calibri"/>
-                <a:ea typeface="Calibri"/>
-                <a:cs typeface="Calibri"/>
-              </a:defRPr>
-            </a:pPr>
-            <a:r>
-              <a:rPr sz="1350" b="0">
-                <a:solidFill>
-                  <a:srgbClr val="FFFFFF"/>
-                </a:solidFill>
-                <a:latin typeface="Calibri"/>
-                <a:ea typeface="Calibri"/>
-                <a:cs typeface="Calibri"/>
-              </a:rPr>
-              <a:t>Kursvecka 3 · v. 40  ·  4 / 19</a:t>
-            </a:r>
-          </a:p>
-        </p:txBody>
-      </p:sp>
+        </p:spPr>
+      </p:pic>
     </p:spTree>
     <p:extLst>
       <p:ext uri="{BB962C8B-B14F-4D97-AF65-F5344CB8AC3E}">
@@ -11889,10 +9368,10 @@
       </p:sp>
       <p:sp>
         <p:nvSpPr>
-          <p:cNvPr id="6" name="">
-            <a:extLst xmlns:a="http://schemas.openxmlformats.org/drawingml/2006/main">
-              <a:ext uri="{FF2B5EF4-FFF2-40B4-BE49-F238E27FC236}">
-                <a16:creationId xmlns:a16="http://schemas.microsoft.com/office/drawing/2014/main" id="{8FA1D274-A804-426E-86F4-0972CE713229}"/>
+          <p:cNvPr id="28" name="">
+            <a:extLst xmlns:a="http://schemas.openxmlformats.org/drawingml/2006/main">
+              <a:ext uri="{FF2B5EF4-FFF2-40B4-BE49-F238E27FC236}">
+                <a16:creationId xmlns:a16="http://schemas.microsoft.com/office/drawing/2014/main" id="{74C5E80F-9F16-4AC0-9403-9FBD84F977BE}"/>
               </a:ext>
             </a:extLst>
           </p:cNvPr>
@@ -11903,128 +9382,8 @@
         </p:nvSpPr>
         <p:spPr>
           <a:xfrm xmlns:a="http://schemas.openxmlformats.org/drawingml/2006/main">
-            <a:off x="882015" y="2510790"/>
-            <a:ext cx="164592" cy="953"/>
-          </a:xfrm>
-          <a:custGeom xmlns:a="http://schemas.openxmlformats.org/drawingml/2006/main">
-            <a:pathLst>
-              <a:path w="164592" h="953">
-                <a:moveTo>
-                  <a:pt x="0" y="0"/>
-                </a:moveTo>
-                <a:lnTo>
-                  <a:pt x="164592" y="0"/>
-                </a:lnTo>
-              </a:path>
-            </a:pathLst>
-          </a:custGeom>
-          <a:noFill xmlns:a="http://schemas.openxmlformats.org/drawingml/2006/main"/>
-          <a:ln xmlns:a="http://schemas.openxmlformats.org/drawingml/2006/main" w="27432">
-            <a:solidFill>
-              <a:srgbClr val="111111"/>
-            </a:solidFill>
-          </a:ln>
-        </p:spPr>
-        <p:txBody xmlns:a="http://schemas.openxmlformats.org/drawingml/2006/main">
-          <a:bodyPr/>
-          <a:p/>
-        </p:txBody>
-      </p:sp>
-      <p:sp>
-        <p:nvSpPr>
-          <p:cNvPr id="7" name="">
-            <a:extLst xmlns:a="http://schemas.openxmlformats.org/drawingml/2006/main">
-              <a:ext uri="{FF2B5EF4-FFF2-40B4-BE49-F238E27FC236}">
-                <a16:creationId xmlns:a16="http://schemas.microsoft.com/office/drawing/2014/main" id="{35B865FB-3CEC-4AB5-B959-6C6CEC4EBC17}"/>
-              </a:ext>
-            </a:extLst>
-          </p:cNvPr>
-          <p:cNvSpPr>
-            <a:spLocks xmlns:a="http://schemas.openxmlformats.org/drawingml/2006/main" noGrp="1"/>
-          </p:cNvSpPr>
-          <p:nvPr/>
-        </p:nvSpPr>
-        <p:spPr>
-          <a:xfrm xmlns:a="http://schemas.openxmlformats.org/drawingml/2006/main">
-            <a:off x="1046607" y="2382774"/>
-            <a:ext cx="585216" cy="256032"/>
-          </a:xfrm>
-          <a:prstGeom xmlns:a="http://schemas.openxmlformats.org/drawingml/2006/main" prst="rect">
-            <a:avLst/>
-          </a:prstGeom>
-          <a:noFill xmlns:a="http://schemas.openxmlformats.org/drawingml/2006/main"/>
-          <a:ln xmlns:a="http://schemas.openxmlformats.org/drawingml/2006/main" w="23813">
-            <a:solidFill>
-              <a:srgbClr val="111111"/>
-            </a:solidFill>
-          </a:ln>
-        </p:spPr>
-        <p:txBody xmlns:a="http://schemas.openxmlformats.org/drawingml/2006/main">
-          <a:bodyPr/>
-          <a:p/>
-        </p:txBody>
-      </p:sp>
-      <p:sp>
-        <p:nvSpPr>
-          <p:cNvPr id="8" name="">
-            <a:extLst xmlns:a="http://schemas.openxmlformats.org/drawingml/2006/main">
-              <a:ext uri="{FF2B5EF4-FFF2-40B4-BE49-F238E27FC236}">
-                <a16:creationId xmlns:a16="http://schemas.microsoft.com/office/drawing/2014/main" id="{59BE928F-1BCE-4C31-9240-B23759010ABA}"/>
-              </a:ext>
-            </a:extLst>
-          </p:cNvPr>
-          <p:cNvSpPr>
-            <a:spLocks xmlns:a="http://schemas.openxmlformats.org/drawingml/2006/main" noGrp="1"/>
-          </p:cNvSpPr>
-          <p:nvPr/>
-        </p:nvSpPr>
-        <p:spPr>
-          <a:xfrm xmlns:a="http://schemas.openxmlformats.org/drawingml/2006/main">
-            <a:off x="1631823" y="2510790"/>
-            <a:ext cx="164592" cy="953"/>
-          </a:xfrm>
-          <a:custGeom xmlns:a="http://schemas.openxmlformats.org/drawingml/2006/main">
-            <a:pathLst>
-              <a:path w="164592" h="953">
-                <a:moveTo>
-                  <a:pt x="0" y="0"/>
-                </a:moveTo>
-                <a:lnTo>
-                  <a:pt x="164592" y="0"/>
-                </a:lnTo>
-              </a:path>
-            </a:pathLst>
-          </a:custGeom>
-          <a:noFill xmlns:a="http://schemas.openxmlformats.org/drawingml/2006/main"/>
-          <a:ln xmlns:a="http://schemas.openxmlformats.org/drawingml/2006/main" w="27432">
-            <a:solidFill>
-              <a:srgbClr val="111111"/>
-            </a:solidFill>
-          </a:ln>
-        </p:spPr>
-        <p:txBody xmlns:a="http://schemas.openxmlformats.org/drawingml/2006/main">
-          <a:bodyPr/>
-          <a:p/>
-        </p:txBody>
-      </p:sp>
-      <p:sp>
-        <p:nvSpPr>
-          <p:cNvPr id="9" name="">
-            <a:extLst xmlns:a="http://schemas.openxmlformats.org/drawingml/2006/main">
-              <a:ext uri="{FF2B5EF4-FFF2-40B4-BE49-F238E27FC236}">
-                <a16:creationId xmlns:a16="http://schemas.microsoft.com/office/drawing/2014/main" id="{21DF543B-1A3F-4C84-AD48-662F2ED83646}"/>
-              </a:ext>
-            </a:extLst>
-          </p:cNvPr>
-          <p:cNvSpPr>
-            <a:spLocks xmlns:a="http://schemas.openxmlformats.org/drawingml/2006/main" noGrp="1"/>
-          </p:cNvSpPr>
-          <p:nvPr/>
-        </p:nvSpPr>
-        <p:spPr>
-          <a:xfrm xmlns:a="http://schemas.openxmlformats.org/drawingml/2006/main">
-            <a:off x="790575" y="2007870"/>
-            <a:ext cx="1554480" cy="347472"/>
+            <a:off x="619125" y="5924550"/>
+            <a:ext cx="7858125" cy="190500"/>
           </a:xfrm>
           <a:prstGeom xmlns:a="http://schemas.openxmlformats.org/drawingml/2006/main" prst="rect">
             <a:avLst/>
@@ -12041,35 +9400,35 @@
           <a:lstStyle xmlns:a="http://schemas.openxmlformats.org/drawingml/2006/main"/>
           <a:p xmlns:a="http://schemas.openxmlformats.org/drawingml/2006/main">
             <a:pPr>
-              <a:defRPr sz="1584" b="0">
-                <a:solidFill>
-                  <a:srgbClr val="111111"/>
-                </a:solidFill>
-                <a:latin typeface="Calibri"/>
-                <a:ea typeface="Calibri"/>
-                <a:cs typeface="Calibri"/>
-              </a:defRPr>
-            </a:pPr>
-            <a:r>
-              <a:rPr sz="1584" b="0">
-                <a:solidFill>
-                  <a:srgbClr val="111111"/>
+              <a:defRPr sz="1050" b="0">
+                <a:solidFill>
+                  <a:srgbClr val="555555"/>
+                </a:solidFill>
+                <a:latin typeface="Calibri"/>
+                <a:ea typeface="Calibri"/>
+                <a:cs typeface="Calibri"/>
+              </a:defRPr>
+            </a:pPr>
+            <a:r>
+              <a:rPr sz="1050" b="0">
+                <a:solidFill>
+                  <a:srgbClr val="555555"/>
                 </a:solidFill>
                 <a:latin typeface="Calibri"/>
                 <a:ea typeface="Calibri"/>
                 <a:cs typeface="Calibri"/>
               </a:rPr>
-              <a:t>R: motstånd</a:t>
-            </a:r>
-          </a:p>
-        </p:txBody>
-      </p:sp>
-      <p:sp>
-        <p:nvSpPr>
-          <p:cNvPr id="10" name="">
-            <a:extLst xmlns:a="http://schemas.openxmlformats.org/drawingml/2006/main">
-              <a:ext uri="{FF2B5EF4-FFF2-40B4-BE49-F238E27FC236}">
-                <a16:creationId xmlns:a16="http://schemas.microsoft.com/office/drawing/2014/main" id="{F0DFEB67-7BDA-4E84-93CB-FF6ED8758527}"/>
+              <a:t>Principskiss för undervisning. Ingen installationsritning.</a:t>
+            </a:r>
+          </a:p>
+        </p:txBody>
+      </p:sp>
+      <p:sp>
+        <p:nvSpPr>
+          <p:cNvPr id="29" name="">
+            <a:extLst xmlns:a="http://schemas.openxmlformats.org/drawingml/2006/main">
+              <a:ext uri="{FF2B5EF4-FFF2-40B4-BE49-F238E27FC236}">
+                <a16:creationId xmlns:a16="http://schemas.microsoft.com/office/drawing/2014/main" id="{FF93A721-D1F9-4792-AAD3-1297B5E81929}"/>
               </a:ext>
             </a:extLst>
           </p:cNvPr>
@@ -12080,205 +9439,8 @@
         </p:nvSpPr>
         <p:spPr>
           <a:xfrm xmlns:a="http://schemas.openxmlformats.org/drawingml/2006/main">
-            <a:off x="3350895" y="2510790"/>
-            <a:ext cx="182880" cy="953"/>
-          </a:xfrm>
-          <a:custGeom xmlns:a="http://schemas.openxmlformats.org/drawingml/2006/main">
-            <a:pathLst>
-              <a:path w="182880" h="953">
-                <a:moveTo>
-                  <a:pt x="0" y="0"/>
-                </a:moveTo>
-                <a:lnTo>
-                  <a:pt x="182880" y="0"/>
-                </a:lnTo>
-              </a:path>
-            </a:pathLst>
-          </a:custGeom>
-          <a:noFill xmlns:a="http://schemas.openxmlformats.org/drawingml/2006/main"/>
-          <a:ln xmlns:a="http://schemas.openxmlformats.org/drawingml/2006/main" w="27432">
-            <a:solidFill>
-              <a:srgbClr val="111111"/>
-            </a:solidFill>
-          </a:ln>
-        </p:spPr>
-        <p:txBody xmlns:a="http://schemas.openxmlformats.org/drawingml/2006/main">
-          <a:bodyPr/>
-          <a:p/>
-        </p:txBody>
-      </p:sp>
-      <p:sp>
-        <p:nvSpPr>
-          <p:cNvPr id="11" name="">
-            <a:extLst xmlns:a="http://schemas.openxmlformats.org/drawingml/2006/main">
-              <a:ext uri="{FF2B5EF4-FFF2-40B4-BE49-F238E27FC236}">
-                <a16:creationId xmlns:a16="http://schemas.microsoft.com/office/drawing/2014/main" id="{FE34328D-AD02-4403-BC06-01680FAAFF4D}"/>
-              </a:ext>
-            </a:extLst>
-          </p:cNvPr>
-          <p:cNvSpPr>
-            <a:spLocks xmlns:a="http://schemas.openxmlformats.org/drawingml/2006/main" noGrp="1"/>
-          </p:cNvSpPr>
-          <p:nvPr/>
-        </p:nvSpPr>
-        <p:spPr>
-          <a:xfrm xmlns:a="http://schemas.openxmlformats.org/drawingml/2006/main">
-            <a:off x="3506343" y="2483358"/>
-            <a:ext cx="54864" cy="54864"/>
-          </a:xfrm>
-          <a:prstGeom xmlns:a="http://schemas.openxmlformats.org/drawingml/2006/main" prst="ellipse">
-            <a:avLst/>
-          </a:prstGeom>
-          <a:noFill xmlns:a="http://schemas.openxmlformats.org/drawingml/2006/main"/>
-          <a:ln xmlns:a="http://schemas.openxmlformats.org/drawingml/2006/main" w="23813">
-            <a:solidFill>
-              <a:srgbClr val="111111"/>
-            </a:solidFill>
-          </a:ln>
-        </p:spPr>
-        <p:txBody xmlns:a="http://schemas.openxmlformats.org/drawingml/2006/main">
-          <a:bodyPr/>
-          <a:p/>
-        </p:txBody>
-      </p:sp>
-      <p:sp>
-        <p:nvSpPr>
-          <p:cNvPr id="12" name="">
-            <a:extLst xmlns:a="http://schemas.openxmlformats.org/drawingml/2006/main">
-              <a:ext uri="{FF2B5EF4-FFF2-40B4-BE49-F238E27FC236}">
-                <a16:creationId xmlns:a16="http://schemas.microsoft.com/office/drawing/2014/main" id="{6002723B-59D6-4F9E-9966-9ED23D1C4218}"/>
-              </a:ext>
-            </a:extLst>
-          </p:cNvPr>
-          <p:cNvSpPr>
-            <a:spLocks xmlns:a="http://schemas.openxmlformats.org/drawingml/2006/main" noGrp="1"/>
-          </p:cNvSpPr>
-          <p:nvPr/>
-        </p:nvSpPr>
-        <p:spPr>
-          <a:xfrm xmlns:a="http://schemas.openxmlformats.org/drawingml/2006/main">
-            <a:off x="4054983" y="2483358"/>
-            <a:ext cx="54864" cy="54864"/>
-          </a:xfrm>
-          <a:prstGeom xmlns:a="http://schemas.openxmlformats.org/drawingml/2006/main" prst="ellipse">
-            <a:avLst/>
-          </a:prstGeom>
-          <a:noFill xmlns:a="http://schemas.openxmlformats.org/drawingml/2006/main"/>
-          <a:ln xmlns:a="http://schemas.openxmlformats.org/drawingml/2006/main" w="23813">
-            <a:solidFill>
-              <a:srgbClr val="111111"/>
-            </a:solidFill>
-          </a:ln>
-        </p:spPr>
-        <p:txBody xmlns:a="http://schemas.openxmlformats.org/drawingml/2006/main">
-          <a:bodyPr/>
-          <a:p/>
-        </p:txBody>
-      </p:sp>
-      <p:sp>
-        <p:nvSpPr>
-          <p:cNvPr id="13" name="">
-            <a:extLst xmlns:a="http://schemas.openxmlformats.org/drawingml/2006/main">
-              <a:ext uri="{FF2B5EF4-FFF2-40B4-BE49-F238E27FC236}">
-                <a16:creationId xmlns:a16="http://schemas.microsoft.com/office/drawing/2014/main" id="{37E95547-E848-49FD-BE34-49D21C6917DC}"/>
-              </a:ext>
-            </a:extLst>
-          </p:cNvPr>
-          <p:cNvSpPr>
-            <a:spLocks xmlns:a="http://schemas.openxmlformats.org/drawingml/2006/main" noGrp="1"/>
-          </p:cNvSpPr>
-          <p:nvPr/>
-        </p:nvSpPr>
-        <p:spPr>
-          <a:xfrm xmlns:a="http://schemas.openxmlformats.org/drawingml/2006/main">
-            <a:off x="3533775" y="2236470"/>
-            <a:ext cx="548640" cy="274320"/>
-          </a:xfrm>
-          <a:custGeom xmlns:a="http://schemas.openxmlformats.org/drawingml/2006/main">
-            <a:pathLst>
-              <a:path w="548640" h="274320">
-                <a:moveTo>
-                  <a:pt x="0" y="274320"/>
-                </a:moveTo>
-                <a:lnTo>
-                  <a:pt x="548640" y="0"/>
-                </a:lnTo>
-              </a:path>
-            </a:pathLst>
-          </a:custGeom>
-          <a:noFill xmlns:a="http://schemas.openxmlformats.org/drawingml/2006/main"/>
-          <a:ln xmlns:a="http://schemas.openxmlformats.org/drawingml/2006/main" w="27432">
-            <a:solidFill>
-              <a:srgbClr val="111111"/>
-            </a:solidFill>
-          </a:ln>
-        </p:spPr>
-        <p:txBody xmlns:a="http://schemas.openxmlformats.org/drawingml/2006/main">
-          <a:bodyPr/>
-          <a:p/>
-        </p:txBody>
-      </p:sp>
-      <p:sp>
-        <p:nvSpPr>
-          <p:cNvPr id="14" name="">
-            <a:extLst xmlns:a="http://schemas.openxmlformats.org/drawingml/2006/main">
-              <a:ext uri="{FF2B5EF4-FFF2-40B4-BE49-F238E27FC236}">
-                <a16:creationId xmlns:a16="http://schemas.microsoft.com/office/drawing/2014/main" id="{F91F123C-28C4-4A72-8550-F080CB60C138}"/>
-              </a:ext>
-            </a:extLst>
-          </p:cNvPr>
-          <p:cNvSpPr>
-            <a:spLocks xmlns:a="http://schemas.openxmlformats.org/drawingml/2006/main" noGrp="1"/>
-          </p:cNvSpPr>
-          <p:nvPr/>
-        </p:nvSpPr>
-        <p:spPr>
-          <a:xfrm xmlns:a="http://schemas.openxmlformats.org/drawingml/2006/main">
-            <a:off x="4082415" y="2510790"/>
-            <a:ext cx="182880" cy="953"/>
-          </a:xfrm>
-          <a:custGeom xmlns:a="http://schemas.openxmlformats.org/drawingml/2006/main">
-            <a:pathLst>
-              <a:path w="182880" h="953">
-                <a:moveTo>
-                  <a:pt x="0" y="0"/>
-                </a:moveTo>
-                <a:lnTo>
-                  <a:pt x="182880" y="0"/>
-                </a:lnTo>
-              </a:path>
-            </a:pathLst>
-          </a:custGeom>
-          <a:noFill xmlns:a="http://schemas.openxmlformats.org/drawingml/2006/main"/>
-          <a:ln xmlns:a="http://schemas.openxmlformats.org/drawingml/2006/main" w="27432">
-            <a:solidFill>
-              <a:srgbClr val="111111"/>
-            </a:solidFill>
-          </a:ln>
-        </p:spPr>
-        <p:txBody xmlns:a="http://schemas.openxmlformats.org/drawingml/2006/main">
-          <a:bodyPr/>
-          <a:p/>
-        </p:txBody>
-      </p:sp>
-      <p:sp>
-        <p:nvSpPr>
-          <p:cNvPr id="15" name="">
-            <a:extLst xmlns:a="http://schemas.openxmlformats.org/drawingml/2006/main">
-              <a:ext uri="{FF2B5EF4-FFF2-40B4-BE49-F238E27FC236}">
-                <a16:creationId xmlns:a16="http://schemas.microsoft.com/office/drawing/2014/main" id="{76E8E9CE-5A1B-4626-80ED-F435B76D6A39}"/>
-              </a:ext>
-            </a:extLst>
-          </p:cNvPr>
-          <p:cNvSpPr>
-            <a:spLocks xmlns:a="http://schemas.openxmlformats.org/drawingml/2006/main" noGrp="1"/>
-          </p:cNvSpPr>
-          <p:nvPr/>
-        </p:nvSpPr>
-        <p:spPr>
-          <a:xfrm xmlns:a="http://schemas.openxmlformats.org/drawingml/2006/main">
-            <a:off x="3305175" y="1907286"/>
-            <a:ext cx="1371600" cy="320040"/>
+            <a:off x="6715125" y="6429375"/>
+            <a:ext cx="2190750" cy="285750"/>
           </a:xfrm>
           <a:prstGeom xmlns:a="http://schemas.openxmlformats.org/drawingml/2006/main" prst="rect">
             <a:avLst/>
@@ -12295,721 +9457,53 @@
           <a:lstStyle xmlns:a="http://schemas.openxmlformats.org/drawingml/2006/main"/>
           <a:p xmlns:a="http://schemas.openxmlformats.org/drawingml/2006/main">
             <a:pPr>
-              <a:defRPr sz="1584" b="0">
-                <a:solidFill>
-                  <a:srgbClr val="111111"/>
-                </a:solidFill>
-                <a:latin typeface="Calibri"/>
-                <a:ea typeface="Calibri"/>
-                <a:cs typeface="Calibri"/>
-              </a:defRPr>
-            </a:pPr>
-            <a:r>
-              <a:rPr sz="1584" b="0">
-                <a:solidFill>
-                  <a:srgbClr val="111111"/>
+              <a:defRPr sz="1350" b="0">
+                <a:solidFill>
+                  <a:srgbClr val="FFFFFF"/>
+                </a:solidFill>
+                <a:latin typeface="Calibri"/>
+                <a:ea typeface="Calibri"/>
+                <a:cs typeface="Calibri"/>
+              </a:defRPr>
+            </a:pPr>
+            <a:r>
+              <a:rPr sz="1350" b="0">
+                <a:solidFill>
+                  <a:srgbClr val="FFFFFF"/>
                 </a:solidFill>
                 <a:latin typeface="Calibri"/>
                 <a:ea typeface="Calibri"/>
                 <a:cs typeface="Calibri"/>
               </a:rPr>
-              <a:t>S: NO-kontakt</a:t>
-            </a:r>
-          </a:p>
-        </p:txBody>
-      </p:sp>
-      <p:sp>
-        <p:nvSpPr>
-          <p:cNvPr id="16" name="">
-            <a:extLst xmlns:a="http://schemas.openxmlformats.org/drawingml/2006/main">
-              <a:ext uri="{FF2B5EF4-FFF2-40B4-BE49-F238E27FC236}">
-                <a16:creationId xmlns:a16="http://schemas.microsoft.com/office/drawing/2014/main" id="{BB8C3B47-5E69-41AC-83FC-BAD353B13AC4}"/>
-              </a:ext>
-            </a:extLst>
-          </p:cNvPr>
-          <p:cNvSpPr>
-            <a:spLocks xmlns:a="http://schemas.openxmlformats.org/drawingml/2006/main" noGrp="1"/>
-          </p:cNvSpPr>
+              <a:t>Kursvecka 3 · v. 40  ·  6 / 19</a:t>
+            </a:r>
+          </a:p>
+        </p:txBody>
+      </p:sp>
+      <p:pic xmlns:a="http://schemas.openxmlformats.org/drawingml/2006/main" xmlns:r="http://schemas.openxmlformats.org/officeDocument/2006/relationships">
+        <p:nvPicPr>
+          <p:cNvPr id="31" name="schema-bild06" descr="Sex symboler i två rader med förklaring under."/>
+          <p:cNvPicPr>
+            <a:picLocks noChangeAspect="1"/>
+          </p:cNvPicPr>
           <p:nvPr/>
-        </p:nvSpPr>
-        <p:spPr>
-          <a:xfrm xmlns:a="http://schemas.openxmlformats.org/drawingml/2006/main">
-            <a:off x="6523863" y="2209038"/>
-            <a:ext cx="603504" cy="603504"/>
-          </a:xfrm>
-          <a:prstGeom xmlns:a="http://schemas.openxmlformats.org/drawingml/2006/main" prst="ellipse">
+        </p:nvPicPr>
+        <p:blipFill>
+          <a:blip r:embed="rId3"/>
+          <a:stretch>
+            <a:fillRect/>
+          </a:stretch>
+        </p:blipFill>
+        <p:spPr>
+          <a:xfrm>
+            <a:off x="457200" y="1645920"/>
+            <a:ext cx="8229600" cy="3474720"/>
+          </a:xfrm>
+          <a:prstGeom prst="rect">
             <a:avLst/>
           </a:prstGeom>
-          <a:noFill xmlns:a="http://schemas.openxmlformats.org/drawingml/2006/main"/>
-          <a:ln xmlns:a="http://schemas.openxmlformats.org/drawingml/2006/main" w="23813">
-            <a:solidFill>
-              <a:srgbClr val="111111"/>
-            </a:solidFill>
-          </a:ln>
-        </p:spPr>
-        <p:txBody xmlns:a="http://schemas.openxmlformats.org/drawingml/2006/main">
-          <a:bodyPr/>
-          <a:p/>
-        </p:txBody>
-      </p:sp>
-      <p:sp>
-        <p:nvSpPr>
-          <p:cNvPr id="17" name="">
-            <a:extLst xmlns:a="http://schemas.openxmlformats.org/drawingml/2006/main">
-              <a:ext uri="{FF2B5EF4-FFF2-40B4-BE49-F238E27FC236}">
-                <a16:creationId xmlns:a16="http://schemas.microsoft.com/office/drawing/2014/main" id="{52E19519-0E62-45D0-BBFD-1EF2B5FCFFED}"/>
-              </a:ext>
-            </a:extLst>
-          </p:cNvPr>
-          <p:cNvSpPr>
-            <a:spLocks xmlns:a="http://schemas.openxmlformats.org/drawingml/2006/main" noGrp="1"/>
-          </p:cNvSpPr>
-          <p:nvPr/>
-        </p:nvSpPr>
-        <p:spPr>
-          <a:xfrm xmlns:a="http://schemas.openxmlformats.org/drawingml/2006/main">
-            <a:off x="6752463" y="2364486"/>
-            <a:ext cx="320040" cy="329184"/>
-          </a:xfrm>
-          <a:prstGeom xmlns:a="http://schemas.openxmlformats.org/drawingml/2006/main" prst="rect">
-            <a:avLst/>
-          </a:prstGeom>
-          <a:noFill xmlns:a="http://schemas.openxmlformats.org/drawingml/2006/main"/>
-          <a:ln xmlns:a="http://schemas.openxmlformats.org/drawingml/2006/main" w="0">
-            <a:noFill/>
-          </a:ln>
-        </p:spPr>
-        <p:txBody>
-          <a:bodyPr xmlns:a="http://schemas.openxmlformats.org/drawingml/2006/main" lIns="0" tIns="0" rIns="0" bIns="0">
-            <a:noAutofit/>
-          </a:bodyPr>
-          <a:lstStyle xmlns:a="http://schemas.openxmlformats.org/drawingml/2006/main"/>
-          <a:p xmlns:a="http://schemas.openxmlformats.org/drawingml/2006/main">
-            <a:pPr>
-              <a:defRPr sz="1656" b="0">
-                <a:solidFill>
-                  <a:srgbClr val="111111"/>
-                </a:solidFill>
-                <a:latin typeface="Calibri"/>
-                <a:ea typeface="Calibri"/>
-                <a:cs typeface="Calibri"/>
-              </a:defRPr>
-            </a:pPr>
-            <a:r>
-              <a:rPr sz="1656" b="0">
-                <a:solidFill>
-                  <a:srgbClr val="111111"/>
-                </a:solidFill>
-                <a:latin typeface="Calibri"/>
-                <a:ea typeface="Calibri"/>
-                <a:cs typeface="Calibri"/>
-              </a:rPr>
-              <a:t>V</a:t>
-            </a:r>
-          </a:p>
-        </p:txBody>
-      </p:sp>
-      <p:sp>
-        <p:nvSpPr>
-          <p:cNvPr id="18" name="">
-            <a:extLst xmlns:a="http://schemas.openxmlformats.org/drawingml/2006/main">
-              <a:ext uri="{FF2B5EF4-FFF2-40B4-BE49-F238E27FC236}">
-                <a16:creationId xmlns:a16="http://schemas.microsoft.com/office/drawing/2014/main" id="{CE5E3917-1453-4130-9478-8A83D97D8840}"/>
-              </a:ext>
-            </a:extLst>
-          </p:cNvPr>
-          <p:cNvSpPr>
-            <a:spLocks xmlns:a="http://schemas.openxmlformats.org/drawingml/2006/main" noGrp="1"/>
-          </p:cNvSpPr>
-          <p:nvPr/>
-        </p:nvSpPr>
-        <p:spPr>
-          <a:xfrm xmlns:a="http://schemas.openxmlformats.org/drawingml/2006/main">
-            <a:off x="5865495" y="2967990"/>
-            <a:ext cx="2331720" cy="411480"/>
-          </a:xfrm>
-          <a:prstGeom xmlns:a="http://schemas.openxmlformats.org/drawingml/2006/main" prst="rect">
-            <a:avLst/>
-          </a:prstGeom>
-          <a:noFill xmlns:a="http://schemas.openxmlformats.org/drawingml/2006/main"/>
-          <a:ln xmlns:a="http://schemas.openxmlformats.org/drawingml/2006/main" w="0">
-            <a:noFill/>
-          </a:ln>
-        </p:spPr>
-        <p:txBody>
-          <a:bodyPr xmlns:a="http://schemas.openxmlformats.org/drawingml/2006/main" lIns="0" tIns="0" rIns="0" bIns="0">
-            <a:noAutofit/>
-          </a:bodyPr>
-          <a:lstStyle xmlns:a="http://schemas.openxmlformats.org/drawingml/2006/main"/>
-          <a:p xmlns:a="http://schemas.openxmlformats.org/drawingml/2006/main">
-            <a:pPr>
-              <a:defRPr sz="1728" b="0">
-                <a:solidFill>
-                  <a:srgbClr val="111111"/>
-                </a:solidFill>
-                <a:latin typeface="Calibri"/>
-                <a:ea typeface="Calibri"/>
-                <a:cs typeface="Calibri"/>
-              </a:defRPr>
-            </a:pPr>
-            <a:r>
-              <a:rPr sz="1728" b="0">
-                <a:solidFill>
-                  <a:srgbClr val="111111"/>
-                </a:solidFill>
-                <a:latin typeface="Calibri"/>
-                <a:ea typeface="Calibri"/>
-                <a:cs typeface="Calibri"/>
-              </a:rPr>
-              <a:t>Spänningsmätare</a:t>
-            </a:r>
-          </a:p>
-        </p:txBody>
-      </p:sp>
-      <p:sp>
-        <p:nvSpPr>
-          <p:cNvPr id="19" name="">
-            <a:extLst xmlns:a="http://schemas.openxmlformats.org/drawingml/2006/main">
-              <a:ext uri="{FF2B5EF4-FFF2-40B4-BE49-F238E27FC236}">
-                <a16:creationId xmlns:a16="http://schemas.microsoft.com/office/drawing/2014/main" id="{8233BF03-4DEF-40C3-A8AC-14170E29B2E6}"/>
-              </a:ext>
-            </a:extLst>
-          </p:cNvPr>
-          <p:cNvSpPr>
-            <a:spLocks xmlns:a="http://schemas.openxmlformats.org/drawingml/2006/main" noGrp="1"/>
-          </p:cNvSpPr>
-          <p:nvPr/>
-        </p:nvSpPr>
-        <p:spPr>
-          <a:xfrm xmlns:a="http://schemas.openxmlformats.org/drawingml/2006/main">
-            <a:off x="973455" y="3973830"/>
-            <a:ext cx="640080" cy="274320"/>
-          </a:xfrm>
-          <a:prstGeom xmlns:a="http://schemas.openxmlformats.org/drawingml/2006/main" prst="rect">
-            <a:avLst/>
-          </a:prstGeom>
-          <a:noFill xmlns:a="http://schemas.openxmlformats.org/drawingml/2006/main"/>
-          <a:ln xmlns:a="http://schemas.openxmlformats.org/drawingml/2006/main" w="23813">
-            <a:solidFill>
-              <a:srgbClr val="075398"/>
-            </a:solidFill>
-          </a:ln>
-        </p:spPr>
-        <p:txBody xmlns:a="http://schemas.openxmlformats.org/drawingml/2006/main">
-          <a:bodyPr/>
-          <a:p/>
-        </p:txBody>
-      </p:sp>
-      <p:sp>
-        <p:nvSpPr>
-          <p:cNvPr id="20" name="">
-            <a:extLst xmlns:a="http://schemas.openxmlformats.org/drawingml/2006/main">
-              <a:ext uri="{FF2B5EF4-FFF2-40B4-BE49-F238E27FC236}">
-                <a16:creationId xmlns:a16="http://schemas.microsoft.com/office/drawing/2014/main" id="{62C4D1F2-69BE-46A5-8314-58AC43917DC4}"/>
-              </a:ext>
-            </a:extLst>
-          </p:cNvPr>
-          <p:cNvSpPr>
-            <a:spLocks xmlns:a="http://schemas.openxmlformats.org/drawingml/2006/main" noGrp="1"/>
-          </p:cNvSpPr>
-          <p:nvPr/>
-        </p:nvSpPr>
-        <p:spPr>
-          <a:xfrm xmlns:a="http://schemas.openxmlformats.org/drawingml/2006/main">
-            <a:off x="744855" y="4110990"/>
-            <a:ext cx="1097280" cy="953"/>
-          </a:xfrm>
-          <a:custGeom xmlns:a="http://schemas.openxmlformats.org/drawingml/2006/main">
-            <a:pathLst>
-              <a:path w="1097280" h="953">
-                <a:moveTo>
-                  <a:pt x="0" y="0"/>
-                </a:moveTo>
-                <a:lnTo>
-                  <a:pt x="1097280" y="0"/>
-                </a:lnTo>
-              </a:path>
-            </a:pathLst>
-          </a:custGeom>
-          <a:noFill xmlns:a="http://schemas.openxmlformats.org/drawingml/2006/main"/>
-          <a:ln xmlns:a="http://schemas.openxmlformats.org/drawingml/2006/main" w="27432">
-            <a:solidFill>
-              <a:srgbClr val="111111"/>
-            </a:solidFill>
-          </a:ln>
-        </p:spPr>
-        <p:txBody xmlns:a="http://schemas.openxmlformats.org/drawingml/2006/main">
-          <a:bodyPr/>
-          <a:p/>
-        </p:txBody>
-      </p:sp>
-      <p:sp>
-        <p:nvSpPr>
-          <p:cNvPr id="21" name="">
-            <a:extLst xmlns:a="http://schemas.openxmlformats.org/drawingml/2006/main">
-              <a:ext uri="{FF2B5EF4-FFF2-40B4-BE49-F238E27FC236}">
-                <a16:creationId xmlns:a16="http://schemas.microsoft.com/office/drawing/2014/main" id="{B2BD9CFA-3772-44E9-8473-1CB262C7C97C}"/>
-              </a:ext>
-            </a:extLst>
-          </p:cNvPr>
-          <p:cNvSpPr>
-            <a:spLocks xmlns:a="http://schemas.openxmlformats.org/drawingml/2006/main" noGrp="1"/>
-          </p:cNvSpPr>
-          <p:nvPr/>
-        </p:nvSpPr>
-        <p:spPr>
-          <a:xfrm xmlns:a="http://schemas.openxmlformats.org/drawingml/2006/main">
-            <a:off x="699135" y="4476750"/>
-            <a:ext cx="1737360" cy="411480"/>
-          </a:xfrm>
-          <a:prstGeom xmlns:a="http://schemas.openxmlformats.org/drawingml/2006/main" prst="rect">
-            <a:avLst/>
-          </a:prstGeom>
-          <a:noFill xmlns:a="http://schemas.openxmlformats.org/drawingml/2006/main"/>
-          <a:ln xmlns:a="http://schemas.openxmlformats.org/drawingml/2006/main" w="0">
-            <a:noFill/>
-          </a:ln>
-        </p:spPr>
-        <p:txBody>
-          <a:bodyPr xmlns:a="http://schemas.openxmlformats.org/drawingml/2006/main" lIns="0" tIns="0" rIns="0" bIns="0">
-            <a:noAutofit/>
-          </a:bodyPr>
-          <a:lstStyle xmlns:a="http://schemas.openxmlformats.org/drawingml/2006/main"/>
-          <a:p xmlns:a="http://schemas.openxmlformats.org/drawingml/2006/main">
-            <a:pPr>
-              <a:defRPr sz="1728" b="0">
-                <a:solidFill>
-                  <a:srgbClr val="111111"/>
-                </a:solidFill>
-                <a:latin typeface="Calibri"/>
-                <a:ea typeface="Calibri"/>
-                <a:cs typeface="Calibri"/>
-              </a:defRPr>
-            </a:pPr>
-            <a:r>
-              <a:rPr sz="1728" b="0">
-                <a:solidFill>
-                  <a:srgbClr val="111111"/>
-                </a:solidFill>
-                <a:latin typeface="Calibri"/>
-                <a:ea typeface="Calibri"/>
-                <a:cs typeface="Calibri"/>
-              </a:rPr>
-              <a:t>F: säkring</a:t>
-            </a:r>
-          </a:p>
-        </p:txBody>
-      </p:sp>
-      <p:sp>
-        <p:nvSpPr>
-          <p:cNvPr id="22" name="">
-            <a:extLst xmlns:a="http://schemas.openxmlformats.org/drawingml/2006/main">
-              <a:ext uri="{FF2B5EF4-FFF2-40B4-BE49-F238E27FC236}">
-                <a16:creationId xmlns:a16="http://schemas.microsoft.com/office/drawing/2014/main" id="{2C79FF2C-5E71-42B3-842E-E652857E9362}"/>
-              </a:ext>
-            </a:extLst>
-          </p:cNvPr>
-          <p:cNvSpPr>
-            <a:spLocks xmlns:a="http://schemas.openxmlformats.org/drawingml/2006/main" noGrp="1"/>
-          </p:cNvSpPr>
-          <p:nvPr/>
-        </p:nvSpPr>
-        <p:spPr>
-          <a:xfrm xmlns:a="http://schemas.openxmlformats.org/drawingml/2006/main">
-            <a:off x="3488055" y="3882390"/>
-            <a:ext cx="685800" cy="502920"/>
-          </a:xfrm>
-          <a:prstGeom xmlns:a="http://schemas.openxmlformats.org/drawingml/2006/main" prst="rect">
-            <a:avLst/>
-          </a:prstGeom>
-          <a:noFill xmlns:a="http://schemas.openxmlformats.org/drawingml/2006/main"/>
-          <a:ln xmlns:a="http://schemas.openxmlformats.org/drawingml/2006/main" w="23813">
-            <a:solidFill>
-              <a:srgbClr val="075398"/>
-            </a:solidFill>
-          </a:ln>
-        </p:spPr>
-        <p:txBody xmlns:a="http://schemas.openxmlformats.org/drawingml/2006/main">
-          <a:bodyPr/>
-          <a:p/>
-        </p:txBody>
-      </p:sp>
-      <p:sp>
-        <p:nvSpPr>
-          <p:cNvPr id="23" name="">
-            <a:extLst xmlns:a="http://schemas.openxmlformats.org/drawingml/2006/main">
-              <a:ext uri="{FF2B5EF4-FFF2-40B4-BE49-F238E27FC236}">
-                <a16:creationId xmlns:a16="http://schemas.microsoft.com/office/drawing/2014/main" id="{B8D73482-6102-4DDD-BA78-B9D63E757AC3}"/>
-              </a:ext>
-            </a:extLst>
-          </p:cNvPr>
-          <p:cNvSpPr>
-            <a:spLocks xmlns:a="http://schemas.openxmlformats.org/drawingml/2006/main" noGrp="1"/>
-          </p:cNvSpPr>
-          <p:nvPr/>
-        </p:nvSpPr>
-        <p:spPr>
-          <a:xfrm xmlns:a="http://schemas.openxmlformats.org/drawingml/2006/main">
-            <a:off x="3579495" y="3973830"/>
-            <a:ext cx="502920" cy="411480"/>
-          </a:xfrm>
-          <a:prstGeom xmlns:a="http://schemas.openxmlformats.org/drawingml/2006/main" prst="rect">
-            <a:avLst/>
-          </a:prstGeom>
-          <a:noFill xmlns:a="http://schemas.openxmlformats.org/drawingml/2006/main"/>
-          <a:ln xmlns:a="http://schemas.openxmlformats.org/drawingml/2006/main" w="0">
-            <a:noFill/>
-          </a:ln>
-        </p:spPr>
-        <p:txBody>
-          <a:bodyPr xmlns:a="http://schemas.openxmlformats.org/drawingml/2006/main" lIns="0" tIns="0" rIns="0" bIns="0">
-            <a:noAutofit/>
-          </a:bodyPr>
-          <a:lstStyle xmlns:a="http://schemas.openxmlformats.org/drawingml/2006/main"/>
-          <a:p xmlns:a="http://schemas.openxmlformats.org/drawingml/2006/main">
-            <a:pPr>
-              <a:defRPr sz="1584" b="0">
-                <a:solidFill>
-                  <a:srgbClr val="075398"/>
-                </a:solidFill>
-                <a:latin typeface="Calibri"/>
-                <a:ea typeface="Calibri"/>
-                <a:cs typeface="Calibri"/>
-              </a:defRPr>
-            </a:pPr>
-            <a:r>
-              <a:rPr sz="1584" b="0">
-                <a:solidFill>
-                  <a:srgbClr val="075398"/>
-                </a:solidFill>
-                <a:latin typeface="Calibri"/>
-                <a:ea typeface="Calibri"/>
-                <a:cs typeface="Calibri"/>
-              </a:rPr>
-              <a:t>K1</a:t>
-            </a:r>
-          </a:p>
-        </p:txBody>
-      </p:sp>
-      <p:sp>
-        <p:nvSpPr>
-          <p:cNvPr id="24" name="">
-            <a:extLst xmlns:a="http://schemas.openxmlformats.org/drawingml/2006/main">
-              <a:ext uri="{FF2B5EF4-FFF2-40B4-BE49-F238E27FC236}">
-                <a16:creationId xmlns:a16="http://schemas.microsoft.com/office/drawing/2014/main" id="{5B236D04-8B95-4763-98B8-7585A6391AF4}"/>
-              </a:ext>
-            </a:extLst>
-          </p:cNvPr>
-          <p:cNvSpPr>
-            <a:spLocks xmlns:a="http://schemas.openxmlformats.org/drawingml/2006/main" noGrp="1"/>
-          </p:cNvSpPr>
-          <p:nvPr/>
-        </p:nvSpPr>
-        <p:spPr>
-          <a:xfrm xmlns:a="http://schemas.openxmlformats.org/drawingml/2006/main">
-            <a:off x="3168015" y="4476750"/>
-            <a:ext cx="1920240" cy="411480"/>
-          </a:xfrm>
-          <a:prstGeom xmlns:a="http://schemas.openxmlformats.org/drawingml/2006/main" prst="rect">
-            <a:avLst/>
-          </a:prstGeom>
-          <a:noFill xmlns:a="http://schemas.openxmlformats.org/drawingml/2006/main"/>
-          <a:ln xmlns:a="http://schemas.openxmlformats.org/drawingml/2006/main" w="0">
-            <a:noFill/>
-          </a:ln>
-        </p:spPr>
-        <p:txBody>
-          <a:bodyPr xmlns:a="http://schemas.openxmlformats.org/drawingml/2006/main" lIns="0" tIns="0" rIns="0" bIns="0">
-            <a:noAutofit/>
-          </a:bodyPr>
-          <a:lstStyle xmlns:a="http://schemas.openxmlformats.org/drawingml/2006/main"/>
-          <a:p xmlns:a="http://schemas.openxmlformats.org/drawingml/2006/main">
-            <a:pPr>
-              <a:defRPr sz="1728" b="0">
-                <a:solidFill>
-                  <a:srgbClr val="111111"/>
-                </a:solidFill>
-                <a:latin typeface="Calibri"/>
-                <a:ea typeface="Calibri"/>
-                <a:cs typeface="Calibri"/>
-              </a:defRPr>
-            </a:pPr>
-            <a:r>
-              <a:rPr sz="1728" b="0">
-                <a:solidFill>
-                  <a:srgbClr val="111111"/>
-                </a:solidFill>
-                <a:latin typeface="Calibri"/>
-                <a:ea typeface="Calibri"/>
-                <a:cs typeface="Calibri"/>
-              </a:rPr>
-              <a:t>K: reläspole</a:t>
-            </a:r>
-          </a:p>
-        </p:txBody>
-      </p:sp>
-      <p:sp>
-        <p:nvSpPr>
-          <p:cNvPr id="25" name="">
-            <a:extLst xmlns:a="http://schemas.openxmlformats.org/drawingml/2006/main">
-              <a:ext uri="{FF2B5EF4-FFF2-40B4-BE49-F238E27FC236}">
-                <a16:creationId xmlns:a16="http://schemas.microsoft.com/office/drawing/2014/main" id="{B67FD183-7F3E-4B6F-873A-419C1944DF3A}"/>
-              </a:ext>
-            </a:extLst>
-          </p:cNvPr>
-          <p:cNvSpPr>
-            <a:spLocks xmlns:a="http://schemas.openxmlformats.org/drawingml/2006/main" noGrp="1"/>
-          </p:cNvSpPr>
-          <p:nvPr/>
-        </p:nvSpPr>
-        <p:spPr>
-          <a:xfrm xmlns:a="http://schemas.openxmlformats.org/drawingml/2006/main">
-            <a:off x="6523863" y="3763518"/>
-            <a:ext cx="603504" cy="603504"/>
-          </a:xfrm>
-          <a:prstGeom xmlns:a="http://schemas.openxmlformats.org/drawingml/2006/main" prst="ellipse">
-            <a:avLst/>
-          </a:prstGeom>
-          <a:noFill xmlns:a="http://schemas.openxmlformats.org/drawingml/2006/main"/>
-          <a:ln xmlns:a="http://schemas.openxmlformats.org/drawingml/2006/main" w="23813">
-            <a:solidFill>
-              <a:srgbClr val="111111"/>
-            </a:solidFill>
-          </a:ln>
-        </p:spPr>
-        <p:txBody xmlns:a="http://schemas.openxmlformats.org/drawingml/2006/main">
-          <a:bodyPr/>
-          <a:p/>
-        </p:txBody>
-      </p:sp>
-      <p:sp>
-        <p:nvSpPr>
-          <p:cNvPr id="26" name="">
-            <a:extLst xmlns:a="http://schemas.openxmlformats.org/drawingml/2006/main">
-              <a:ext uri="{FF2B5EF4-FFF2-40B4-BE49-F238E27FC236}">
-                <a16:creationId xmlns:a16="http://schemas.microsoft.com/office/drawing/2014/main" id="{B3E48FC8-8F99-459C-A998-E79C73873165}"/>
-              </a:ext>
-            </a:extLst>
-          </p:cNvPr>
-          <p:cNvSpPr>
-            <a:spLocks xmlns:a="http://schemas.openxmlformats.org/drawingml/2006/main" noGrp="1"/>
-          </p:cNvSpPr>
-          <p:nvPr/>
-        </p:nvSpPr>
-        <p:spPr>
-          <a:xfrm xmlns:a="http://schemas.openxmlformats.org/drawingml/2006/main">
-            <a:off x="6752463" y="3918966"/>
-            <a:ext cx="320040" cy="329184"/>
-          </a:xfrm>
-          <a:prstGeom xmlns:a="http://schemas.openxmlformats.org/drawingml/2006/main" prst="rect">
-            <a:avLst/>
-          </a:prstGeom>
-          <a:noFill xmlns:a="http://schemas.openxmlformats.org/drawingml/2006/main"/>
-          <a:ln xmlns:a="http://schemas.openxmlformats.org/drawingml/2006/main" w="0">
-            <a:noFill/>
-          </a:ln>
-        </p:spPr>
-        <p:txBody>
-          <a:bodyPr xmlns:a="http://schemas.openxmlformats.org/drawingml/2006/main" lIns="0" tIns="0" rIns="0" bIns="0">
-            <a:noAutofit/>
-          </a:bodyPr>
-          <a:lstStyle xmlns:a="http://schemas.openxmlformats.org/drawingml/2006/main"/>
-          <a:p xmlns:a="http://schemas.openxmlformats.org/drawingml/2006/main">
-            <a:pPr>
-              <a:defRPr sz="1656" b="0">
-                <a:solidFill>
-                  <a:srgbClr val="111111"/>
-                </a:solidFill>
-                <a:latin typeface="Calibri"/>
-                <a:ea typeface="Calibri"/>
-                <a:cs typeface="Calibri"/>
-              </a:defRPr>
-            </a:pPr>
-            <a:r>
-              <a:rPr sz="1656" b="0">
-                <a:solidFill>
-                  <a:srgbClr val="111111"/>
-                </a:solidFill>
-                <a:latin typeface="Calibri"/>
-                <a:ea typeface="Calibri"/>
-                <a:cs typeface="Calibri"/>
-              </a:rPr>
-              <a:t>A</a:t>
-            </a:r>
-          </a:p>
-        </p:txBody>
-      </p:sp>
-      <p:sp>
-        <p:nvSpPr>
-          <p:cNvPr id="27" name="">
-            <a:extLst xmlns:a="http://schemas.openxmlformats.org/drawingml/2006/main">
-              <a:ext uri="{FF2B5EF4-FFF2-40B4-BE49-F238E27FC236}">
-                <a16:creationId xmlns:a16="http://schemas.microsoft.com/office/drawing/2014/main" id="{9B9BA30C-7BAE-43EB-A06A-0CA19BC08FCA}"/>
-              </a:ext>
-            </a:extLst>
-          </p:cNvPr>
-          <p:cNvSpPr>
-            <a:spLocks xmlns:a="http://schemas.openxmlformats.org/drawingml/2006/main" noGrp="1"/>
-          </p:cNvSpPr>
-          <p:nvPr/>
-        </p:nvSpPr>
-        <p:spPr>
-          <a:xfrm xmlns:a="http://schemas.openxmlformats.org/drawingml/2006/main">
-            <a:off x="6002655" y="4476750"/>
-            <a:ext cx="2011680" cy="411480"/>
-          </a:xfrm>
-          <a:prstGeom xmlns:a="http://schemas.openxmlformats.org/drawingml/2006/main" prst="rect">
-            <a:avLst/>
-          </a:prstGeom>
-          <a:noFill xmlns:a="http://schemas.openxmlformats.org/drawingml/2006/main"/>
-          <a:ln xmlns:a="http://schemas.openxmlformats.org/drawingml/2006/main" w="0">
-            <a:noFill/>
-          </a:ln>
-        </p:spPr>
-        <p:txBody>
-          <a:bodyPr xmlns:a="http://schemas.openxmlformats.org/drawingml/2006/main" lIns="0" tIns="0" rIns="0" bIns="0">
-            <a:noAutofit/>
-          </a:bodyPr>
-          <a:lstStyle xmlns:a="http://schemas.openxmlformats.org/drawingml/2006/main"/>
-          <a:p xmlns:a="http://schemas.openxmlformats.org/drawingml/2006/main">
-            <a:pPr>
-              <a:defRPr sz="1728" b="0">
-                <a:solidFill>
-                  <a:srgbClr val="111111"/>
-                </a:solidFill>
-                <a:latin typeface="Calibri"/>
-                <a:ea typeface="Calibri"/>
-                <a:cs typeface="Calibri"/>
-              </a:defRPr>
-            </a:pPr>
-            <a:r>
-              <a:rPr sz="1728" b="0">
-                <a:solidFill>
-                  <a:srgbClr val="111111"/>
-                </a:solidFill>
-                <a:latin typeface="Calibri"/>
-                <a:ea typeface="Calibri"/>
-                <a:cs typeface="Calibri"/>
-              </a:rPr>
-              <a:t>Strömmätare</a:t>
-            </a:r>
-          </a:p>
-        </p:txBody>
-      </p:sp>
-      <p:sp>
-        <p:nvSpPr>
-          <p:cNvPr id="28" name="">
-            <a:extLst xmlns:a="http://schemas.openxmlformats.org/drawingml/2006/main">
-              <a:ext uri="{FF2B5EF4-FFF2-40B4-BE49-F238E27FC236}">
-                <a16:creationId xmlns:a16="http://schemas.microsoft.com/office/drawing/2014/main" id="{74C5E80F-9F16-4AC0-9403-9FBD84F977BE}"/>
-              </a:ext>
-            </a:extLst>
-          </p:cNvPr>
-          <p:cNvSpPr>
-            <a:spLocks xmlns:a="http://schemas.openxmlformats.org/drawingml/2006/main" noGrp="1"/>
-          </p:cNvSpPr>
-          <p:nvPr/>
-        </p:nvSpPr>
-        <p:spPr>
-          <a:xfrm xmlns:a="http://schemas.openxmlformats.org/drawingml/2006/main">
-            <a:off x="619125" y="5924550"/>
-            <a:ext cx="7858125" cy="190500"/>
-          </a:xfrm>
-          <a:prstGeom xmlns:a="http://schemas.openxmlformats.org/drawingml/2006/main" prst="rect">
-            <a:avLst/>
-          </a:prstGeom>
-          <a:noFill xmlns:a="http://schemas.openxmlformats.org/drawingml/2006/main"/>
-          <a:ln xmlns:a="http://schemas.openxmlformats.org/drawingml/2006/main" w="0">
-            <a:noFill/>
-          </a:ln>
-        </p:spPr>
-        <p:txBody>
-          <a:bodyPr xmlns:a="http://schemas.openxmlformats.org/drawingml/2006/main" lIns="0" tIns="0" rIns="0" bIns="0">
-            <a:noAutofit/>
-          </a:bodyPr>
-          <a:lstStyle xmlns:a="http://schemas.openxmlformats.org/drawingml/2006/main"/>
-          <a:p xmlns:a="http://schemas.openxmlformats.org/drawingml/2006/main">
-            <a:pPr>
-              <a:defRPr sz="1050" b="0">
-                <a:solidFill>
-                  <a:srgbClr val="555555"/>
-                </a:solidFill>
-                <a:latin typeface="Calibri"/>
-                <a:ea typeface="Calibri"/>
-                <a:cs typeface="Calibri"/>
-              </a:defRPr>
-            </a:pPr>
-            <a:r>
-              <a:rPr sz="1050" b="0">
-                <a:solidFill>
-                  <a:srgbClr val="555555"/>
-                </a:solidFill>
-                <a:latin typeface="Calibri"/>
-                <a:ea typeface="Calibri"/>
-                <a:cs typeface="Calibri"/>
-              </a:rPr>
-              <a:t>Principskiss för undervisning. Ingen installationsritning.</a:t>
-            </a:r>
-          </a:p>
-        </p:txBody>
-      </p:sp>
-      <p:sp>
-        <p:nvSpPr>
-          <p:cNvPr id="29" name="">
-            <a:extLst xmlns:a="http://schemas.openxmlformats.org/drawingml/2006/main">
-              <a:ext uri="{FF2B5EF4-FFF2-40B4-BE49-F238E27FC236}">
-                <a16:creationId xmlns:a16="http://schemas.microsoft.com/office/drawing/2014/main" id="{FF93A721-D1F9-4792-AAD3-1297B5E81929}"/>
-              </a:ext>
-            </a:extLst>
-          </p:cNvPr>
-          <p:cNvSpPr>
-            <a:spLocks xmlns:a="http://schemas.openxmlformats.org/drawingml/2006/main" noGrp="1"/>
-          </p:cNvSpPr>
-          <p:nvPr/>
-        </p:nvSpPr>
-        <p:spPr>
-          <a:xfrm xmlns:a="http://schemas.openxmlformats.org/drawingml/2006/main">
-            <a:off x="6715125" y="6429375"/>
-            <a:ext cx="2190750" cy="285750"/>
-          </a:xfrm>
-          <a:prstGeom xmlns:a="http://schemas.openxmlformats.org/drawingml/2006/main" prst="rect">
-            <a:avLst/>
-          </a:prstGeom>
-          <a:noFill xmlns:a="http://schemas.openxmlformats.org/drawingml/2006/main"/>
-          <a:ln xmlns:a="http://schemas.openxmlformats.org/drawingml/2006/main" w="0">
-            <a:noFill/>
-          </a:ln>
-        </p:spPr>
-        <p:txBody>
-          <a:bodyPr xmlns:a="http://schemas.openxmlformats.org/drawingml/2006/main" lIns="0" tIns="0" rIns="0" bIns="0">
-            <a:noAutofit/>
-          </a:bodyPr>
-          <a:lstStyle xmlns:a="http://schemas.openxmlformats.org/drawingml/2006/main"/>
-          <a:p xmlns:a="http://schemas.openxmlformats.org/drawingml/2006/main">
-            <a:pPr>
-              <a:defRPr sz="1350" b="0">
-                <a:solidFill>
-                  <a:srgbClr val="FFFFFF"/>
-                </a:solidFill>
-                <a:latin typeface="Calibri"/>
-                <a:ea typeface="Calibri"/>
-                <a:cs typeface="Calibri"/>
-              </a:defRPr>
-            </a:pPr>
-            <a:r>
-              <a:rPr sz="1350" b="0">
-                <a:solidFill>
-                  <a:srgbClr val="FFFFFF"/>
-                </a:solidFill>
-                <a:latin typeface="Calibri"/>
-                <a:ea typeface="Calibri"/>
-                <a:cs typeface="Calibri"/>
-              </a:rPr>
-              <a:t>Kursvecka 3 · v. 40  ·  6 / 19</a:t>
-            </a:r>
-          </a:p>
-        </p:txBody>
-      </p:sp>
+        </p:spPr>
+      </p:pic>
     </p:spTree>
     <p:extLst>
       <p:ext uri="{BB962C8B-B14F-4D97-AF65-F5344CB8AC3E}">

</xml_diff>

<commit_message>
Sjöskolan v38_01: omslaget visar en låst effektbrytare i stället för båten
Ritad i JavaScript (verktyg/ac/brytare.mjs): effektbrytare i FRÅN-läge med hänglås och skylten FRÅNSKILD – MANÖVRERA EJ. Samma omslag i måndagens samlade presentation. Bildspelsbyggaren hoppar över filer som inte är kapitelpresentationer.

Co-Authored-By: Claude Opus 5.5 <noreply@anthropic.com>
Claude-Session: https://claude.ai/code/session_011V9KjBb53XrDm23Dw58SH3
</commit_message>
<xml_diff>
--- a/sjoskolan/vecka-38/aktuell/v38_01_Franskiljning_och_matteknik_elev.pptx
+++ b/sjoskolan/vecka-38/aktuell/v38_01_Franskiljning_och_matteknik_elev.pptx
@@ -3419,26 +3419,26 @@
           </a:prstGeom>
         </p:spPr>
       </p:pic>
-      <p:pic>
+      <p:pic xmlns:a="http://schemas.openxmlformats.org/drawingml/2006/main" xmlns:r="http://schemas.openxmlformats.org/officeDocument/2006/relationships">
         <p:nvPicPr>
-          <p:cNvPr id="9" name="Bildobjekt 1"/>
+          <p:cNvPr id="10" name="omslag-brytare" descr="Effektbrytare i FRÅN-läge, låst med rött hänglås och gul skylt: FRÅNSKILD, MANÖVRERA EJ."/>
           <p:cNvPicPr>
-            <a:picLocks xmlns:a="http://schemas.openxmlformats.org/drawingml/2006/main" noChangeAspect="1"/>
+            <a:picLocks noChangeAspect="1"/>
           </p:cNvPicPr>
           <p:nvPr/>
         </p:nvPicPr>
         <p:blipFill>
-          <a:blip xmlns:r="http://schemas.openxmlformats.org/officeDocument/2006/relationships" xmlns:a="http://schemas.openxmlformats.org/drawingml/2006/main" r:embed="R9374dec19c304fa2"/>
-          <a:stretch xmlns:a="http://schemas.openxmlformats.org/drawingml/2006/main">
-            <a:fillRect l="0" t="0" r="0" b="0"/>
+          <a:blip r:embed="rId4"/>
+          <a:stretch>
+            <a:fillRect/>
           </a:stretch>
         </p:blipFill>
         <p:spPr>
-          <a:xfrm xmlns:a="http://schemas.openxmlformats.org/drawingml/2006/main">
+          <a:xfrm>
             <a:off x="0" y="-185460"/>
             <a:ext cx="9138501" cy="6068674"/>
           </a:xfrm>
-          <a:prstGeom xmlns:a="http://schemas.openxmlformats.org/drawingml/2006/main" prst="rect">
+          <a:prstGeom prst="rect">
             <a:avLst/>
           </a:prstGeom>
         </p:spPr>

</xml_diff>